<commit_message>
slides(pptx): rebuild weeks 2, 3, 9 from current sources; fix alt text with "]"
The committed decks predated later edits to slides/week02.md, week03.md
and week09.md.

- week02: adds the "How fuzzing finds it" slide (19 -> 20 pages)
- week03: adds the ECB picture and "four fixes in the code" slides and the
  CWE-321 (a case of CWE-798, filed under A07) wording (17 -> 20 pages)
- week09: proctor notes describe hosted-instance flags and
  ctf_integrity_report.py instead of seed_flags.py

build_all.js: the markdown-image matcher stopped at the first "]" in the
alt text, so an image whose alt contains "data[3]" leaked raw markdown
onto the slide. Match greedily up to the last "](" and reject a line with
a second "](" in the alt. Of the 26 image lines across all 19 sources
only week02.md:106 changes.

Rendered all three decks (soffice -> pdf) and checked every page: no
clipping. Other decks are not rebuilt.

Co-Authored-By: Claude Sonnet 5 <noreply@anthropic.com>
</commit_message>
<xml_diff>
--- a/slides/pptx/week02.pptx
+++ b/slides/pptx/week02.pptx
@@ -24,9 +24,10 @@
     <p:sldId id="272" r:id="rId18"/>
     <p:sldId id="273" r:id="rId19"/>
     <p:sldId id="274" r:id="rId20"/>
+    <p:sldId id="275" r:id="rId21"/>
   </p:sldIdLst>
   <p:notesMasterIdLst>
-    <p:notesMasterId r:id="rId21"/>
+    <p:notesMasterId r:id="rId22"/>
   </p:notesMasterIdLst>
   <p:sldSz cx="9144000" cy="5143500"/>
   <p:notesSz cx="5143500" cy="9144000"/>
@@ -608,7 +609,7 @@
           <a:p>
             <a:r>
               <a:rPr lang="en-US" dirty="0"/>
-              <a:t>This is harness.c's exact logic, computed in the browser — not an animation of "how fuzzing feels." Make sure "FUZ" (3 bytes, overflow) and "FUZZ" (4 bytes, deliberate trap via __builtin_trap — a different crash class, no memory-safety bug at all) both get tried, since that distinction is easy to blur. Ties to worksheet Task 4. ~4 min.</a:t>
+              <a:t>The static companion to the fuzz-verdict sim, and the answer to 'why fuzz if we already ran SAST?' Walk it: SAST can't know the input will ever be exactly FUZ, so it stays silent (blue); the fuzzer doesn't brute-force randomly — coverage feedback rewards each new gate passed, so it climbs to FUZ and the unguarded data[3] read faults under ASan (orange). Land on: static reads, fuzzing runs — complements. ~4 min.</a:t>
             </a:r>
             <a:endParaRPr lang="en-US" dirty="0"/>
           </a:p>
@@ -696,7 +697,7 @@
           <a:p>
             <a:r>
               <a:rPr lang="en-US" dirty="0"/>
-              <a:t>Crucial professional skill: a scanner that cries wolf gets ignored. IMPORTANT — a real `bash scan.sh` run against this week's own vulnerable-repo returns 12 findings and all 12 are genuine true positives; there is no clean false-positive example in this specimen, so don't invent one live. The real triage skill THIS repo exercises is deduplication: 5 Semgrep rules fire on the identical SQLi line, 3 fire on the identical command-injection line — teach "same root cause, one row in your table" rather than promising a false positive you won't be able to produce on demand. Every finding still gets a CWE + a TP call + a one-line justification. ~4 min.</a:t>
+              <a:t>This is harness.c's exact logic, computed in the browser — not an animation of "how fuzzing feels." Make sure "FUZ" (3 bytes, overflow) and "FUZZ" (4 bytes, deliberate trap via __builtin_trap — a different crash class, no memory-safety bug at all) both get tried, since that distinction is easy to blur. Ties to worksheet Task 4. ~4 min.</a:t>
             </a:r>
             <a:endParaRPr lang="en-US" dirty="0"/>
           </a:p>
@@ -784,7 +785,7 @@
           <a:p>
             <a:r>
               <a:rPr lang="en-US" dirty="0"/>
-              <a:t>Every rule ID and line number here is copied from an actual scan.sh run, not invented. The point: "5 rules fired" is not "5 bugs" — recognizing the SAME root cause under two different rule names is the real-world triage skill, more useful than a TP/FP guess. Directly rehearses worksheet Task 3's triage table. ~4 min.</a:t>
+              <a:t>Crucial professional skill: a scanner that cries wolf gets ignored. IMPORTANT — a real `bash scan.sh` run against this week's own vulnerable-repo returns 12 findings and all 12 are genuine true positives; there is no clean false-positive example in this specimen, so don't invent one live. The real triage skill THIS repo exercises is deduplication: 5 Semgrep rules fire on the identical SQLi line, 3 fire on the identical command-injection line — teach "same root cause, one row in your table" rather than promising a false positive you won't be able to produce on demand. Every finding still gets a CWE + a TP call + a one-line justification. ~4 min.</a:t>
             </a:r>
             <a:endParaRPr lang="en-US" dirty="0"/>
           </a:p>
@@ -872,7 +873,7 @@
           <a:p>
             <a:r>
               <a:rPr lang="en-US" dirty="0"/>
-              <a:t>Trivy is the one they'll type today (Task 5, scanning the NoteVault target) — say so explicitly so "tools you'll meet" doesn't read as "tools this lab uses." SonarQube/GHAS are real-world awareness. Connect "technical debt" to the cost curve from the recap. ~3 min.</a:t>
+              <a:t>Every rule ID and line number here is copied from an actual scan.sh run, not invented. The point: "5 rules fired" is not "5 bugs" — recognizing the SAME root cause under two different rule names is the real-world triage skill, more useful than a TP/FP guess. Directly rehearses worksheet Task 3's triage table. ~4 min.</a:t>
             </a:r>
             <a:endParaRPr lang="en-US" dirty="0"/>
           </a:p>
@@ -960,7 +961,7 @@
           <a:p>
             <a:r>
               <a:rPr lang="en-US" dirty="0"/>
-              <a:t>Explain the game before lab: speed + accuracy. Penalize wild guessing (misclassified subtracts) so they must justify each finding. Mirrors a real bug-bounty triage queue. Warn about the two gotchas up front: Gitleaks needs `--no-git` or it silently reports zero leaks; the repo root's own `.gitleaks.toml` deliberately allowlists this lab's secrets, so scan `vulnerable-repo/` specifically, not the repo root. ~3 min.</a:t>
+              <a:t>Trivy is the one they'll type today (Task 5, scanning the NoteVault target) — say so explicitly so "tools you'll meet" doesn't read as "tools this lab uses." SonarQube/GHAS are real-world awareness. Connect "technical debt" to the cost curve from the recap. ~3 min.</a:t>
             </a:r>
             <a:endParaRPr lang="en-US" dirty="0"/>
           </a:p>
@@ -1048,7 +1049,7 @@
           <a:p>
             <a:r>
               <a:rPr lang="en-US" dirty="0"/>
-              <a:t>Quick, fun, instant feedback (it crashes or it doesn't). Sets up W11. If short on time, make this a demo. ~2 min.</a:t>
+              <a:t>Explain the game before lab: speed + accuracy. Penalize wild guessing (misclassified subtracts) so they must justify each finding. Mirrors a real bug-bounty triage queue. Warn about the two gotchas up front: Gitleaks needs `--no-git` or it silently reports zero leaks; the repo root's own `.gitleaks.toml` deliberately allowlists this lab's secrets, so scan `vulnerable-repo/` specifically, not the repo root. ~3 min.</a:t>
             </a:r>
             <a:endParaRPr lang="en-US" dirty="0"/>
           </a:p>
@@ -1136,7 +1137,7 @@
           <a:p>
             <a:r>
               <a:rPr lang="en-US" dirty="0"/>
-              <a:t>The graded output — six tasks, not three. The defend/fix task (25 pts, "Defense") is the single biggest score component and is easy to undersell if you only recap the triage table. Point to scan.sh.</a:t>
+              <a:t>Quick, fun, instant feedback (it crashes or it doesn't). Sets up W11. If short on time, make this a demo. ~2 min.</a:t>
             </a:r>
             <a:endParaRPr lang="en-US" dirty="0"/>
           </a:p>
@@ -1312,7 +1313,7 @@
           <a:p>
             <a:r>
               <a:rPr lang="en-US" dirty="0"/>
-              <a:t>Recap, 3 lines. Cold-call: "name a bug SAST would miss but DAST would catch." ~2 min.</a:t>
+              <a:t>The graded output — six tasks, not three. The defend/fix task (25 pts, "Defense") is the single biggest score component and is easy to undersell if you only recap the triage table. Point to scan.sh.</a:t>
             </a:r>
             <a:endParaRPr lang="en-US" dirty="0"/>
           </a:p>
@@ -1400,7 +1401,7 @@
           <a:p>
             <a:r>
               <a:rPr lang="en-US" dirty="0"/>
-              <a:t>Cliffhanger: "Next week we break crypto — crack passwords and decrypt a secret in minutes." Remind: scanners ready in their VM.</a:t>
+              <a:t>Recap, 3 lines. Cold-call: "name a bug SAST would miss but DAST would catch." ~2 min.</a:t>
             </a:r>
             <a:endParaRPr lang="en-US" dirty="0"/>
           </a:p>
@@ -1512,6 +1513,94 @@
             <a:fld id="{F7021451-1387-4CA6-816F-3879F97B5CBC}" type="slidenum">
               <a:rPr lang="en-US"/>
               <a:t>2</a:t>
+            </a:fld>
+            <a:endParaRPr lang="en-US"/>
+          </a:p>
+        </p:txBody>
+      </p:sp>
+    </p:spTree>
+    <p:extLst>
+      <p:ext uri="{BB962C8B-B14F-4D97-AF65-F5344CB8AC3E}">
+        <p14:creationId xmlns:p14="http://schemas.microsoft.com/office/powerpoint/2010/main" val="1024086991"/>
+      </p:ext>
+    </p:extLst>
+  </p:cSld>
+  <p:clrMapOvr>
+    <a:masterClrMapping/>
+  </p:clrMapOvr>
+</p:notes>
+</file>
+
+<file path=ppt/notesSlides/notesSlide20.xml><?xml version="1.0" encoding="utf-8"?>
+<p:notes xmlns:a="http://schemas.openxmlformats.org/drawingml/2006/main" xmlns:r="http://schemas.openxmlformats.org/officeDocument/2006/relationships" xmlns:p="http://schemas.openxmlformats.org/presentationml/2006/main">
+  <p:cSld>
+    <p:spTree>
+      <p:nvGrpSpPr>
+        <p:cNvPr id="1" name=""/>
+        <p:cNvGrpSpPr/>
+        <p:nvPr/>
+      </p:nvGrpSpPr>
+      <p:grpSpPr>
+        <a:xfrm>
+          <a:off x="0" y="0"/>
+          <a:ext cx="0" cy="0"/>
+          <a:chOff x="0" y="0"/>
+          <a:chExt cx="0" cy="0"/>
+        </a:xfrm>
+      </p:grpSpPr>
+      <p:sp>
+        <p:nvSpPr>
+          <p:cNvPr id="2" name="Slide Image Placeholder 1"/>
+          <p:cNvSpPr>
+            <a:spLocks noGrp="1" noRot="1" noChangeAspect="1"/>
+          </p:cNvSpPr>
+          <p:nvPr>
+            <p:ph type="sldImg"/>
+          </p:nvPr>
+        </p:nvSpPr>
+        <p:spPr/>
+      </p:sp>
+      <p:sp>
+        <p:nvSpPr>
+          <p:cNvPr id="3" name="Notes Placeholder 2"/>
+          <p:cNvSpPr>
+            <a:spLocks noGrp="1"/>
+          </p:cNvSpPr>
+          <p:nvPr>
+            <p:ph type="body" idx="1"/>
+          </p:nvPr>
+        </p:nvSpPr>
+        <p:spPr/>
+        <p:txBody>
+          <a:bodyPr/>
+          <a:lstStyle/>
+          <a:p>
+            <a:r>
+              <a:rPr lang="en-US" dirty="0"/>
+              <a:t>Cliffhanger: "Next week we break crypto — crack passwords and decrypt a secret in minutes." Remind: scanners ready in their VM.</a:t>
+            </a:r>
+            <a:endParaRPr lang="en-US" dirty="0"/>
+          </a:p>
+        </p:txBody>
+      </p:sp>
+      <p:sp>
+        <p:nvSpPr>
+          <p:cNvPr id="4" name="Slide Number Placeholder 3"/>
+          <p:cNvSpPr>
+            <a:spLocks noGrp="1"/>
+          </p:cNvSpPr>
+          <p:nvPr>
+            <p:ph type="sldNum" sz="quarter" idx="10"/>
+          </p:nvPr>
+        </p:nvSpPr>
+        <p:spPr/>
+        <p:txBody>
+          <a:bodyPr/>
+          <a:lstStyle/>
+          <a:p>
+            <a:fld id="{F7021451-1387-4CA6-816F-3879F97B5CBC}" type="slidenum">
+              <a:rPr lang="en-US"/>
+              <a:t>20</a:t>
             </a:fld>
             <a:endParaRPr lang="en-US"/>
           </a:p>
@@ -2737,7 +2826,7 @@
                 <a:ea typeface="Arial" pitchFamily="34" charset="-122"/>
                 <a:cs typeface="Arial" pitchFamily="34" charset="-120"/>
               </a:rPr>
-              <a:t>Try it — what actually crashes this harness</a:t>
+              <a:t>How fuzzing finds it</a:t>
             </a:r>
             <a:endParaRPr lang="en-US" sz="2600" dirty="0"/>
           </a:p>
@@ -2752,7 +2841,7 @@
         <p:spPr>
           <a:xfrm>
             <a:off x="548640" y="1325880"/>
-            <a:ext cx="8046720" cy="822960"/>
+            <a:ext cx="8046720" cy="2194560"/>
           </a:xfrm>
           <a:prstGeom prst="rect">
             <a:avLst/>
@@ -2778,24 +2867,7 @@
                 <a:ea typeface="Calibri" pitchFamily="34" charset="-122"/>
                 <a:cs typeface="Calibri" pitchFamily="34" charset="-120"/>
               </a:rPr>
-              <a:t>Type bytes, or pick a preset. Each cell is one if in the real source.</a:t>
-            </a:r>
-            <a:endParaRPr lang="en-US" sz="1400" dirty="0"/>
-          </a:p>
-          <a:p>
-            <a:pPr indent="0" marL="0">
-              <a:buNone/>
-            </a:pPr>
-            <a:r>
-              <a:rPr lang="en-US" sz="1400" dirty="0">
-                <a:solidFill>
-                  <a:srgbClr val="1F2937"/>
-                </a:solidFill>
-                <a:latin typeface="Calibri" pitchFamily="34" charset="0"/>
-                <a:ea typeface="Calibri" pitchFamily="34" charset="-122"/>
-                <a:cs typeface="Calibri" pitchFamily="34" charset="-120"/>
-              </a:rPr>
-              <a:t>Try it live: /sim/fuzz-verdict (interactive simulation, web only)</a:t>
+              <a:t>See diagram: A coverage-guided fuzzer reaches a bug a static analyzer misses: the harness has four nested byte checks (F, U, Z, Z) and the fourth reads data[3] with no size&gt;3 guard, so the input 'FUZ' reads one byte out of bounds. SAST reads the code and stays silent; the fuzzer mutates inputs and is rewarded for each new branch reached, climbing random -&gt; F -&gt; FU -&gt; FUZ until the unguarded read crashes under AddressSanitizer, which writes a reproducer file. SAST and fuzzing are complements, not substitutes. (web only)</a:t>
             </a:r>
             <a:endParaRPr lang="en-US" sz="1400" dirty="0"/>
           </a:p>
@@ -2980,7 +3052,7 @@
                 <a:ea typeface="Arial" pitchFamily="34" charset="-122"/>
                 <a:cs typeface="Arial" pitchFamily="34" charset="-120"/>
               </a:rPr>
-              <a:t>Triage: not every finding is a bug</a:t>
+              <a:t>Try it — what actually crashes this harness</a:t>
             </a:r>
             <a:endParaRPr lang="en-US" sz="2600" dirty="0"/>
           </a:p>
@@ -2988,43 +3060,14 @@
       </p:sp>
       <p:sp>
         <p:nvSpPr>
-          <p:cNvPr id="5" name="Shape 2"/>
-          <p:cNvSpPr/>
-          <p:nvPr/>
-        </p:nvSpPr>
-        <p:spPr>
-          <a:xfrm>
-            <a:off x="457200" y="1325880"/>
-            <a:ext cx="8229600" cy="1517904"/>
-          </a:xfrm>
-          <a:prstGeom prst="roundRect">
-            <a:avLst>
-              <a:gd name="adj" fmla="val 4819"/>
-            </a:avLst>
-          </a:prstGeom>
-          <a:solidFill>
-            <a:srgbClr val="F1F5F9"/>
-          </a:solidFill>
-          <a:ln/>
-          <a:effectLst>
-            <a:outerShdw sx="100000" sy="100000" kx="0" ky="0" algn="bl" rotWithShape="0" blurRad="76200" dist="25400" dir="5400000">
-              <a:srgbClr val="000000">
-                <a:alpha val="12000"/>
-              </a:srgbClr>
-            </a:outerShdw>
-          </a:effectLst>
-        </p:spPr>
-      </p:sp>
-      <p:sp>
-        <p:nvSpPr>
-          <p:cNvPr id="6" name="Text 3"/>
-          <p:cNvSpPr/>
-          <p:nvPr/>
-        </p:nvSpPr>
-        <p:spPr>
-          <a:xfrm>
-            <a:off x="731520" y="1435608"/>
-            <a:ext cx="7680960" cy="1298448"/>
+          <p:cNvPr id="5" name="Text 2"/>
+          <p:cNvSpPr/>
+          <p:nvPr/>
+        </p:nvSpPr>
+        <p:spPr>
+          <a:xfrm>
+            <a:off x="548640" y="1325880"/>
+            <a:ext cx="8046720" cy="822960"/>
           </a:xfrm>
           <a:prstGeom prst="rect">
             <a:avLst/>
@@ -3038,12 +3081,8 @@
           </a:bodyPr>
           <a:lstStyle/>
           <a:p>
-            <a:pPr marL="342900" indent="-342900">
-              <a:spcAft>
-                <a:spcPts val="600"/>
-              </a:spcAft>
-              <a:buSzPct val="100000"/>
-              <a:buChar char="•"/>
+            <a:pPr indent="0" marL="0">
+              <a:buNone/>
             </a:pPr>
             <a:r>
               <a:rPr lang="en-US" sz="1400" dirty="0">
@@ -3054,17 +3093,13 @@
                 <a:ea typeface="Calibri" pitchFamily="34" charset="-122"/>
                 <a:cs typeface="Calibri" pitchFamily="34" charset="-120"/>
               </a:rPr>
-              <a:t>True positive vs false positive</a:t>
+              <a:t>Type bytes, or pick a preset. Each cell is one if in the real source.</a:t>
             </a:r>
             <a:endParaRPr lang="en-US" sz="1400" dirty="0"/>
           </a:p>
           <a:p>
-            <a:pPr marL="342900" indent="-342900">
-              <a:spcAft>
-                <a:spcPts val="600"/>
-              </a:spcAft>
-              <a:buSzPct val="100000"/>
-              <a:buChar char="•"/>
+            <a:pPr indent="0" marL="0">
+              <a:buNone/>
             </a:pPr>
             <a:r>
               <a:rPr lang="en-US" sz="1400" dirty="0">
@@ -3075,87 +3110,45 @@
                 <a:ea typeface="Calibri" pitchFamily="34" charset="-122"/>
                 <a:cs typeface="Calibri" pitchFamily="34" charset="-120"/>
               </a:rPr>
-              <a:t>Map each to a CWE + severity</a:t>
+              <a:t>Try it live: /sim/fuzz-verdict (interactive simulation, web only)</a:t>
             </a:r>
             <a:endParaRPr lang="en-US" sz="1400" dirty="0"/>
           </a:p>
-          <a:p>
-            <a:pPr marL="342900" indent="-342900">
-              <a:spcAft>
-                <a:spcPts val="600"/>
-              </a:spcAft>
-              <a:buSzPct val="100000"/>
-              <a:buChar char="•"/>
-            </a:pPr>
-            <a:r>
-              <a:rPr lang="en-US" sz="1400" dirty="0">
-                <a:solidFill>
-                  <a:srgbClr val="1F2937"/>
+        </p:txBody>
+      </p:sp>
+      <p:sp>
+        <p:nvSpPr>
+          <p:cNvPr id="6" name="Text 3"/>
+          <p:cNvSpPr/>
+          <p:nvPr/>
+        </p:nvSpPr>
+        <p:spPr>
+          <a:xfrm>
+            <a:off x="457200" y="4800600"/>
+            <a:ext cx="6949440" cy="274320"/>
+          </a:xfrm>
+          <a:prstGeom prst="rect">
+            <a:avLst/>
+          </a:prstGeom>
+          <a:noFill/>
+          <a:ln/>
+        </p:spPr>
+        <p:txBody>
+          <a:bodyPr wrap="square" lIns="0" tIns="0" rIns="0" bIns="0" rtlCol="0" anchor="ctr"/>
+          <a:lstStyle/>
+          <a:p>
+            <a:pPr indent="0" marL="0">
+              <a:buNone/>
+            </a:pPr>
+            <a:r>
+              <a:rPr lang="en-US" sz="900" dirty="0">
+                <a:solidFill>
+                  <a:srgbClr val="64748B"/>
                 </a:solidFill>
                 <a:latin typeface="Calibri" pitchFamily="34" charset="0"/>
                 <a:ea typeface="Calibri" pitchFamily="34" charset="-122"/>
                 <a:cs typeface="Calibri" pitchFamily="34" charset="-120"/>
               </a:rPr>
-              <a:t>Prioritize by exploitability × impact</a:t>
-            </a:r>
-            <a:endParaRPr lang="en-US" sz="1400" dirty="0"/>
-          </a:p>
-          <a:p>
-            <a:pPr marL="342900" indent="-342900">
-              <a:spcAft>
-                <a:spcPts val="600"/>
-              </a:spcAft>
-              <a:buSzPct val="100000"/>
-              <a:buChar char="•"/>
-            </a:pPr>
-            <a:r>
-              <a:rPr lang="en-US" sz="1400" dirty="0">
-                <a:solidFill>
-                  <a:srgbClr val="1F2937"/>
-                </a:solidFill>
-                <a:latin typeface="Calibri" pitchFamily="34" charset="0"/>
-                <a:ea typeface="Calibri" pitchFamily="34" charset="-122"/>
-                <a:cs typeface="Calibri" pitchFamily="34" charset="-120"/>
-              </a:rPr>
-              <a:t>Noise kills trust in tools — triage well</a:t>
-            </a:r>
-            <a:endParaRPr lang="en-US" sz="1400" dirty="0"/>
-          </a:p>
-        </p:txBody>
-      </p:sp>
-      <p:sp>
-        <p:nvSpPr>
-          <p:cNvPr id="7" name="Text 4"/>
-          <p:cNvSpPr/>
-          <p:nvPr/>
-        </p:nvSpPr>
-        <p:spPr>
-          <a:xfrm>
-            <a:off x="457200" y="4800600"/>
-            <a:ext cx="6949440" cy="274320"/>
-          </a:xfrm>
-          <a:prstGeom prst="rect">
-            <a:avLst/>
-          </a:prstGeom>
-          <a:noFill/>
-          <a:ln/>
-        </p:spPr>
-        <p:txBody>
-          <a:bodyPr wrap="square" lIns="0" tIns="0" rIns="0" bIns="0" rtlCol="0" anchor="ctr"/>
-          <a:lstStyle/>
-          <a:p>
-            <a:pPr indent="0" marL="0">
-              <a:buNone/>
-            </a:pPr>
-            <a:r>
-              <a:rPr lang="en-US" sz="900" dirty="0">
-                <a:solidFill>
-                  <a:srgbClr val="64748B"/>
-                </a:solidFill>
-                <a:latin typeface="Calibri" pitchFamily="34" charset="0"/>
-                <a:ea typeface="Calibri" pitchFamily="34" charset="-122"/>
-                <a:cs typeface="Calibri" pitchFamily="34" charset="-120"/>
-              </a:rPr>
               <a:t>Software Security · Week 2</a:t>
             </a:r>
             <a:endParaRPr lang="en-US" sz="900" dirty="0"/>
@@ -3164,7 +3157,7 @@
       </p:sp>
       <p:pic>
         <p:nvPicPr>
-          <p:cNvPr id="8" name="Image 1" descr="/Users/pop7/Library/CloudStorage/OneDrive-MonsterConnectCo.,Ltd/Lecture/KOSEN69 - software-security/slides/pptx/assets/logo-small.png">    </p:cNvPr>
+          <p:cNvPr id="7" name="Image 1" descr="/Users/pop7/Library/CloudStorage/OneDrive-MonsterConnectCo.,Ltd/Lecture/KOSEN69 - software-security/slides/pptx/assets/logo-small.png">    </p:cNvPr>
           <p:cNvPicPr>
             <a:picLocks noChangeAspect="1"/>
           </p:cNvPicPr>
@@ -3302,7 +3295,7 @@
                 <a:ea typeface="Arial" pitchFamily="34" charset="-122"/>
                 <a:cs typeface="Arial" pitchFamily="34" charset="-120"/>
               </a:rPr>
-              <a:t>Try it — which bug is this, really?</a:t>
+              <a:t>Triage: not every finding is a bug</a:t>
             </a:r>
             <a:endParaRPr lang="en-US" sz="2600" dirty="0"/>
           </a:p>
@@ -3310,14 +3303,43 @@
       </p:sp>
       <p:sp>
         <p:nvSpPr>
-          <p:cNvPr id="5" name="Text 2"/>
-          <p:cNvSpPr/>
-          <p:nvPr/>
-        </p:nvSpPr>
-        <p:spPr>
-          <a:xfrm>
-            <a:off x="548640" y="1325880"/>
-            <a:ext cx="8046720" cy="822960"/>
+          <p:cNvPr id="5" name="Shape 2"/>
+          <p:cNvSpPr/>
+          <p:nvPr/>
+        </p:nvSpPr>
+        <p:spPr>
+          <a:xfrm>
+            <a:off x="457200" y="1325880"/>
+            <a:ext cx="8229600" cy="1517904"/>
+          </a:xfrm>
+          <a:prstGeom prst="roundRect">
+            <a:avLst>
+              <a:gd name="adj" fmla="val 4819"/>
+            </a:avLst>
+          </a:prstGeom>
+          <a:solidFill>
+            <a:srgbClr val="F1F5F9"/>
+          </a:solidFill>
+          <a:ln/>
+          <a:effectLst>
+            <a:outerShdw sx="100000" sy="100000" kx="0" ky="0" algn="bl" rotWithShape="0" blurRad="76200" dist="25400" dir="5400000">
+              <a:srgbClr val="000000">
+                <a:alpha val="12000"/>
+              </a:srgbClr>
+            </a:outerShdw>
+          </a:effectLst>
+        </p:spPr>
+      </p:sp>
+      <p:sp>
+        <p:nvSpPr>
+          <p:cNvPr id="6" name="Text 3"/>
+          <p:cNvSpPr/>
+          <p:nvPr/>
+        </p:nvSpPr>
+        <p:spPr>
+          <a:xfrm>
+            <a:off x="731520" y="1435608"/>
+            <a:ext cx="7680960" cy="1298448"/>
           </a:xfrm>
           <a:prstGeom prst="rect">
             <a:avLst/>
@@ -3331,8 +3353,12 @@
           </a:bodyPr>
           <a:lstStyle/>
           <a:p>
-            <a:pPr indent="0" marL="0">
-              <a:buNone/>
+            <a:pPr marL="342900" indent="-342900">
+              <a:spcAft>
+                <a:spcPts val="600"/>
+              </a:spcAft>
+              <a:buSzPct val="100000"/>
+              <a:buChar char="•"/>
             </a:pPr>
             <a:r>
               <a:rPr lang="en-US" sz="1400" dirty="0">
@@ -3343,13 +3369,17 @@
                 <a:ea typeface="Calibri" pitchFamily="34" charset="-122"/>
                 <a:cs typeface="Calibri" pitchFamily="34" charset="-120"/>
               </a:rPr>
-              <a:t>Seven raw findings from a real scan. Map each back to the one bug underneath.</a:t>
+              <a:t>True positive vs false positive</a:t>
             </a:r>
             <a:endParaRPr lang="en-US" sz="1400" dirty="0"/>
           </a:p>
           <a:p>
-            <a:pPr indent="0" marL="0">
-              <a:buNone/>
+            <a:pPr marL="342900" indent="-342900">
+              <a:spcAft>
+                <a:spcPts val="600"/>
+              </a:spcAft>
+              <a:buSzPct val="100000"/>
+              <a:buChar char="•"/>
             </a:pPr>
             <a:r>
               <a:rPr lang="en-US" sz="1400" dirty="0">
@@ -3360,45 +3390,87 @@
                 <a:ea typeface="Calibri" pitchFamily="34" charset="-122"/>
                 <a:cs typeface="Calibri" pitchFamily="34" charset="-120"/>
               </a:rPr>
-              <a:t>Try it live: /sim/triage-drill (interactive simulation, web only)</a:t>
+              <a:t>Map each to a CWE + severity</a:t>
             </a:r>
             <a:endParaRPr lang="en-US" sz="1400" dirty="0"/>
           </a:p>
-        </p:txBody>
-      </p:sp>
-      <p:sp>
-        <p:nvSpPr>
-          <p:cNvPr id="6" name="Text 3"/>
-          <p:cNvSpPr/>
-          <p:nvPr/>
-        </p:nvSpPr>
-        <p:spPr>
-          <a:xfrm>
-            <a:off x="457200" y="4800600"/>
-            <a:ext cx="6949440" cy="274320"/>
-          </a:xfrm>
-          <a:prstGeom prst="rect">
-            <a:avLst/>
-          </a:prstGeom>
-          <a:noFill/>
-          <a:ln/>
-        </p:spPr>
-        <p:txBody>
-          <a:bodyPr wrap="square" lIns="0" tIns="0" rIns="0" bIns="0" rtlCol="0" anchor="ctr"/>
-          <a:lstStyle/>
-          <a:p>
-            <a:pPr indent="0" marL="0">
-              <a:buNone/>
-            </a:pPr>
-            <a:r>
-              <a:rPr lang="en-US" sz="900" dirty="0">
-                <a:solidFill>
-                  <a:srgbClr val="64748B"/>
+          <a:p>
+            <a:pPr marL="342900" indent="-342900">
+              <a:spcAft>
+                <a:spcPts val="600"/>
+              </a:spcAft>
+              <a:buSzPct val="100000"/>
+              <a:buChar char="•"/>
+            </a:pPr>
+            <a:r>
+              <a:rPr lang="en-US" sz="1400" dirty="0">
+                <a:solidFill>
+                  <a:srgbClr val="1F2937"/>
                 </a:solidFill>
                 <a:latin typeface="Calibri" pitchFamily="34" charset="0"/>
                 <a:ea typeface="Calibri" pitchFamily="34" charset="-122"/>
                 <a:cs typeface="Calibri" pitchFamily="34" charset="-120"/>
               </a:rPr>
+              <a:t>Prioritize by exploitability × impact</a:t>
+            </a:r>
+            <a:endParaRPr lang="en-US" sz="1400" dirty="0"/>
+          </a:p>
+          <a:p>
+            <a:pPr marL="342900" indent="-342900">
+              <a:spcAft>
+                <a:spcPts val="600"/>
+              </a:spcAft>
+              <a:buSzPct val="100000"/>
+              <a:buChar char="•"/>
+            </a:pPr>
+            <a:r>
+              <a:rPr lang="en-US" sz="1400" dirty="0">
+                <a:solidFill>
+                  <a:srgbClr val="1F2937"/>
+                </a:solidFill>
+                <a:latin typeface="Calibri" pitchFamily="34" charset="0"/>
+                <a:ea typeface="Calibri" pitchFamily="34" charset="-122"/>
+                <a:cs typeface="Calibri" pitchFamily="34" charset="-120"/>
+              </a:rPr>
+              <a:t>Noise kills trust in tools — triage well</a:t>
+            </a:r>
+            <a:endParaRPr lang="en-US" sz="1400" dirty="0"/>
+          </a:p>
+        </p:txBody>
+      </p:sp>
+      <p:sp>
+        <p:nvSpPr>
+          <p:cNvPr id="7" name="Text 4"/>
+          <p:cNvSpPr/>
+          <p:nvPr/>
+        </p:nvSpPr>
+        <p:spPr>
+          <a:xfrm>
+            <a:off x="457200" y="4800600"/>
+            <a:ext cx="6949440" cy="274320"/>
+          </a:xfrm>
+          <a:prstGeom prst="rect">
+            <a:avLst/>
+          </a:prstGeom>
+          <a:noFill/>
+          <a:ln/>
+        </p:spPr>
+        <p:txBody>
+          <a:bodyPr wrap="square" lIns="0" tIns="0" rIns="0" bIns="0" rtlCol="0" anchor="ctr"/>
+          <a:lstStyle/>
+          <a:p>
+            <a:pPr indent="0" marL="0">
+              <a:buNone/>
+            </a:pPr>
+            <a:r>
+              <a:rPr lang="en-US" sz="900" dirty="0">
+                <a:solidFill>
+                  <a:srgbClr val="64748B"/>
+                </a:solidFill>
+                <a:latin typeface="Calibri" pitchFamily="34" charset="0"/>
+                <a:ea typeface="Calibri" pitchFamily="34" charset="-122"/>
+                <a:cs typeface="Calibri" pitchFamily="34" charset="-120"/>
+              </a:rPr>
               <a:t>Software Security · Week 2</a:t>
             </a:r>
             <a:endParaRPr lang="en-US" sz="900" dirty="0"/>
@@ -3407,7 +3479,7 @@
       </p:sp>
       <p:pic>
         <p:nvPicPr>
-          <p:cNvPr id="7" name="Image 1" descr="/Users/pop7/Library/CloudStorage/OneDrive-MonsterConnectCo.,Ltd/Lecture/KOSEN69 - software-security/slides/pptx/assets/logo-small.png">    </p:cNvPr>
+          <p:cNvPr id="8" name="Image 1" descr="/Users/pop7/Library/CloudStorage/OneDrive-MonsterConnectCo.,Ltd/Lecture/KOSEN69 - software-security/slides/pptx/assets/logo-small.png">    </p:cNvPr>
           <p:cNvPicPr>
             <a:picLocks noChangeAspect="1"/>
           </p:cNvPicPr>
@@ -3545,7 +3617,7 @@
                 <a:ea typeface="Arial" pitchFamily="34" charset="-122"/>
                 <a:cs typeface="Arial" pitchFamily="34" charset="-120"/>
               </a:rPr>
-              <a:t>Tools you'll meet</a:t>
+              <a:t>Try it — which bug is this, really?</a:t>
             </a:r>
             <a:endParaRPr lang="en-US" sz="2600" dirty="0"/>
           </a:p>
@@ -3553,43 +3625,14 @@
       </p:sp>
       <p:sp>
         <p:nvSpPr>
-          <p:cNvPr id="5" name="Shape 2"/>
-          <p:cNvSpPr/>
-          <p:nvPr/>
-        </p:nvSpPr>
-        <p:spPr>
-          <a:xfrm>
-            <a:off x="457200" y="1325880"/>
-            <a:ext cx="8229600" cy="1609344"/>
-          </a:xfrm>
-          <a:prstGeom prst="roundRect">
-            <a:avLst>
-              <a:gd name="adj" fmla="val 4545"/>
-            </a:avLst>
-          </a:prstGeom>
-          <a:solidFill>
-            <a:srgbClr val="F1F5F9"/>
-          </a:solidFill>
-          <a:ln/>
-          <a:effectLst>
-            <a:outerShdw sx="100000" sy="100000" kx="0" ky="0" algn="bl" rotWithShape="0" blurRad="76200" dist="25400" dir="5400000">
-              <a:srgbClr val="000000">
-                <a:alpha val="12000"/>
-              </a:srgbClr>
-            </a:outerShdw>
-          </a:effectLst>
-        </p:spPr>
-      </p:sp>
-      <p:sp>
-        <p:nvSpPr>
-          <p:cNvPr id="6" name="Text 3"/>
-          <p:cNvSpPr/>
-          <p:nvPr/>
-        </p:nvSpPr>
-        <p:spPr>
-          <a:xfrm>
-            <a:off x="731520" y="1435608"/>
-            <a:ext cx="7680960" cy="1389888"/>
+          <p:cNvPr id="5" name="Text 2"/>
+          <p:cNvSpPr/>
+          <p:nvPr/>
+        </p:nvSpPr>
+        <p:spPr>
+          <a:xfrm>
+            <a:off x="548640" y="1325880"/>
+            <a:ext cx="8046720" cy="822960"/>
           </a:xfrm>
           <a:prstGeom prst="rect">
             <a:avLst/>
@@ -3603,12 +3646,8 @@
           </a:bodyPr>
           <a:lstStyle/>
           <a:p>
-            <a:pPr marL="342900" indent="-342900">
-              <a:spcAft>
-                <a:spcPts val="600"/>
-              </a:spcAft>
-              <a:buSzPct val="100000"/>
-              <a:buChar char="•"/>
+            <a:pPr indent="0" marL="0">
+              <a:buNone/>
             </a:pPr>
             <a:r>
               <a:rPr lang="en-US" sz="1400" dirty="0">
@@ -3619,17 +3658,13 @@
                 <a:ea typeface="Calibri" pitchFamily="34" charset="-122"/>
                 <a:cs typeface="Calibri" pitchFamily="34" charset="-120"/>
               </a:rPr>
-              <a:t>Trivy — the SCA scanner you'll actually run this lab (dependency scan today; image + IaC scanning return in W12/13)</a:t>
+              <a:t>Seven raw findings from a real scan. Map each back to the one bug underneath.</a:t>
             </a:r>
             <a:endParaRPr lang="en-US" sz="1400" dirty="0"/>
           </a:p>
           <a:p>
-            <a:pPr marL="342900" indent="-342900">
-              <a:spcAft>
-                <a:spcPts val="600"/>
-              </a:spcAft>
-              <a:buSzPct val="100000"/>
-              <a:buChar char="•"/>
+            <a:pPr indent="0" marL="0">
+              <a:buNone/>
             </a:pPr>
             <a:r>
               <a:rPr lang="en-US" sz="1400" dirty="0">
@@ -3640,66 +3675,45 @@
                 <a:ea typeface="Calibri" pitchFamily="34" charset="-122"/>
                 <a:cs typeface="Calibri" pitchFamily="34" charset="-120"/>
               </a:rPr>
-              <a:t>SonarQube, GitHub Advanced Security (GHAS) — quality-gate/SAST-in-the-repo tools you'll see in industry/internships, not used in this lab</a:t>
+              <a:t>Try it live: /sim/triage-drill (interactive simulation, web only)</a:t>
             </a:r>
             <a:endParaRPr lang="en-US" sz="1400" dirty="0"/>
           </a:p>
-          <a:p>
-            <a:pPr marL="342900" indent="-342900">
-              <a:spcAft>
-                <a:spcPts val="600"/>
-              </a:spcAft>
-              <a:buSzPct val="100000"/>
-              <a:buChar char="•"/>
-            </a:pPr>
-            <a:r>
-              <a:rPr lang="en-US" sz="1400" dirty="0">
-                <a:solidFill>
-                  <a:srgbClr val="1F2937"/>
+        </p:txBody>
+      </p:sp>
+      <p:sp>
+        <p:nvSpPr>
+          <p:cNvPr id="6" name="Text 3"/>
+          <p:cNvSpPr/>
+          <p:nvPr/>
+        </p:nvSpPr>
+        <p:spPr>
+          <a:xfrm>
+            <a:off x="457200" y="4800600"/>
+            <a:ext cx="6949440" cy="274320"/>
+          </a:xfrm>
+          <a:prstGeom prst="rect">
+            <a:avLst/>
+          </a:prstGeom>
+          <a:noFill/>
+          <a:ln/>
+        </p:spPr>
+        <p:txBody>
+          <a:bodyPr wrap="square" lIns="0" tIns="0" rIns="0" bIns="0" rtlCol="0" anchor="ctr"/>
+          <a:lstStyle/>
+          <a:p>
+            <a:pPr indent="0" marL="0">
+              <a:buNone/>
+            </a:pPr>
+            <a:r>
+              <a:rPr lang="en-US" sz="900" dirty="0">
+                <a:solidFill>
+                  <a:srgbClr val="64748B"/>
                 </a:solidFill>
                 <a:latin typeface="Calibri" pitchFamily="34" charset="0"/>
                 <a:ea typeface="Calibri" pitchFamily="34" charset="-122"/>
                 <a:cs typeface="Calibri" pitchFamily="34" charset="-120"/>
               </a:rPr>
-              <a:t>Address technical debt early — cheaper than re-work later</a:t>
-            </a:r>
-            <a:endParaRPr lang="en-US" sz="1400" dirty="0"/>
-          </a:p>
-        </p:txBody>
-      </p:sp>
-      <p:sp>
-        <p:nvSpPr>
-          <p:cNvPr id="7" name="Text 4"/>
-          <p:cNvSpPr/>
-          <p:nvPr/>
-        </p:nvSpPr>
-        <p:spPr>
-          <a:xfrm>
-            <a:off x="457200" y="4800600"/>
-            <a:ext cx="6949440" cy="274320"/>
-          </a:xfrm>
-          <a:prstGeom prst="rect">
-            <a:avLst/>
-          </a:prstGeom>
-          <a:noFill/>
-          <a:ln/>
-        </p:spPr>
-        <p:txBody>
-          <a:bodyPr wrap="square" lIns="0" tIns="0" rIns="0" bIns="0" rtlCol="0" anchor="ctr"/>
-          <a:lstStyle/>
-          <a:p>
-            <a:pPr indent="0" marL="0">
-              <a:buNone/>
-            </a:pPr>
-            <a:r>
-              <a:rPr lang="en-US" sz="900" dirty="0">
-                <a:solidFill>
-                  <a:srgbClr val="64748B"/>
-                </a:solidFill>
-                <a:latin typeface="Calibri" pitchFamily="34" charset="0"/>
-                <a:ea typeface="Calibri" pitchFamily="34" charset="-122"/>
-                <a:cs typeface="Calibri" pitchFamily="34" charset="-120"/>
-              </a:rPr>
               <a:t>Software Security · Week 2</a:t>
             </a:r>
             <a:endParaRPr lang="en-US" sz="900" dirty="0"/>
@@ -3708,7 +3722,7 @@
       </p:sp>
       <p:pic>
         <p:nvPicPr>
-          <p:cNvPr id="8" name="Image 1" descr="/Users/pop7/Library/CloudStorage/OneDrive-MonsterConnectCo.,Ltd/Lecture/KOSEN69 - software-security/slides/pptx/assets/logo-small.png">    </p:cNvPr>
+          <p:cNvPr id="7" name="Image 1" descr="/Users/pop7/Library/CloudStorage/OneDrive-MonsterConnectCo.,Ltd/Lecture/KOSEN69 - software-security/slides/pptx/assets/logo-small.png">    </p:cNvPr>
           <p:cNvPicPr>
             <a:picLocks noChangeAspect="1"/>
           </p:cNvPicPr>
@@ -3846,7 +3860,7 @@
                 <a:ea typeface="Arial" pitchFamily="34" charset="-122"/>
                 <a:cs typeface="Arial" pitchFamily="34" charset="-120"/>
               </a:rPr>
-              <a:t>🏁 Game — Bug Triage Race</a:t>
+              <a:t>Tools you'll meet</a:t>
             </a:r>
             <a:endParaRPr lang="en-US" sz="2600" dirty="0"/>
           </a:p>
@@ -3861,11 +3875,11 @@
         <p:spPr>
           <a:xfrm>
             <a:off x="457200" y="1325880"/>
-            <a:ext cx="8229600" cy="896112"/>
+            <a:ext cx="8229600" cy="1609344"/>
           </a:xfrm>
           <a:prstGeom prst="roundRect">
             <a:avLst>
-              <a:gd name="adj" fmla="val 8163"/>
+              <a:gd name="adj" fmla="val 4545"/>
             </a:avLst>
           </a:prstGeom>
           <a:solidFill>
@@ -3890,7 +3904,7 @@
         <p:spPr>
           <a:xfrm>
             <a:off x="731520" y="1435608"/>
-            <a:ext cx="7680960" cy="676656"/>
+            <a:ext cx="7680960" cy="1389888"/>
           </a:xfrm>
           <a:prstGeom prst="rect">
             <a:avLst/>
@@ -3920,7 +3934,7 @@
                 <a:ea typeface="Calibri" pitchFamily="34" charset="-122"/>
                 <a:cs typeface="Calibri" pitchFamily="34" charset="-120"/>
               </a:rPr>
-              <a:t>Run Semgrep + Gitleaks on the flawed repo</a:t>
+              <a:t>Trivy — the SCA scanner you'll actually run this lab (dependency scan today; image + IaC scanning return in W12/13)</a:t>
             </a:r>
             <a:endParaRPr lang="en-US" sz="1400" dirty="0"/>
           </a:p>
@@ -3941,164 +3955,66 @@
                 <a:ea typeface="Calibri" pitchFamily="34" charset="-122"/>
                 <a:cs typeface="Calibri" pitchFamily="34" charset="-120"/>
               </a:rPr>
-              <a:t>Score = true positives − misclassified · live scoreboard</a:t>
+              <a:t>SonarQube, GitHub Advanced Security (GHAS) — quality-gate/SAST-in-the-repo tools you'll see in industry/internships, not used in this lab</a:t>
             </a:r>
             <a:endParaRPr lang="en-US" sz="1400" dirty="0"/>
           </a:p>
-        </p:txBody>
-      </p:sp>
-      <p:sp>
-        <p:nvSpPr>
-          <p:cNvPr id="7" name="Shape 4"/>
-          <p:cNvSpPr/>
-          <p:nvPr/>
-        </p:nvSpPr>
-        <p:spPr>
-          <a:xfrm>
-            <a:off x="457200" y="2386584"/>
-            <a:ext cx="8229600" cy="1152144"/>
-          </a:xfrm>
-          <a:prstGeom prst="roundRect">
-            <a:avLst>
-              <a:gd name="adj" fmla="val 4762"/>
-            </a:avLst>
-          </a:prstGeom>
-          <a:solidFill>
-            <a:srgbClr val="0A1020"/>
-          </a:solidFill>
-          <a:ln w="12700">
-            <a:solidFill>
-              <a:srgbClr val="E8EDF3"/>
-            </a:solidFill>
-            <a:prstDash val="solid"/>
-          </a:ln>
-        </p:spPr>
-      </p:sp>
-      <p:sp>
-        <p:nvSpPr>
-          <p:cNvPr id="8" name="Text 5"/>
-          <p:cNvSpPr/>
-          <p:nvPr/>
-        </p:nvSpPr>
-        <p:spPr>
-          <a:xfrm>
-            <a:off x="640080" y="2459736"/>
-            <a:ext cx="7863840" cy="1005840"/>
-          </a:xfrm>
-          <a:prstGeom prst="rect">
-            <a:avLst/>
-          </a:prstGeom>
-          <a:noFill/>
-          <a:ln/>
-        </p:spPr>
-        <p:txBody>
-          <a:bodyPr wrap="square" lIns="0" tIns="0" rIns="0" bIns="0" rtlCol="0" anchor="t">
-            <a:normAutofit/>
-          </a:bodyPr>
-          <a:lstStyle/>
-          <a:p>
-            <a:pPr indent="0" marL="0">
-              <a:buNone/>
-            </a:pPr>
-            <a:r>
-              <a:rPr lang="en-US" sz="1150" dirty="0">
-                <a:solidFill>
-                  <a:srgbClr val="9FE7D6"/>
-                </a:solidFill>
-                <a:latin typeface="Courier New" pitchFamily="34" charset="0"/>
-                <a:ea typeface="Courier New" pitchFamily="34" charset="-122"/>
-                <a:cs typeface="Courier New" pitchFamily="34" charset="-120"/>
-              </a:rPr>
-              <a:t>docker run --rm -v "$PWD/vulnerable-repo:/src" semgrep/semgrep \</a:t>
-            </a:r>
-            <a:endParaRPr lang="en-US" sz="1150" dirty="0"/>
-          </a:p>
-          <a:p>
-            <a:pPr indent="0" marL="0">
-              <a:buNone/>
-            </a:pPr>
-            <a:r>
-              <a:rPr lang="en-US" sz="1150" dirty="0">
-                <a:solidFill>
-                  <a:srgbClr val="9FE7D6"/>
-                </a:solidFill>
-                <a:latin typeface="Courier New" pitchFamily="34" charset="0"/>
-                <a:ea typeface="Courier New" pitchFamily="34" charset="-122"/>
-                <a:cs typeface="Courier New" pitchFamily="34" charset="-120"/>
-              </a:rPr>
-              <a:t>  semgrep --config p/default --config p/owasp-top-ten /src</a:t>
-            </a:r>
-            <a:endParaRPr lang="en-US" sz="1150" dirty="0"/>
-          </a:p>
-          <a:p>
-            <a:pPr indent="0" marL="0">
-              <a:buNone/>
-            </a:pPr>
-            <a:r>
-              <a:rPr lang="en-US" sz="1150" dirty="0">
-                <a:solidFill>
-                  <a:srgbClr val="9FE7D6"/>
-                </a:solidFill>
-                <a:latin typeface="Courier New" pitchFamily="34" charset="0"/>
-                <a:ea typeface="Courier New" pitchFamily="34" charset="-122"/>
-                <a:cs typeface="Courier New" pitchFamily="34" charset="-120"/>
-              </a:rPr>
-              <a:t>docker run --rm -v "$PWD/vulnerable-repo:/repo" zricethezav/gitleaks:latest \</a:t>
-            </a:r>
-            <a:endParaRPr lang="en-US" sz="1150" dirty="0"/>
-          </a:p>
-          <a:p>
-            <a:pPr indent="0" marL="0">
-              <a:buNone/>
-            </a:pPr>
-            <a:r>
-              <a:rPr lang="en-US" sz="1150" dirty="0">
-                <a:solidFill>
-                  <a:srgbClr val="9FE7D6"/>
-                </a:solidFill>
-                <a:latin typeface="Courier New" pitchFamily="34" charset="0"/>
-                <a:ea typeface="Courier New" pitchFamily="34" charset="-122"/>
-                <a:cs typeface="Courier New" pitchFamily="34" charset="-120"/>
-              </a:rPr>
-              <a:t>  detect -s /repo -v --no-git</a:t>
-            </a:r>
-            <a:endParaRPr lang="en-US" sz="1150" dirty="0"/>
-          </a:p>
-        </p:txBody>
-      </p:sp>
-      <p:sp>
-        <p:nvSpPr>
-          <p:cNvPr id="9" name="Text 6"/>
-          <p:cNvSpPr/>
-          <p:nvPr/>
-        </p:nvSpPr>
-        <p:spPr>
-          <a:xfrm>
-            <a:off x="457200" y="4800600"/>
-            <a:ext cx="6949440" cy="274320"/>
-          </a:xfrm>
-          <a:prstGeom prst="rect">
-            <a:avLst/>
-          </a:prstGeom>
-          <a:noFill/>
-          <a:ln/>
-        </p:spPr>
-        <p:txBody>
-          <a:bodyPr wrap="square" lIns="0" tIns="0" rIns="0" bIns="0" rtlCol="0" anchor="ctr"/>
-          <a:lstStyle/>
-          <a:p>
-            <a:pPr indent="0" marL="0">
-              <a:buNone/>
-            </a:pPr>
-            <a:r>
-              <a:rPr lang="en-US" sz="900" dirty="0">
-                <a:solidFill>
-                  <a:srgbClr val="64748B"/>
+          <a:p>
+            <a:pPr marL="342900" indent="-342900">
+              <a:spcAft>
+                <a:spcPts val="600"/>
+              </a:spcAft>
+              <a:buSzPct val="100000"/>
+              <a:buChar char="•"/>
+            </a:pPr>
+            <a:r>
+              <a:rPr lang="en-US" sz="1400" dirty="0">
+                <a:solidFill>
+                  <a:srgbClr val="1F2937"/>
                 </a:solidFill>
                 <a:latin typeface="Calibri" pitchFamily="34" charset="0"/>
                 <a:ea typeface="Calibri" pitchFamily="34" charset="-122"/>
                 <a:cs typeface="Calibri" pitchFamily="34" charset="-120"/>
               </a:rPr>
+              <a:t>Address technical debt early — cheaper than re-work later</a:t>
+            </a:r>
+            <a:endParaRPr lang="en-US" sz="1400" dirty="0"/>
+          </a:p>
+        </p:txBody>
+      </p:sp>
+      <p:sp>
+        <p:nvSpPr>
+          <p:cNvPr id="7" name="Text 4"/>
+          <p:cNvSpPr/>
+          <p:nvPr/>
+        </p:nvSpPr>
+        <p:spPr>
+          <a:xfrm>
+            <a:off x="457200" y="4800600"/>
+            <a:ext cx="6949440" cy="274320"/>
+          </a:xfrm>
+          <a:prstGeom prst="rect">
+            <a:avLst/>
+          </a:prstGeom>
+          <a:noFill/>
+          <a:ln/>
+        </p:spPr>
+        <p:txBody>
+          <a:bodyPr wrap="square" lIns="0" tIns="0" rIns="0" bIns="0" rtlCol="0" anchor="ctr"/>
+          <a:lstStyle/>
+          <a:p>
+            <a:pPr indent="0" marL="0">
+              <a:buNone/>
+            </a:pPr>
+            <a:r>
+              <a:rPr lang="en-US" sz="900" dirty="0">
+                <a:solidFill>
+                  <a:srgbClr val="64748B"/>
+                </a:solidFill>
+                <a:latin typeface="Calibri" pitchFamily="34" charset="0"/>
+                <a:ea typeface="Calibri" pitchFamily="34" charset="-122"/>
+                <a:cs typeface="Calibri" pitchFamily="34" charset="-120"/>
+              </a:rPr>
               <a:t>Software Security · Week 2</a:t>
             </a:r>
             <a:endParaRPr lang="en-US" sz="900" dirty="0"/>
@@ -4107,7 +4023,7 @@
       </p:sp>
       <p:pic>
         <p:nvPicPr>
-          <p:cNvPr id="10" name="Image 1" descr="/Users/pop7/Library/CloudStorage/OneDrive-MonsterConnectCo.,Ltd/Lecture/KOSEN69 - software-security/slides/pptx/assets/logo-small.png">    </p:cNvPr>
+          <p:cNvPr id="8" name="Image 1" descr="/Users/pop7/Library/CloudStorage/OneDrive-MonsterConnectCo.,Ltd/Lecture/KOSEN69 - software-security/slides/pptx/assets/logo-small.png">    </p:cNvPr>
           <p:cNvPicPr>
             <a:picLocks noChangeAspect="1"/>
           </p:cNvPicPr>
@@ -4245,7 +4161,7 @@
                 <a:ea typeface="Arial" pitchFamily="34" charset="-122"/>
                 <a:cs typeface="Arial" pitchFamily="34" charset="-120"/>
               </a:rPr>
-              <a:t>🐝 Mini-game — Fuzzing Race</a:t>
+              <a:t>🏁 Game — Bug Triage Race</a:t>
             </a:r>
             <a:endParaRPr lang="en-US" sz="2600" dirty="0"/>
           </a:p>
@@ -4260,11 +4176,11 @@
         <p:spPr>
           <a:xfrm>
             <a:off x="457200" y="1325880"/>
-            <a:ext cx="8229600" cy="1207008"/>
+            <a:ext cx="8229600" cy="896112"/>
           </a:xfrm>
           <a:prstGeom prst="roundRect">
             <a:avLst>
-              <a:gd name="adj" fmla="val 6061"/>
+              <a:gd name="adj" fmla="val 8163"/>
             </a:avLst>
           </a:prstGeom>
           <a:solidFill>
@@ -4289,7 +4205,7 @@
         <p:spPr>
           <a:xfrm>
             <a:off x="731520" y="1435608"/>
-            <a:ext cx="7680960" cy="987552"/>
+            <a:ext cx="7680960" cy="676656"/>
           </a:xfrm>
           <a:prstGeom prst="rect">
             <a:avLst/>
@@ -4319,7 +4235,7 @@
                 <a:ea typeface="Calibri" pitchFamily="34" charset="-122"/>
                 <a:cs typeface="Calibri" pitchFamily="34" charset="-120"/>
               </a:rPr>
-              <a:t>First team to make the provided target crash wins</a:t>
+              <a:t>Run Semgrep + Gitleaks on the flawed repo</a:t>
             </a:r>
             <a:endParaRPr lang="en-US" sz="1400" dirty="0"/>
           </a:p>
@@ -4340,66 +4256,164 @@
                 <a:ea typeface="Calibri" pitchFamily="34" charset="-122"/>
                 <a:cs typeface="Calibri" pitchFamily="34" charset="-120"/>
               </a:rPr>
-              <a:t>One crash → one root-cause note</a:t>
+              <a:t>Score = true positives − misclassified · live scoreboard</a:t>
             </a:r>
             <a:endParaRPr lang="en-US" sz="1400" dirty="0"/>
           </a:p>
-          <a:p>
-            <a:pPr marL="342900" indent="-342900">
-              <a:spcAft>
-                <a:spcPts val="600"/>
-              </a:spcAft>
-              <a:buSzPct val="100000"/>
-              <a:buChar char="•"/>
-            </a:pPr>
-            <a:r>
-              <a:rPr lang="en-US" sz="1400" dirty="0">
-                <a:solidFill>
-                  <a:srgbClr val="1F2937"/>
+        </p:txBody>
+      </p:sp>
+      <p:sp>
+        <p:nvSpPr>
+          <p:cNvPr id="7" name="Shape 4"/>
+          <p:cNvSpPr/>
+          <p:nvPr/>
+        </p:nvSpPr>
+        <p:spPr>
+          <a:xfrm>
+            <a:off x="457200" y="2386584"/>
+            <a:ext cx="8229600" cy="1152144"/>
+          </a:xfrm>
+          <a:prstGeom prst="roundRect">
+            <a:avLst>
+              <a:gd name="adj" fmla="val 4762"/>
+            </a:avLst>
+          </a:prstGeom>
+          <a:solidFill>
+            <a:srgbClr val="0A1020"/>
+          </a:solidFill>
+          <a:ln w="12700">
+            <a:solidFill>
+              <a:srgbClr val="E8EDF3"/>
+            </a:solidFill>
+            <a:prstDash val="solid"/>
+          </a:ln>
+        </p:spPr>
+      </p:sp>
+      <p:sp>
+        <p:nvSpPr>
+          <p:cNvPr id="8" name="Text 5"/>
+          <p:cNvSpPr/>
+          <p:nvPr/>
+        </p:nvSpPr>
+        <p:spPr>
+          <a:xfrm>
+            <a:off x="640080" y="2459736"/>
+            <a:ext cx="7863840" cy="1005840"/>
+          </a:xfrm>
+          <a:prstGeom prst="rect">
+            <a:avLst/>
+          </a:prstGeom>
+          <a:noFill/>
+          <a:ln/>
+        </p:spPr>
+        <p:txBody>
+          <a:bodyPr wrap="square" lIns="0" tIns="0" rIns="0" bIns="0" rtlCol="0" anchor="t">
+            <a:normAutofit/>
+          </a:bodyPr>
+          <a:lstStyle/>
+          <a:p>
+            <a:pPr indent="0" marL="0">
+              <a:buNone/>
+            </a:pPr>
+            <a:r>
+              <a:rPr lang="en-US" sz="1150" dirty="0">
+                <a:solidFill>
+                  <a:srgbClr val="9FE7D6"/>
+                </a:solidFill>
+                <a:latin typeface="Courier New" pitchFamily="34" charset="0"/>
+                <a:ea typeface="Courier New" pitchFamily="34" charset="-122"/>
+                <a:cs typeface="Courier New" pitchFamily="34" charset="-120"/>
+              </a:rPr>
+              <a:t>docker run --rm -v "$PWD/vulnerable-repo:/src" semgrep/semgrep \</a:t>
+            </a:r>
+            <a:endParaRPr lang="en-US" sz="1150" dirty="0"/>
+          </a:p>
+          <a:p>
+            <a:pPr indent="0" marL="0">
+              <a:buNone/>
+            </a:pPr>
+            <a:r>
+              <a:rPr lang="en-US" sz="1150" dirty="0">
+                <a:solidFill>
+                  <a:srgbClr val="9FE7D6"/>
+                </a:solidFill>
+                <a:latin typeface="Courier New" pitchFamily="34" charset="0"/>
+                <a:ea typeface="Courier New" pitchFamily="34" charset="-122"/>
+                <a:cs typeface="Courier New" pitchFamily="34" charset="-120"/>
+              </a:rPr>
+              <a:t>  semgrep --config p/default --config p/owasp-top-ten /src</a:t>
+            </a:r>
+            <a:endParaRPr lang="en-US" sz="1150" dirty="0"/>
+          </a:p>
+          <a:p>
+            <a:pPr indent="0" marL="0">
+              <a:buNone/>
+            </a:pPr>
+            <a:r>
+              <a:rPr lang="en-US" sz="1150" dirty="0">
+                <a:solidFill>
+                  <a:srgbClr val="9FE7D6"/>
+                </a:solidFill>
+                <a:latin typeface="Courier New" pitchFamily="34" charset="0"/>
+                <a:ea typeface="Courier New" pitchFamily="34" charset="-122"/>
+                <a:cs typeface="Courier New" pitchFamily="34" charset="-120"/>
+              </a:rPr>
+              <a:t>docker run --rm -v "$PWD/vulnerable-repo:/repo" zricethezav/gitleaks:latest \</a:t>
+            </a:r>
+            <a:endParaRPr lang="en-US" sz="1150" dirty="0"/>
+          </a:p>
+          <a:p>
+            <a:pPr indent="0" marL="0">
+              <a:buNone/>
+            </a:pPr>
+            <a:r>
+              <a:rPr lang="en-US" sz="1150" dirty="0">
+                <a:solidFill>
+                  <a:srgbClr val="9FE7D6"/>
+                </a:solidFill>
+                <a:latin typeface="Courier New" pitchFamily="34" charset="0"/>
+                <a:ea typeface="Courier New" pitchFamily="34" charset="-122"/>
+                <a:cs typeface="Courier New" pitchFamily="34" charset="-120"/>
+              </a:rPr>
+              <a:t>  detect -s /repo -v --no-git</a:t>
+            </a:r>
+            <a:endParaRPr lang="en-US" sz="1150" dirty="0"/>
+          </a:p>
+        </p:txBody>
+      </p:sp>
+      <p:sp>
+        <p:nvSpPr>
+          <p:cNvPr id="9" name="Text 6"/>
+          <p:cNvSpPr/>
+          <p:nvPr/>
+        </p:nvSpPr>
+        <p:spPr>
+          <a:xfrm>
+            <a:off x="457200" y="4800600"/>
+            <a:ext cx="6949440" cy="274320"/>
+          </a:xfrm>
+          <a:prstGeom prst="rect">
+            <a:avLst/>
+          </a:prstGeom>
+          <a:noFill/>
+          <a:ln/>
+        </p:spPr>
+        <p:txBody>
+          <a:bodyPr wrap="square" lIns="0" tIns="0" rIns="0" bIns="0" rtlCol="0" anchor="ctr"/>
+          <a:lstStyle/>
+          <a:p>
+            <a:pPr indent="0" marL="0">
+              <a:buNone/>
+            </a:pPr>
+            <a:r>
+              <a:rPr lang="en-US" sz="900" dirty="0">
+                <a:solidFill>
+                  <a:srgbClr val="64748B"/>
                 </a:solidFill>
                 <a:latin typeface="Calibri" pitchFamily="34" charset="0"/>
                 <a:ea typeface="Calibri" pitchFamily="34" charset="-122"/>
                 <a:cs typeface="Calibri" pitchFamily="34" charset="-120"/>
               </a:rPr>
-              <a:t>Full fuzz→exploit lab returns in Week 11</a:t>
-            </a:r>
-            <a:endParaRPr lang="en-US" sz="1400" dirty="0"/>
-          </a:p>
-        </p:txBody>
-      </p:sp>
-      <p:sp>
-        <p:nvSpPr>
-          <p:cNvPr id="7" name="Text 4"/>
-          <p:cNvSpPr/>
-          <p:nvPr/>
-        </p:nvSpPr>
-        <p:spPr>
-          <a:xfrm>
-            <a:off x="457200" y="4800600"/>
-            <a:ext cx="6949440" cy="274320"/>
-          </a:xfrm>
-          <a:prstGeom prst="rect">
-            <a:avLst/>
-          </a:prstGeom>
-          <a:noFill/>
-          <a:ln/>
-        </p:spPr>
-        <p:txBody>
-          <a:bodyPr wrap="square" lIns="0" tIns="0" rIns="0" bIns="0" rtlCol="0" anchor="ctr"/>
-          <a:lstStyle/>
-          <a:p>
-            <a:pPr indent="0" marL="0">
-              <a:buNone/>
-            </a:pPr>
-            <a:r>
-              <a:rPr lang="en-US" sz="900" dirty="0">
-                <a:solidFill>
-                  <a:srgbClr val="64748B"/>
-                </a:solidFill>
-                <a:latin typeface="Calibri" pitchFamily="34" charset="0"/>
-                <a:ea typeface="Calibri" pitchFamily="34" charset="-122"/>
-                <a:cs typeface="Calibri" pitchFamily="34" charset="-120"/>
-              </a:rPr>
               <a:t>Software Security · Week 2</a:t>
             </a:r>
             <a:endParaRPr lang="en-US" sz="900" dirty="0"/>
@@ -4408,7 +4422,7 @@
       </p:sp>
       <p:pic>
         <p:nvPicPr>
-          <p:cNvPr id="8" name="Image 1" descr="/Users/pop7/Library/CloudStorage/OneDrive-MonsterConnectCo.,Ltd/Lecture/KOSEN69 - software-security/slides/pptx/assets/logo-small.png">    </p:cNvPr>
+          <p:cNvPr id="10" name="Image 1" descr="/Users/pop7/Library/CloudStorage/OneDrive-MonsterConnectCo.,Ltd/Lecture/KOSEN69 - software-security/slides/pptx/assets/logo-small.png">    </p:cNvPr>
           <p:cNvPicPr>
             <a:picLocks noChangeAspect="1"/>
           </p:cNvPicPr>
@@ -4546,7 +4560,7 @@
                 <a:ea typeface="Arial" pitchFamily="34" charset="-122"/>
                 <a:cs typeface="Arial" pitchFamily="34" charset="-120"/>
               </a:rPr>
-              <a:t>Lab 2 — deliverable</a:t>
+              <a:t>🐝 Mini-game — Fuzzing Race</a:t>
             </a:r>
             <a:endParaRPr lang="en-US" sz="2600" dirty="0"/>
           </a:p>
@@ -4561,74 +4575,11 @@
         <p:spPr>
           <a:xfrm>
             <a:off x="457200" y="1325880"/>
-            <a:ext cx="8229600" cy="822960"/>
+            <a:ext cx="8229600" cy="1207008"/>
           </a:xfrm>
           <a:prstGeom prst="roundRect">
             <a:avLst>
-              <a:gd name="adj" fmla="val 8889"/>
-            </a:avLst>
-          </a:prstGeom>
-          <a:solidFill>
-            <a:srgbClr val="E8EDF3"/>
-          </a:solidFill>
-          <a:ln/>
-        </p:spPr>
-      </p:sp>
-      <p:sp>
-        <p:nvSpPr>
-          <p:cNvPr id="6" name="Text 3"/>
-          <p:cNvSpPr/>
-          <p:nvPr/>
-        </p:nvSpPr>
-        <p:spPr>
-          <a:xfrm>
-            <a:off x="731520" y="1325880"/>
-            <a:ext cx="7680960" cy="822960"/>
-          </a:xfrm>
-          <a:prstGeom prst="rect">
-            <a:avLst/>
-          </a:prstGeom>
-          <a:noFill/>
-          <a:ln/>
-        </p:spPr>
-        <p:txBody>
-          <a:bodyPr wrap="square" lIns="0" tIns="0" rIns="0" bIns="0" rtlCol="0" anchor="ctr">
-            <a:normAutofit/>
-          </a:bodyPr>
-          <a:lstStyle/>
-          <a:p>
-            <a:pPr indent="0" marL="0">
-              <a:buNone/>
-            </a:pPr>
-            <a:r>
-              <a:rPr lang="en-US" sz="1400" i="1" dirty="0">
-                <a:solidFill>
-                  <a:srgbClr val="E35205"/>
-                </a:solidFill>
-                <a:latin typeface="Calibri" pitchFamily="34" charset="0"/>
-                <a:ea typeface="Calibri" pitchFamily="34" charset="-122"/>
-                <a:cs typeface="Calibri" pitchFamily="34" charset="-120"/>
-              </a:rPr>
-              <a:t>📋 Worksheet 2 — labs/week02-sdlc-tooling/worksheet.md (Part 3) · kickoff: bash scan.sh (Semgrep ×2 rulesets + Gitleaks --no-git on ./vulnerable-repo)</a:t>
-            </a:r>
-            <a:endParaRPr lang="en-US" sz="1400" dirty="0"/>
-          </a:p>
-        </p:txBody>
-      </p:sp>
-      <p:sp>
-        <p:nvSpPr>
-          <p:cNvPr id="7" name="Shape 4"/>
-          <p:cNvSpPr/>
-          <p:nvPr/>
-        </p:nvSpPr>
-        <p:spPr>
-          <a:xfrm>
-            <a:off x="457200" y="2313432"/>
-            <a:ext cx="8229600" cy="2029968"/>
-          </a:xfrm>
-          <a:prstGeom prst="roundRect">
-            <a:avLst>
-              <a:gd name="adj" fmla="val 3604"/>
+              <a:gd name="adj" fmla="val 6061"/>
             </a:avLst>
           </a:prstGeom>
           <a:solidFill>
@@ -4646,14 +4597,14 @@
       </p:sp>
       <p:sp>
         <p:nvSpPr>
-          <p:cNvPr id="8" name="Text 5"/>
-          <p:cNvSpPr/>
-          <p:nvPr/>
-        </p:nvSpPr>
-        <p:spPr>
-          <a:xfrm>
-            <a:off x="731520" y="2423160"/>
-            <a:ext cx="7680960" cy="1810512"/>
+          <p:cNvPr id="6" name="Text 3"/>
+          <p:cNvSpPr/>
+          <p:nvPr/>
+        </p:nvSpPr>
+        <p:spPr>
+          <a:xfrm>
+            <a:off x="731520" y="1435608"/>
+            <a:ext cx="7680960" cy="987552"/>
           </a:xfrm>
           <a:prstGeom prst="rect">
             <a:avLst/>
@@ -4683,7 +4634,7 @@
                 <a:ea typeface="Calibri" pitchFamily="34" charset="-122"/>
                 <a:cs typeface="Calibri" pitchFamily="34" charset="-120"/>
               </a:rPr>
-              <a:t>A findings triage table: tool, CWE, severity, TP/FP, fix idea (3 TP + 1 FP, justified)</a:t>
+              <a:t>First team to make the provided target crash wins</a:t>
             </a:r>
             <a:endParaRPr lang="en-US" sz="1400" dirty="0"/>
           </a:p>
@@ -4704,7 +4655,7 @@
                 <a:ea typeface="Calibri" pitchFamily="34" charset="-122"/>
                 <a:cs typeface="Calibri" pitchFamily="34" charset="-120"/>
               </a:rPr>
-              <a:t>1 fuzzing crash with a one-line root cause</a:t>
+              <a:t>One crash → one root-cause note</a:t>
             </a:r>
             <a:endParaRPr lang="en-US" sz="1400" dirty="0"/>
           </a:p>
@@ -4725,87 +4676,45 @@
                 <a:ea typeface="Calibri" pitchFamily="34" charset="-122"/>
                 <a:cs typeface="Calibri" pitchFamily="34" charset="-120"/>
               </a:rPr>
-              <a:t>Trivy SCA scan of the NoteVault project target</a:t>
+              <a:t>Full fuzz→exploit lab returns in Week 11</a:t>
             </a:r>
             <a:endParaRPr lang="en-US" sz="1400" dirty="0"/>
           </a:p>
-          <a:p>
-            <a:pPr marL="342900" indent="-342900">
-              <a:spcAft>
-                <a:spcPts val="600"/>
-              </a:spcAft>
-              <a:buSzPct val="100000"/>
-              <a:buChar char="•"/>
-            </a:pPr>
-            <a:r>
-              <a:rPr lang="en-US" sz="1400" dirty="0">
-                <a:solidFill>
-                  <a:srgbClr val="1F2937"/>
+        </p:txBody>
+      </p:sp>
+      <p:sp>
+        <p:nvSpPr>
+          <p:cNvPr id="7" name="Text 4"/>
+          <p:cNvSpPr/>
+          <p:nvPr/>
+        </p:nvSpPr>
+        <p:spPr>
+          <a:xfrm>
+            <a:off x="457200" y="4800600"/>
+            <a:ext cx="6949440" cy="274320"/>
+          </a:xfrm>
+          <a:prstGeom prst="rect">
+            <a:avLst/>
+          </a:prstGeom>
+          <a:noFill/>
+          <a:ln/>
+        </p:spPr>
+        <p:txBody>
+          <a:bodyPr wrap="square" lIns="0" tIns="0" rIns="0" bIns="0" rtlCol="0" anchor="ctr"/>
+          <a:lstStyle/>
+          <a:p>
+            <a:pPr indent="0" marL="0">
+              <a:buNone/>
+            </a:pPr>
+            <a:r>
+              <a:rPr lang="en-US" sz="900" dirty="0">
+                <a:solidFill>
+                  <a:srgbClr val="64748B"/>
                 </a:solidFill>
                 <a:latin typeface="Calibri" pitchFamily="34" charset="0"/>
                 <a:ea typeface="Calibri" pitchFamily="34" charset="-122"/>
                 <a:cs typeface="Calibri" pitchFamily="34" charset="-120"/>
               </a:rPr>
-              <a:t>A security CI gate built from Week 15's security-ci.yml</a:t>
-            </a:r>
-            <a:endParaRPr lang="en-US" sz="1400" dirty="0"/>
-          </a:p>
-          <a:p>
-            <a:pPr marL="342900" indent="-342900">
-              <a:spcAft>
-                <a:spcPts val="600"/>
-              </a:spcAft>
-              <a:buSzPct val="100000"/>
-              <a:buChar char="•"/>
-            </a:pPr>
-            <a:r>
-              <a:rPr lang="en-US" sz="1400" dirty="0">
-                <a:solidFill>
-                  <a:srgbClr val="1F2937"/>
-                </a:solidFill>
-                <a:latin typeface="Calibri" pitchFamily="34" charset="0"/>
-                <a:ea typeface="Calibri" pitchFamily="34" charset="-122"/>
-                <a:cs typeface="Calibri" pitchFamily="34" charset="-120"/>
-              </a:rPr>
-              <a:t>One SAST blind spot you found by hand</a:t>
-            </a:r>
-            <a:endParaRPr lang="en-US" sz="1400" dirty="0"/>
-          </a:p>
-        </p:txBody>
-      </p:sp>
-      <p:sp>
-        <p:nvSpPr>
-          <p:cNvPr id="9" name="Text 6"/>
-          <p:cNvSpPr/>
-          <p:nvPr/>
-        </p:nvSpPr>
-        <p:spPr>
-          <a:xfrm>
-            <a:off x="457200" y="4800600"/>
-            <a:ext cx="6949440" cy="274320"/>
-          </a:xfrm>
-          <a:prstGeom prst="rect">
-            <a:avLst/>
-          </a:prstGeom>
-          <a:noFill/>
-          <a:ln/>
-        </p:spPr>
-        <p:txBody>
-          <a:bodyPr wrap="square" lIns="0" tIns="0" rIns="0" bIns="0" rtlCol="0" anchor="ctr"/>
-          <a:lstStyle/>
-          <a:p>
-            <a:pPr indent="0" marL="0">
-              <a:buNone/>
-            </a:pPr>
-            <a:r>
-              <a:rPr lang="en-US" sz="900" dirty="0">
-                <a:solidFill>
-                  <a:srgbClr val="64748B"/>
-                </a:solidFill>
-                <a:latin typeface="Calibri" pitchFamily="34" charset="0"/>
-                <a:ea typeface="Calibri" pitchFamily="34" charset="-122"/>
-                <a:cs typeface="Calibri" pitchFamily="34" charset="-120"/>
-              </a:rPr>
               <a:t>Software Security · Week 2</a:t>
             </a:r>
             <a:endParaRPr lang="en-US" sz="900" dirty="0"/>
@@ -4814,7 +4723,7 @@
       </p:sp>
       <p:pic>
         <p:nvPicPr>
-          <p:cNvPr id="10" name="Image 1" descr="/Users/pop7/Library/CloudStorage/OneDrive-MonsterConnectCo.,Ltd/Lecture/KOSEN69 - software-security/slides/pptx/assets/logo-small.png">    </p:cNvPr>
+          <p:cNvPr id="8" name="Image 1" descr="/Users/pop7/Library/CloudStorage/OneDrive-MonsterConnectCo.,Ltd/Lecture/KOSEN69 - software-security/slides/pptx/assets/logo-small.png">    </p:cNvPr>
           <p:cNvPicPr>
             <a:picLocks noChangeAspect="1"/>
           </p:cNvPicPr>
@@ -4952,7 +4861,7 @@
                 <a:ea typeface="Arial" pitchFamily="34" charset="-122"/>
                 <a:cs typeface="Arial" pitchFamily="34" charset="-120"/>
               </a:rPr>
-              <a:t>Lab 2 — deliverable (cont.)</a:t>
+              <a:t>Lab 2 — deliverable</a:t>
             </a:r>
             <a:endParaRPr lang="en-US" sz="2600" dirty="0"/>
           </a:p>
@@ -4967,11 +4876,74 @@
         <p:spPr>
           <a:xfrm>
             <a:off x="457200" y="1325880"/>
-            <a:ext cx="8229600" cy="1097280"/>
+            <a:ext cx="8229600" cy="822960"/>
           </a:xfrm>
           <a:prstGeom prst="roundRect">
             <a:avLst>
-              <a:gd name="adj" fmla="val 6667"/>
+              <a:gd name="adj" fmla="val 8889"/>
+            </a:avLst>
+          </a:prstGeom>
+          <a:solidFill>
+            <a:srgbClr val="E8EDF3"/>
+          </a:solidFill>
+          <a:ln/>
+        </p:spPr>
+      </p:sp>
+      <p:sp>
+        <p:nvSpPr>
+          <p:cNvPr id="6" name="Text 3"/>
+          <p:cNvSpPr/>
+          <p:nvPr/>
+        </p:nvSpPr>
+        <p:spPr>
+          <a:xfrm>
+            <a:off x="731520" y="1325880"/>
+            <a:ext cx="7680960" cy="822960"/>
+          </a:xfrm>
+          <a:prstGeom prst="rect">
+            <a:avLst/>
+          </a:prstGeom>
+          <a:noFill/>
+          <a:ln/>
+        </p:spPr>
+        <p:txBody>
+          <a:bodyPr wrap="square" lIns="0" tIns="0" rIns="0" bIns="0" rtlCol="0" anchor="ctr">
+            <a:normAutofit/>
+          </a:bodyPr>
+          <a:lstStyle/>
+          <a:p>
+            <a:pPr indent="0" marL="0">
+              <a:buNone/>
+            </a:pPr>
+            <a:r>
+              <a:rPr lang="en-US" sz="1400" i="1" dirty="0">
+                <a:solidFill>
+                  <a:srgbClr val="E35205"/>
+                </a:solidFill>
+                <a:latin typeface="Calibri" pitchFamily="34" charset="0"/>
+                <a:ea typeface="Calibri" pitchFamily="34" charset="-122"/>
+                <a:cs typeface="Calibri" pitchFamily="34" charset="-120"/>
+              </a:rPr>
+              <a:t>📋 Worksheet 2 — labs/week02-sdlc-tooling/worksheet.md (Part 3) · kickoff: bash scan.sh (Semgrep ×2 rulesets + Gitleaks --no-git on ./vulnerable-repo)</a:t>
+            </a:r>
+            <a:endParaRPr lang="en-US" sz="1400" dirty="0"/>
+          </a:p>
+        </p:txBody>
+      </p:sp>
+      <p:sp>
+        <p:nvSpPr>
+          <p:cNvPr id="7" name="Shape 4"/>
+          <p:cNvSpPr/>
+          <p:nvPr/>
+        </p:nvSpPr>
+        <p:spPr>
+          <a:xfrm>
+            <a:off x="457200" y="2313432"/>
+            <a:ext cx="8229600" cy="2029968"/>
+          </a:xfrm>
+          <a:prstGeom prst="roundRect">
+            <a:avLst>
+              <a:gd name="adj" fmla="val 3604"/>
             </a:avLst>
           </a:prstGeom>
           <a:solidFill>
@@ -4989,14 +4961,14 @@
       </p:sp>
       <p:sp>
         <p:nvSpPr>
-          <p:cNvPr id="6" name="Text 3"/>
-          <p:cNvSpPr/>
-          <p:nvPr/>
-        </p:nvSpPr>
-        <p:spPr>
-          <a:xfrm>
-            <a:off x="731520" y="1435608"/>
-            <a:ext cx="7680960" cy="877824"/>
+          <p:cNvPr id="8" name="Text 5"/>
+          <p:cNvSpPr/>
+          <p:nvPr/>
+        </p:nvSpPr>
+        <p:spPr>
+          <a:xfrm>
+            <a:off x="731520" y="2423160"/>
+            <a:ext cx="7680960" cy="1810512"/>
           </a:xfrm>
           <a:prstGeom prst="rect">
             <a:avLst/>
@@ -5026,7 +4998,7 @@
                 <a:ea typeface="Calibri" pitchFamily="34" charset="-122"/>
                 <a:cs typeface="Calibri" pitchFamily="34" charset="-120"/>
               </a:rPr>
-              <a:t>Defend/fix: remediate all 5 planted flaws, before/after diff — this alone is 25 of 100 rubric points</a:t>
+              <a:t>A findings triage table: tool, CWE, severity, TP/FP, fix idea (3 TP + 1 FP, justified)</a:t>
             </a:r>
             <a:endParaRPr lang="en-US" sz="1400" dirty="0"/>
           </a:p>
@@ -5047,45 +5019,108 @@
                 <a:ea typeface="Calibri" pitchFamily="34" charset="-122"/>
                 <a:cs typeface="Calibri" pitchFamily="34" charset="-120"/>
               </a:rPr>
-              <a:t>+ Audit the AI and EiPE / Prompt Problem (see worksheet)</a:t>
+              <a:t>1 fuzzing crash with a one-line root cause</a:t>
             </a:r>
             <a:endParaRPr lang="en-US" sz="1400" dirty="0"/>
           </a:p>
-        </p:txBody>
-      </p:sp>
-      <p:sp>
-        <p:nvSpPr>
-          <p:cNvPr id="7" name="Text 4"/>
-          <p:cNvSpPr/>
-          <p:nvPr/>
-        </p:nvSpPr>
-        <p:spPr>
-          <a:xfrm>
-            <a:off x="457200" y="4800600"/>
-            <a:ext cx="6949440" cy="274320"/>
-          </a:xfrm>
-          <a:prstGeom prst="rect">
-            <a:avLst/>
-          </a:prstGeom>
-          <a:noFill/>
-          <a:ln/>
-        </p:spPr>
-        <p:txBody>
-          <a:bodyPr wrap="square" lIns="0" tIns="0" rIns="0" bIns="0" rtlCol="0" anchor="ctr"/>
-          <a:lstStyle/>
-          <a:p>
-            <a:pPr indent="0" marL="0">
-              <a:buNone/>
-            </a:pPr>
-            <a:r>
-              <a:rPr lang="en-US" sz="900" dirty="0">
-                <a:solidFill>
-                  <a:srgbClr val="64748B"/>
+          <a:p>
+            <a:pPr marL="342900" indent="-342900">
+              <a:spcAft>
+                <a:spcPts val="600"/>
+              </a:spcAft>
+              <a:buSzPct val="100000"/>
+              <a:buChar char="•"/>
+            </a:pPr>
+            <a:r>
+              <a:rPr lang="en-US" sz="1400" dirty="0">
+                <a:solidFill>
+                  <a:srgbClr val="1F2937"/>
                 </a:solidFill>
                 <a:latin typeface="Calibri" pitchFamily="34" charset="0"/>
                 <a:ea typeface="Calibri" pitchFamily="34" charset="-122"/>
                 <a:cs typeface="Calibri" pitchFamily="34" charset="-120"/>
               </a:rPr>
+              <a:t>Trivy SCA scan of the NoteVault project target</a:t>
+            </a:r>
+            <a:endParaRPr lang="en-US" sz="1400" dirty="0"/>
+          </a:p>
+          <a:p>
+            <a:pPr marL="342900" indent="-342900">
+              <a:spcAft>
+                <a:spcPts val="600"/>
+              </a:spcAft>
+              <a:buSzPct val="100000"/>
+              <a:buChar char="•"/>
+            </a:pPr>
+            <a:r>
+              <a:rPr lang="en-US" sz="1400" dirty="0">
+                <a:solidFill>
+                  <a:srgbClr val="1F2937"/>
+                </a:solidFill>
+                <a:latin typeface="Calibri" pitchFamily="34" charset="0"/>
+                <a:ea typeface="Calibri" pitchFamily="34" charset="-122"/>
+                <a:cs typeface="Calibri" pitchFamily="34" charset="-120"/>
+              </a:rPr>
+              <a:t>A security CI gate built from Week 15's security-ci.yml</a:t>
+            </a:r>
+            <a:endParaRPr lang="en-US" sz="1400" dirty="0"/>
+          </a:p>
+          <a:p>
+            <a:pPr marL="342900" indent="-342900">
+              <a:spcAft>
+                <a:spcPts val="600"/>
+              </a:spcAft>
+              <a:buSzPct val="100000"/>
+              <a:buChar char="•"/>
+            </a:pPr>
+            <a:r>
+              <a:rPr lang="en-US" sz="1400" dirty="0">
+                <a:solidFill>
+                  <a:srgbClr val="1F2937"/>
+                </a:solidFill>
+                <a:latin typeface="Calibri" pitchFamily="34" charset="0"/>
+                <a:ea typeface="Calibri" pitchFamily="34" charset="-122"/>
+                <a:cs typeface="Calibri" pitchFamily="34" charset="-120"/>
+              </a:rPr>
+              <a:t>One SAST blind spot you found by hand</a:t>
+            </a:r>
+            <a:endParaRPr lang="en-US" sz="1400" dirty="0"/>
+          </a:p>
+        </p:txBody>
+      </p:sp>
+      <p:sp>
+        <p:nvSpPr>
+          <p:cNvPr id="9" name="Text 6"/>
+          <p:cNvSpPr/>
+          <p:nvPr/>
+        </p:nvSpPr>
+        <p:spPr>
+          <a:xfrm>
+            <a:off x="457200" y="4800600"/>
+            <a:ext cx="6949440" cy="274320"/>
+          </a:xfrm>
+          <a:prstGeom prst="rect">
+            <a:avLst/>
+          </a:prstGeom>
+          <a:noFill/>
+          <a:ln/>
+        </p:spPr>
+        <p:txBody>
+          <a:bodyPr wrap="square" lIns="0" tIns="0" rIns="0" bIns="0" rtlCol="0" anchor="ctr"/>
+          <a:lstStyle/>
+          <a:p>
+            <a:pPr indent="0" marL="0">
+              <a:buNone/>
+            </a:pPr>
+            <a:r>
+              <a:rPr lang="en-US" sz="900" dirty="0">
+                <a:solidFill>
+                  <a:srgbClr val="64748B"/>
+                </a:solidFill>
+                <a:latin typeface="Calibri" pitchFamily="34" charset="0"/>
+                <a:ea typeface="Calibri" pitchFamily="34" charset="-122"/>
+                <a:cs typeface="Calibri" pitchFamily="34" charset="-120"/>
+              </a:rPr>
               <a:t>Software Security · Week 2</a:t>
             </a:r>
             <a:endParaRPr lang="en-US" sz="900" dirty="0"/>
@@ -5094,7 +5129,7 @@
       </p:sp>
       <p:pic>
         <p:nvPicPr>
-          <p:cNvPr id="8" name="Image 1" descr="/Users/pop7/Library/CloudStorage/OneDrive-MonsterConnectCo.,Ltd/Lecture/KOSEN69 - software-security/slides/pptx/assets/logo-small.png">    </p:cNvPr>
+          <p:cNvPr id="10" name="Image 1" descr="/Users/pop7/Library/CloudStorage/OneDrive-MonsterConnectCo.,Ltd/Lecture/KOSEN69 - software-security/slides/pptx/assets/logo-small.png">    </p:cNvPr>
           <p:cNvPicPr>
             <a:picLocks noChangeAspect="1"/>
           </p:cNvPicPr>
@@ -5232,7 +5267,7 @@
                 <a:ea typeface="Arial" pitchFamily="34" charset="-122"/>
                 <a:cs typeface="Arial" pitchFamily="34" charset="-120"/>
               </a:rPr>
-              <a:t>Key takeaways</a:t>
+              <a:t>Lab 2 — deliverable (cont.)</a:t>
             </a:r>
             <a:endParaRPr lang="en-US" sz="2600" dirty="0"/>
           </a:p>
@@ -5247,11 +5282,11 @@
         <p:spPr>
           <a:xfrm>
             <a:off x="457200" y="1325880"/>
-            <a:ext cx="8229600" cy="1207008"/>
+            <a:ext cx="8229600" cy="1097280"/>
           </a:xfrm>
           <a:prstGeom prst="roundRect">
             <a:avLst>
-              <a:gd name="adj" fmla="val 6061"/>
+              <a:gd name="adj" fmla="val 6667"/>
             </a:avLst>
           </a:prstGeom>
           <a:solidFill>
@@ -5276,7 +5311,7 @@
         <p:spPr>
           <a:xfrm>
             <a:off x="731520" y="1435608"/>
-            <a:ext cx="7680960" cy="987552"/>
+            <a:ext cx="7680960" cy="877824"/>
           </a:xfrm>
           <a:prstGeom prst="rect">
             <a:avLst/>
@@ -5306,7 +5341,7 @@
                 <a:ea typeface="Calibri" pitchFamily="34" charset="-122"/>
                 <a:cs typeface="Calibri" pitchFamily="34" charset="-120"/>
               </a:rPr>
-              <a:t>No single tool finds everything — layer SAST/DAST/SCA/fuzzing</a:t>
+              <a:t>Defend/fix: remediate all 5 planted flaws, before/after diff — this alone is 25 of 100 rubric points</a:t>
             </a:r>
             <a:endParaRPr lang="en-US" sz="1400" dirty="0"/>
           </a:p>
@@ -5327,28 +5362,7 @@
                 <a:ea typeface="Calibri" pitchFamily="34" charset="-122"/>
                 <a:cs typeface="Calibri" pitchFamily="34" charset="-120"/>
               </a:rPr>
-              <a:t>Triage by CWE + severity; kill the noise</a:t>
-            </a:r>
-            <a:endParaRPr lang="en-US" sz="1400" dirty="0"/>
-          </a:p>
-          <a:p>
-            <a:pPr marL="342900" indent="-342900">
-              <a:spcAft>
-                <a:spcPts val="600"/>
-              </a:spcAft>
-              <a:buSzPct val="100000"/>
-              <a:buChar char="•"/>
-            </a:pPr>
-            <a:r>
-              <a:rPr lang="en-US" sz="1400" dirty="0">
-                <a:solidFill>
-                  <a:srgbClr val="1F2937"/>
-                </a:solidFill>
-                <a:latin typeface="Calibri" pitchFamily="34" charset="0"/>
-                <a:ea typeface="Calibri" pitchFamily="34" charset="-122"/>
-                <a:cs typeface="Calibri" pitchFamily="34" charset="-120"/>
-              </a:rPr>
-              <a:t>Fuzzing is the highest-yield bug finder — automate it</a:t>
+              <a:t>+ Audit the AI and EiPE / Prompt Problem (see worksheet)</a:t>
             </a:r>
             <a:endParaRPr lang="en-US" sz="1400" dirty="0"/>
           </a:p>
@@ -5451,14 +5465,65 @@
       </p:grpSpPr>
       <p:sp>
         <p:nvSpPr>
-          <p:cNvPr id="2" name="Text 0"/>
-          <p:cNvSpPr/>
-          <p:nvPr/>
-        </p:nvSpPr>
-        <p:spPr>
-          <a:xfrm>
-            <a:off x="640080" y="1737360"/>
-            <a:ext cx="7863840" cy="1097280"/>
+          <p:cNvPr id="2" name="Shape 0"/>
+          <p:cNvSpPr/>
+          <p:nvPr/>
+        </p:nvSpPr>
+        <p:spPr>
+          <a:xfrm>
+            <a:off x="457200" y="384048"/>
+            <a:ext cx="530352" cy="530352"/>
+          </a:xfrm>
+          <a:prstGeom prst="ellipse">
+            <a:avLst/>
+          </a:prstGeom>
+          <a:solidFill>
+            <a:srgbClr val="E35205"/>
+          </a:solidFill>
+          <a:ln/>
+          <a:effectLst>
+            <a:outerShdw sx="100000" sy="100000" kx="0" ky="0" algn="bl" rotWithShape="0" blurRad="76200" dist="25400" dir="5400000">
+              <a:srgbClr val="000000">
+                <a:alpha val="12000"/>
+              </a:srgbClr>
+            </a:outerShdw>
+          </a:effectLst>
+        </p:spPr>
+      </p:sp>
+      <p:pic>
+        <p:nvPicPr>
+          <p:cNvPr id="3" name="Image 0" descr="preencoded.png">    </p:cNvPr>
+          <p:cNvPicPr>
+            <a:picLocks noChangeAspect="1"/>
+          </p:cNvPicPr>
+          <p:nvPr/>
+        </p:nvPicPr>
+        <p:blipFill>
+          <a:blip r:embed="rId1"/>
+          <a:stretch>
+            <a:fillRect/>
+          </a:stretch>
+        </p:blipFill>
+        <p:spPr>
+          <a:xfrm>
+            <a:off x="594360" y="521208"/>
+            <a:ext cx="256032" cy="256032"/>
+          </a:xfrm>
+          <a:prstGeom prst="rect">
+            <a:avLst/>
+          </a:prstGeom>
+        </p:spPr>
+      </p:pic>
+      <p:sp>
+        <p:nvSpPr>
+          <p:cNvPr id="4" name="Text 1"/>
+          <p:cNvSpPr/>
+          <p:nvPr/>
+        </p:nvSpPr>
+        <p:spPr>
+          <a:xfrm>
+            <a:off x="1143000" y="329184"/>
+            <a:ext cx="7498080" cy="603504"/>
           </a:xfrm>
           <a:prstGeom prst="rect">
             <a:avLst/>
@@ -5474,7 +5539,7 @@
               <a:buNone/>
             </a:pPr>
             <a:r>
-              <a:rPr lang="en-US" sz="4600" b="1" dirty="0">
+              <a:rPr lang="en-US" sz="2600" b="1" dirty="0">
                 <a:solidFill>
                   <a:srgbClr val="1F2937"/>
                 </a:solidFill>
@@ -5482,22 +5547,51 @@
                 <a:ea typeface="Arial" pitchFamily="34" charset="-122"/>
                 <a:cs typeface="Arial" pitchFamily="34" charset="-120"/>
               </a:rPr>
-              <a:t>Questions?</a:t>
-            </a:r>
-            <a:endParaRPr lang="en-US" sz="4600" dirty="0"/>
-          </a:p>
-        </p:txBody>
-      </p:sp>
-      <p:sp>
-        <p:nvSpPr>
-          <p:cNvPr id="3" name="Text 1"/>
-          <p:cNvSpPr/>
-          <p:nvPr/>
-        </p:nvSpPr>
-        <p:spPr>
-          <a:xfrm>
-            <a:off x="658368" y="2834640"/>
-            <a:ext cx="7863840" cy="731520"/>
+              <a:t>Key takeaways</a:t>
+            </a:r>
+            <a:endParaRPr lang="en-US" sz="2600" dirty="0"/>
+          </a:p>
+        </p:txBody>
+      </p:sp>
+      <p:sp>
+        <p:nvSpPr>
+          <p:cNvPr id="5" name="Shape 2"/>
+          <p:cNvSpPr/>
+          <p:nvPr/>
+        </p:nvSpPr>
+        <p:spPr>
+          <a:xfrm>
+            <a:off x="457200" y="1325880"/>
+            <a:ext cx="8229600" cy="1207008"/>
+          </a:xfrm>
+          <a:prstGeom prst="roundRect">
+            <a:avLst>
+              <a:gd name="adj" fmla="val 6061"/>
+            </a:avLst>
+          </a:prstGeom>
+          <a:solidFill>
+            <a:srgbClr val="F1F5F9"/>
+          </a:solidFill>
+          <a:ln/>
+          <a:effectLst>
+            <a:outerShdw sx="100000" sy="100000" kx="0" ky="0" algn="bl" rotWithShape="0" blurRad="76200" dist="25400" dir="5400000">
+              <a:srgbClr val="000000">
+                <a:alpha val="12000"/>
+              </a:srgbClr>
+            </a:outerShdw>
+          </a:effectLst>
+        </p:spPr>
+      </p:sp>
+      <p:sp>
+        <p:nvSpPr>
+          <p:cNvPr id="6" name="Text 3"/>
+          <p:cNvSpPr/>
+          <p:nvPr/>
+        </p:nvSpPr>
+        <p:spPr>
+          <a:xfrm>
+            <a:off x="731520" y="1435608"/>
+            <a:ext cx="7680960" cy="987552"/>
           </a:xfrm>
           <a:prstGeom prst="rect">
             <a:avLst/>
@@ -5506,37 +5600,124 @@
           <a:ln/>
         </p:spPr>
         <p:txBody>
-          <a:bodyPr wrap="square" lIns="0" tIns="0" rIns="0" bIns="0" rtlCol="0" anchor="ctr"/>
-          <a:lstStyle/>
-          <a:p>
-            <a:pPr indent="0" marL="0">
-              <a:buNone/>
-            </a:pPr>
-            <a:r>
-              <a:rPr lang="en-US" sz="1800" dirty="0">
-                <a:solidFill>
-                  <a:srgbClr val="E35205"/>
+          <a:bodyPr wrap="square" lIns="0" tIns="0" rIns="0" bIns="0" rtlCol="0" anchor="t">
+            <a:normAutofit/>
+          </a:bodyPr>
+          <a:lstStyle/>
+          <a:p>
+            <a:pPr marL="342900" indent="-342900">
+              <a:spcAft>
+                <a:spcPts val="600"/>
+              </a:spcAft>
+              <a:buSzPct val="100000"/>
+              <a:buChar char="•"/>
+            </a:pPr>
+            <a:r>
+              <a:rPr lang="en-US" sz="1400" dirty="0">
+                <a:solidFill>
+                  <a:srgbClr val="1F2937"/>
                 </a:solidFill>
                 <a:latin typeface="Calibri" pitchFamily="34" charset="0"/>
                 <a:ea typeface="Calibri" pitchFamily="34" charset="-122"/>
                 <a:cs typeface="Calibri" pitchFamily="34" charset="-120"/>
               </a:rPr>
-              <a:t>Next week: Cryptography used correctly</a:t>
-            </a:r>
-            <a:endParaRPr lang="en-US" sz="1800" dirty="0"/>
+              <a:t>No single tool finds everything — layer SAST/DAST/SCA/fuzzing</a:t>
+            </a:r>
+            <a:endParaRPr lang="en-US" sz="1400" dirty="0"/>
+          </a:p>
+          <a:p>
+            <a:pPr marL="342900" indent="-342900">
+              <a:spcAft>
+                <a:spcPts val="600"/>
+              </a:spcAft>
+              <a:buSzPct val="100000"/>
+              <a:buChar char="•"/>
+            </a:pPr>
+            <a:r>
+              <a:rPr lang="en-US" sz="1400" dirty="0">
+                <a:solidFill>
+                  <a:srgbClr val="1F2937"/>
+                </a:solidFill>
+                <a:latin typeface="Calibri" pitchFamily="34" charset="0"/>
+                <a:ea typeface="Calibri" pitchFamily="34" charset="-122"/>
+                <a:cs typeface="Calibri" pitchFamily="34" charset="-120"/>
+              </a:rPr>
+              <a:t>Triage by CWE + severity; kill the noise</a:t>
+            </a:r>
+            <a:endParaRPr lang="en-US" sz="1400" dirty="0"/>
+          </a:p>
+          <a:p>
+            <a:pPr marL="342900" indent="-342900">
+              <a:spcAft>
+                <a:spcPts val="600"/>
+              </a:spcAft>
+              <a:buSzPct val="100000"/>
+              <a:buChar char="•"/>
+            </a:pPr>
+            <a:r>
+              <a:rPr lang="en-US" sz="1400" dirty="0">
+                <a:solidFill>
+                  <a:srgbClr val="1F2937"/>
+                </a:solidFill>
+                <a:latin typeface="Calibri" pitchFamily="34" charset="0"/>
+                <a:ea typeface="Calibri" pitchFamily="34" charset="-122"/>
+                <a:cs typeface="Calibri" pitchFamily="34" charset="-120"/>
+              </a:rPr>
+              <a:t>Fuzzing is the highest-yield bug finder — automate it</a:t>
+            </a:r>
+            <a:endParaRPr lang="en-US" sz="1400" dirty="0"/>
+          </a:p>
+        </p:txBody>
+      </p:sp>
+      <p:sp>
+        <p:nvSpPr>
+          <p:cNvPr id="7" name="Text 4"/>
+          <p:cNvSpPr/>
+          <p:nvPr/>
+        </p:nvSpPr>
+        <p:spPr>
+          <a:xfrm>
+            <a:off x="457200" y="4800600"/>
+            <a:ext cx="6949440" cy="274320"/>
+          </a:xfrm>
+          <a:prstGeom prst="rect">
+            <a:avLst/>
+          </a:prstGeom>
+          <a:noFill/>
+          <a:ln/>
+        </p:spPr>
+        <p:txBody>
+          <a:bodyPr wrap="square" lIns="0" tIns="0" rIns="0" bIns="0" rtlCol="0" anchor="ctr"/>
+          <a:lstStyle/>
+          <a:p>
+            <a:pPr indent="0" marL="0">
+              <a:buNone/>
+            </a:pPr>
+            <a:r>
+              <a:rPr lang="en-US" sz="900" dirty="0">
+                <a:solidFill>
+                  <a:srgbClr val="64748B"/>
+                </a:solidFill>
+                <a:latin typeface="Calibri" pitchFamily="34" charset="0"/>
+                <a:ea typeface="Calibri" pitchFamily="34" charset="-122"/>
+                <a:cs typeface="Calibri" pitchFamily="34" charset="-120"/>
+              </a:rPr>
+              <a:t>Software Security · Week 2</a:t>
+            </a:r>
+            <a:endParaRPr lang="en-US" sz="900" dirty="0"/>
           </a:p>
         </p:txBody>
       </p:sp>
       <p:pic>
         <p:nvPicPr>
-          <p:cNvPr id="4" name="Image 0" descr="/Users/pop7/Library/CloudStorage/OneDrive-MonsterConnectCo.,Ltd/Lecture/KOSEN69 - software-security/slides/pptx/assets/logo-small.png">    </p:cNvPr>
+          <p:cNvPr id="8" name="Image 1" descr="/Users/pop7/Library/CloudStorage/OneDrive-MonsterConnectCo.,Ltd/Lecture/KOSEN69 - software-security/slides/pptx/assets/logo-small.png">    </p:cNvPr>
           <p:cNvPicPr>
             <a:picLocks noChangeAspect="1"/>
           </p:cNvPicPr>
           <p:nvPr/>
         </p:nvPicPr>
         <p:blipFill>
-          <a:blip r:embed="rId1"/>
+          <a:blip r:embed="rId2"/>
           <a:stretch>
             <a:fillRect/>
           </a:stretch>
@@ -5859,6 +6040,140 @@
         </p:nvPicPr>
         <p:blipFill>
           <a:blip r:embed="rId2"/>
+          <a:stretch>
+            <a:fillRect/>
+          </a:stretch>
+        </p:blipFill>
+        <p:spPr>
+          <a:xfrm>
+            <a:off x="7882128" y="4700016"/>
+            <a:ext cx="768096" cy="356616"/>
+          </a:xfrm>
+          <a:prstGeom prst="rect">
+            <a:avLst/>
+          </a:prstGeom>
+        </p:spPr>
+      </p:pic>
+    </p:spTree>
+  </p:cSld>
+  <p:clrMapOvr>
+    <a:masterClrMapping/>
+  </p:clrMapOvr>
+</p:sld>
+</file>
+
+<file path=ppt/slides/slide20.xml><?xml version="1.0" encoding="utf-8"?>
+<p:sld xmlns:a="http://schemas.openxmlformats.org/drawingml/2006/main" xmlns:r="http://schemas.openxmlformats.org/officeDocument/2006/relationships" xmlns:p="http://schemas.openxmlformats.org/presentationml/2006/main">
+  <p:cSld name="Slide 20">
+    <p:bg>
+      <p:bgPr>
+        <a:solidFill>
+          <a:srgbClr val="FFFFFF"/>
+        </a:solidFill>
+      </p:bgPr>
+    </p:bg>
+    <p:spTree>
+      <p:nvGrpSpPr>
+        <p:cNvPr id="1" name=""/>
+        <p:cNvGrpSpPr/>
+        <p:nvPr/>
+      </p:nvGrpSpPr>
+      <p:grpSpPr>
+        <a:xfrm>
+          <a:off x="0" y="0"/>
+          <a:ext cx="0" cy="0"/>
+          <a:chOff x="0" y="0"/>
+          <a:chExt cx="0" cy="0"/>
+        </a:xfrm>
+      </p:grpSpPr>
+      <p:sp>
+        <p:nvSpPr>
+          <p:cNvPr id="2" name="Text 0"/>
+          <p:cNvSpPr/>
+          <p:nvPr/>
+        </p:nvSpPr>
+        <p:spPr>
+          <a:xfrm>
+            <a:off x="640080" y="1737360"/>
+            <a:ext cx="7863840" cy="1097280"/>
+          </a:xfrm>
+          <a:prstGeom prst="rect">
+            <a:avLst/>
+          </a:prstGeom>
+          <a:noFill/>
+          <a:ln/>
+        </p:spPr>
+        <p:txBody>
+          <a:bodyPr wrap="square" lIns="0" tIns="0" rIns="0" bIns="0" rtlCol="0" anchor="ctr"/>
+          <a:lstStyle/>
+          <a:p>
+            <a:pPr indent="0" marL="0">
+              <a:buNone/>
+            </a:pPr>
+            <a:r>
+              <a:rPr lang="en-US" sz="4600" b="1" dirty="0">
+                <a:solidFill>
+                  <a:srgbClr val="1F2937"/>
+                </a:solidFill>
+                <a:latin typeface="Arial" pitchFamily="34" charset="0"/>
+                <a:ea typeface="Arial" pitchFamily="34" charset="-122"/>
+                <a:cs typeface="Arial" pitchFamily="34" charset="-120"/>
+              </a:rPr>
+              <a:t>Questions?</a:t>
+            </a:r>
+            <a:endParaRPr lang="en-US" sz="4600" dirty="0"/>
+          </a:p>
+        </p:txBody>
+      </p:sp>
+      <p:sp>
+        <p:nvSpPr>
+          <p:cNvPr id="3" name="Text 1"/>
+          <p:cNvSpPr/>
+          <p:nvPr/>
+        </p:nvSpPr>
+        <p:spPr>
+          <a:xfrm>
+            <a:off x="658368" y="2834640"/>
+            <a:ext cx="7863840" cy="731520"/>
+          </a:xfrm>
+          <a:prstGeom prst="rect">
+            <a:avLst/>
+          </a:prstGeom>
+          <a:noFill/>
+          <a:ln/>
+        </p:spPr>
+        <p:txBody>
+          <a:bodyPr wrap="square" lIns="0" tIns="0" rIns="0" bIns="0" rtlCol="0" anchor="ctr"/>
+          <a:lstStyle/>
+          <a:p>
+            <a:pPr indent="0" marL="0">
+              <a:buNone/>
+            </a:pPr>
+            <a:r>
+              <a:rPr lang="en-US" sz="1800" dirty="0">
+                <a:solidFill>
+                  <a:srgbClr val="E35205"/>
+                </a:solidFill>
+                <a:latin typeface="Calibri" pitchFamily="34" charset="0"/>
+                <a:ea typeface="Calibri" pitchFamily="34" charset="-122"/>
+                <a:cs typeface="Calibri" pitchFamily="34" charset="-120"/>
+              </a:rPr>
+              <a:t>Next week: Cryptography used correctly</a:t>
+            </a:r>
+            <a:endParaRPr lang="en-US" sz="1800" dirty="0"/>
+          </a:p>
+        </p:txBody>
+      </p:sp>
+      <p:pic>
+        <p:nvPicPr>
+          <p:cNvPr id="4" name="Image 0" descr="/Users/pop7/Library/CloudStorage/OneDrive-MonsterConnectCo.,Ltd/Lecture/KOSEN69 - software-security/slides/pptx/assets/logo-small.png">    </p:cNvPr>
+          <p:cNvPicPr>
+            <a:picLocks noChangeAspect="1"/>
+          </p:cNvPicPr>
+          <p:nvPr/>
+        </p:nvPicPr>
+        <p:blipFill>
+          <a:blip r:embed="rId1"/>
           <a:stretch>
             <a:fillRect/>
           </a:stretch>

</xml_diff>

<commit_message>
slides(pptx): rebuild weeks 2, 3, 9 from current sources; fix alt text with "]" (#104)
The committed decks predated later edits to slides/week02.md, week03.md
and week09.md.

- week02: adds the "How fuzzing finds it" slide (19 -> 20 pages)
- week03: adds the ECB picture and "four fixes in the code" slides and the
  CWE-321 (a case of CWE-798, filed under A07) wording (17 -> 20 pages)
- week09: proctor notes describe hosted-instance flags and
  ctf_integrity_report.py instead of seed_flags.py

build_all.js: the markdown-image matcher stopped at the first "]" in the
alt text, so an image whose alt contains "data[3]" leaked raw markdown
onto the slide. Match greedily up to the last "](" and reject a line with
a second "](" in the alt. Of the 26 image lines across all 19 sources
only week02.md:106 changes.

Rendered all three decks (soffice -> pdf) and checked every page: no
clipping. Other decks are not rebuilt.

Co-authored-by: Claude Sonnet 5 <noreply@anthropic.com>
</commit_message>
<xml_diff>
--- a/slides/pptx/week02.pptx
+++ b/slides/pptx/week02.pptx
@@ -24,9 +24,10 @@
     <p:sldId id="272" r:id="rId18"/>
     <p:sldId id="273" r:id="rId19"/>
     <p:sldId id="274" r:id="rId20"/>
+    <p:sldId id="275" r:id="rId21"/>
   </p:sldIdLst>
   <p:notesMasterIdLst>
-    <p:notesMasterId r:id="rId21"/>
+    <p:notesMasterId r:id="rId22"/>
   </p:notesMasterIdLst>
   <p:sldSz cx="9144000" cy="5143500"/>
   <p:notesSz cx="5143500" cy="9144000"/>
@@ -608,7 +609,7 @@
           <a:p>
             <a:r>
               <a:rPr lang="en-US" dirty="0"/>
-              <a:t>This is harness.c's exact logic, computed in the browser — not an animation of "how fuzzing feels." Make sure "FUZ" (3 bytes, overflow) and "FUZZ" (4 bytes, deliberate trap via __builtin_trap — a different crash class, no memory-safety bug at all) both get tried, since that distinction is easy to blur. Ties to worksheet Task 4. ~4 min.</a:t>
+              <a:t>The static companion to the fuzz-verdict sim, and the answer to 'why fuzz if we already ran SAST?' Walk it: SAST can't know the input will ever be exactly FUZ, so it stays silent (blue); the fuzzer doesn't brute-force randomly — coverage feedback rewards each new gate passed, so it climbs to FUZ and the unguarded data[3] read faults under ASan (orange). Land on: static reads, fuzzing runs — complements. ~4 min.</a:t>
             </a:r>
             <a:endParaRPr lang="en-US" dirty="0"/>
           </a:p>
@@ -696,7 +697,7 @@
           <a:p>
             <a:r>
               <a:rPr lang="en-US" dirty="0"/>
-              <a:t>Crucial professional skill: a scanner that cries wolf gets ignored. IMPORTANT — a real `bash scan.sh` run against this week's own vulnerable-repo returns 12 findings and all 12 are genuine true positives; there is no clean false-positive example in this specimen, so don't invent one live. The real triage skill THIS repo exercises is deduplication: 5 Semgrep rules fire on the identical SQLi line, 3 fire on the identical command-injection line — teach "same root cause, one row in your table" rather than promising a false positive you won't be able to produce on demand. Every finding still gets a CWE + a TP call + a one-line justification. ~4 min.</a:t>
+              <a:t>This is harness.c's exact logic, computed in the browser — not an animation of "how fuzzing feels." Make sure "FUZ" (3 bytes, overflow) and "FUZZ" (4 bytes, deliberate trap via __builtin_trap — a different crash class, no memory-safety bug at all) both get tried, since that distinction is easy to blur. Ties to worksheet Task 4. ~4 min.</a:t>
             </a:r>
             <a:endParaRPr lang="en-US" dirty="0"/>
           </a:p>
@@ -784,7 +785,7 @@
           <a:p>
             <a:r>
               <a:rPr lang="en-US" dirty="0"/>
-              <a:t>Every rule ID and line number here is copied from an actual scan.sh run, not invented. The point: "5 rules fired" is not "5 bugs" — recognizing the SAME root cause under two different rule names is the real-world triage skill, more useful than a TP/FP guess. Directly rehearses worksheet Task 3's triage table. ~4 min.</a:t>
+              <a:t>Crucial professional skill: a scanner that cries wolf gets ignored. IMPORTANT — a real `bash scan.sh` run against this week's own vulnerable-repo returns 12 findings and all 12 are genuine true positives; there is no clean false-positive example in this specimen, so don't invent one live. The real triage skill THIS repo exercises is deduplication: 5 Semgrep rules fire on the identical SQLi line, 3 fire on the identical command-injection line — teach "same root cause, one row in your table" rather than promising a false positive you won't be able to produce on demand. Every finding still gets a CWE + a TP call + a one-line justification. ~4 min.</a:t>
             </a:r>
             <a:endParaRPr lang="en-US" dirty="0"/>
           </a:p>
@@ -872,7 +873,7 @@
           <a:p>
             <a:r>
               <a:rPr lang="en-US" dirty="0"/>
-              <a:t>Trivy is the one they'll type today (Task 5, scanning the NoteVault target) — say so explicitly so "tools you'll meet" doesn't read as "tools this lab uses." SonarQube/GHAS are real-world awareness. Connect "technical debt" to the cost curve from the recap. ~3 min.</a:t>
+              <a:t>Every rule ID and line number here is copied from an actual scan.sh run, not invented. The point: "5 rules fired" is not "5 bugs" — recognizing the SAME root cause under two different rule names is the real-world triage skill, more useful than a TP/FP guess. Directly rehearses worksheet Task 3's triage table. ~4 min.</a:t>
             </a:r>
             <a:endParaRPr lang="en-US" dirty="0"/>
           </a:p>
@@ -960,7 +961,7 @@
           <a:p>
             <a:r>
               <a:rPr lang="en-US" dirty="0"/>
-              <a:t>Explain the game before lab: speed + accuracy. Penalize wild guessing (misclassified subtracts) so they must justify each finding. Mirrors a real bug-bounty triage queue. Warn about the two gotchas up front: Gitleaks needs `--no-git` or it silently reports zero leaks; the repo root's own `.gitleaks.toml` deliberately allowlists this lab's secrets, so scan `vulnerable-repo/` specifically, not the repo root. ~3 min.</a:t>
+              <a:t>Trivy is the one they'll type today (Task 5, scanning the NoteVault target) — say so explicitly so "tools you'll meet" doesn't read as "tools this lab uses." SonarQube/GHAS are real-world awareness. Connect "technical debt" to the cost curve from the recap. ~3 min.</a:t>
             </a:r>
             <a:endParaRPr lang="en-US" dirty="0"/>
           </a:p>
@@ -1048,7 +1049,7 @@
           <a:p>
             <a:r>
               <a:rPr lang="en-US" dirty="0"/>
-              <a:t>Quick, fun, instant feedback (it crashes or it doesn't). Sets up W11. If short on time, make this a demo. ~2 min.</a:t>
+              <a:t>Explain the game before lab: speed + accuracy. Penalize wild guessing (misclassified subtracts) so they must justify each finding. Mirrors a real bug-bounty triage queue. Warn about the two gotchas up front: Gitleaks needs `--no-git` or it silently reports zero leaks; the repo root's own `.gitleaks.toml` deliberately allowlists this lab's secrets, so scan `vulnerable-repo/` specifically, not the repo root. ~3 min.</a:t>
             </a:r>
             <a:endParaRPr lang="en-US" dirty="0"/>
           </a:p>
@@ -1136,7 +1137,7 @@
           <a:p>
             <a:r>
               <a:rPr lang="en-US" dirty="0"/>
-              <a:t>The graded output — six tasks, not three. The defend/fix task (25 pts, "Defense") is the single biggest score component and is easy to undersell if you only recap the triage table. Point to scan.sh.</a:t>
+              <a:t>Quick, fun, instant feedback (it crashes or it doesn't). Sets up W11. If short on time, make this a demo. ~2 min.</a:t>
             </a:r>
             <a:endParaRPr lang="en-US" dirty="0"/>
           </a:p>
@@ -1312,7 +1313,7 @@
           <a:p>
             <a:r>
               <a:rPr lang="en-US" dirty="0"/>
-              <a:t>Recap, 3 lines. Cold-call: "name a bug SAST would miss but DAST would catch." ~2 min.</a:t>
+              <a:t>The graded output — six tasks, not three. The defend/fix task (25 pts, "Defense") is the single biggest score component and is easy to undersell if you only recap the triage table. Point to scan.sh.</a:t>
             </a:r>
             <a:endParaRPr lang="en-US" dirty="0"/>
           </a:p>
@@ -1400,7 +1401,7 @@
           <a:p>
             <a:r>
               <a:rPr lang="en-US" dirty="0"/>
-              <a:t>Cliffhanger: "Next week we break crypto — crack passwords and decrypt a secret in minutes." Remind: scanners ready in their VM.</a:t>
+              <a:t>Recap, 3 lines. Cold-call: "name a bug SAST would miss but DAST would catch." ~2 min.</a:t>
             </a:r>
             <a:endParaRPr lang="en-US" dirty="0"/>
           </a:p>
@@ -1512,6 +1513,94 @@
             <a:fld id="{F7021451-1387-4CA6-816F-3879F97B5CBC}" type="slidenum">
               <a:rPr lang="en-US"/>
               <a:t>2</a:t>
+            </a:fld>
+            <a:endParaRPr lang="en-US"/>
+          </a:p>
+        </p:txBody>
+      </p:sp>
+    </p:spTree>
+    <p:extLst>
+      <p:ext uri="{BB962C8B-B14F-4D97-AF65-F5344CB8AC3E}">
+        <p14:creationId xmlns:p14="http://schemas.microsoft.com/office/powerpoint/2010/main" val="1024086991"/>
+      </p:ext>
+    </p:extLst>
+  </p:cSld>
+  <p:clrMapOvr>
+    <a:masterClrMapping/>
+  </p:clrMapOvr>
+</p:notes>
+</file>
+
+<file path=ppt/notesSlides/notesSlide20.xml><?xml version="1.0" encoding="utf-8"?>
+<p:notes xmlns:a="http://schemas.openxmlformats.org/drawingml/2006/main" xmlns:r="http://schemas.openxmlformats.org/officeDocument/2006/relationships" xmlns:p="http://schemas.openxmlformats.org/presentationml/2006/main">
+  <p:cSld>
+    <p:spTree>
+      <p:nvGrpSpPr>
+        <p:cNvPr id="1" name=""/>
+        <p:cNvGrpSpPr/>
+        <p:nvPr/>
+      </p:nvGrpSpPr>
+      <p:grpSpPr>
+        <a:xfrm>
+          <a:off x="0" y="0"/>
+          <a:ext cx="0" cy="0"/>
+          <a:chOff x="0" y="0"/>
+          <a:chExt cx="0" cy="0"/>
+        </a:xfrm>
+      </p:grpSpPr>
+      <p:sp>
+        <p:nvSpPr>
+          <p:cNvPr id="2" name="Slide Image Placeholder 1"/>
+          <p:cNvSpPr>
+            <a:spLocks noGrp="1" noRot="1" noChangeAspect="1"/>
+          </p:cNvSpPr>
+          <p:nvPr>
+            <p:ph type="sldImg"/>
+          </p:nvPr>
+        </p:nvSpPr>
+        <p:spPr/>
+      </p:sp>
+      <p:sp>
+        <p:nvSpPr>
+          <p:cNvPr id="3" name="Notes Placeholder 2"/>
+          <p:cNvSpPr>
+            <a:spLocks noGrp="1"/>
+          </p:cNvSpPr>
+          <p:nvPr>
+            <p:ph type="body" idx="1"/>
+          </p:nvPr>
+        </p:nvSpPr>
+        <p:spPr/>
+        <p:txBody>
+          <a:bodyPr/>
+          <a:lstStyle/>
+          <a:p>
+            <a:r>
+              <a:rPr lang="en-US" dirty="0"/>
+              <a:t>Cliffhanger: "Next week we break crypto — crack passwords and decrypt a secret in minutes." Remind: scanners ready in their VM.</a:t>
+            </a:r>
+            <a:endParaRPr lang="en-US" dirty="0"/>
+          </a:p>
+        </p:txBody>
+      </p:sp>
+      <p:sp>
+        <p:nvSpPr>
+          <p:cNvPr id="4" name="Slide Number Placeholder 3"/>
+          <p:cNvSpPr>
+            <a:spLocks noGrp="1"/>
+          </p:cNvSpPr>
+          <p:nvPr>
+            <p:ph type="sldNum" sz="quarter" idx="10"/>
+          </p:nvPr>
+        </p:nvSpPr>
+        <p:spPr/>
+        <p:txBody>
+          <a:bodyPr/>
+          <a:lstStyle/>
+          <a:p>
+            <a:fld id="{F7021451-1387-4CA6-816F-3879F97B5CBC}" type="slidenum">
+              <a:rPr lang="en-US"/>
+              <a:t>20</a:t>
             </a:fld>
             <a:endParaRPr lang="en-US"/>
           </a:p>
@@ -2737,7 +2826,7 @@
                 <a:ea typeface="Arial" pitchFamily="34" charset="-122"/>
                 <a:cs typeface="Arial" pitchFamily="34" charset="-120"/>
               </a:rPr>
-              <a:t>Try it — what actually crashes this harness</a:t>
+              <a:t>How fuzzing finds it</a:t>
             </a:r>
             <a:endParaRPr lang="en-US" sz="2600" dirty="0"/>
           </a:p>
@@ -2752,7 +2841,7 @@
         <p:spPr>
           <a:xfrm>
             <a:off x="548640" y="1325880"/>
-            <a:ext cx="8046720" cy="822960"/>
+            <a:ext cx="8046720" cy="2194560"/>
           </a:xfrm>
           <a:prstGeom prst="rect">
             <a:avLst/>
@@ -2778,24 +2867,7 @@
                 <a:ea typeface="Calibri" pitchFamily="34" charset="-122"/>
                 <a:cs typeface="Calibri" pitchFamily="34" charset="-120"/>
               </a:rPr>
-              <a:t>Type bytes, or pick a preset. Each cell is one if in the real source.</a:t>
-            </a:r>
-            <a:endParaRPr lang="en-US" sz="1400" dirty="0"/>
-          </a:p>
-          <a:p>
-            <a:pPr indent="0" marL="0">
-              <a:buNone/>
-            </a:pPr>
-            <a:r>
-              <a:rPr lang="en-US" sz="1400" dirty="0">
-                <a:solidFill>
-                  <a:srgbClr val="1F2937"/>
-                </a:solidFill>
-                <a:latin typeface="Calibri" pitchFamily="34" charset="0"/>
-                <a:ea typeface="Calibri" pitchFamily="34" charset="-122"/>
-                <a:cs typeface="Calibri" pitchFamily="34" charset="-120"/>
-              </a:rPr>
-              <a:t>Try it live: /sim/fuzz-verdict (interactive simulation, web only)</a:t>
+              <a:t>See diagram: A coverage-guided fuzzer reaches a bug a static analyzer misses: the harness has four nested byte checks (F, U, Z, Z) and the fourth reads data[3] with no size&gt;3 guard, so the input 'FUZ' reads one byte out of bounds. SAST reads the code and stays silent; the fuzzer mutates inputs and is rewarded for each new branch reached, climbing random -&gt; F -&gt; FU -&gt; FUZ until the unguarded read crashes under AddressSanitizer, which writes a reproducer file. SAST and fuzzing are complements, not substitutes. (web only)</a:t>
             </a:r>
             <a:endParaRPr lang="en-US" sz="1400" dirty="0"/>
           </a:p>
@@ -2980,7 +3052,7 @@
                 <a:ea typeface="Arial" pitchFamily="34" charset="-122"/>
                 <a:cs typeface="Arial" pitchFamily="34" charset="-120"/>
               </a:rPr>
-              <a:t>Triage: not every finding is a bug</a:t>
+              <a:t>Try it — what actually crashes this harness</a:t>
             </a:r>
             <a:endParaRPr lang="en-US" sz="2600" dirty="0"/>
           </a:p>
@@ -2988,43 +3060,14 @@
       </p:sp>
       <p:sp>
         <p:nvSpPr>
-          <p:cNvPr id="5" name="Shape 2"/>
-          <p:cNvSpPr/>
-          <p:nvPr/>
-        </p:nvSpPr>
-        <p:spPr>
-          <a:xfrm>
-            <a:off x="457200" y="1325880"/>
-            <a:ext cx="8229600" cy="1517904"/>
-          </a:xfrm>
-          <a:prstGeom prst="roundRect">
-            <a:avLst>
-              <a:gd name="adj" fmla="val 4819"/>
-            </a:avLst>
-          </a:prstGeom>
-          <a:solidFill>
-            <a:srgbClr val="F1F5F9"/>
-          </a:solidFill>
-          <a:ln/>
-          <a:effectLst>
-            <a:outerShdw sx="100000" sy="100000" kx="0" ky="0" algn="bl" rotWithShape="0" blurRad="76200" dist="25400" dir="5400000">
-              <a:srgbClr val="000000">
-                <a:alpha val="12000"/>
-              </a:srgbClr>
-            </a:outerShdw>
-          </a:effectLst>
-        </p:spPr>
-      </p:sp>
-      <p:sp>
-        <p:nvSpPr>
-          <p:cNvPr id="6" name="Text 3"/>
-          <p:cNvSpPr/>
-          <p:nvPr/>
-        </p:nvSpPr>
-        <p:spPr>
-          <a:xfrm>
-            <a:off x="731520" y="1435608"/>
-            <a:ext cx="7680960" cy="1298448"/>
+          <p:cNvPr id="5" name="Text 2"/>
+          <p:cNvSpPr/>
+          <p:nvPr/>
+        </p:nvSpPr>
+        <p:spPr>
+          <a:xfrm>
+            <a:off x="548640" y="1325880"/>
+            <a:ext cx="8046720" cy="822960"/>
           </a:xfrm>
           <a:prstGeom prst="rect">
             <a:avLst/>
@@ -3038,12 +3081,8 @@
           </a:bodyPr>
           <a:lstStyle/>
           <a:p>
-            <a:pPr marL="342900" indent="-342900">
-              <a:spcAft>
-                <a:spcPts val="600"/>
-              </a:spcAft>
-              <a:buSzPct val="100000"/>
-              <a:buChar char="•"/>
+            <a:pPr indent="0" marL="0">
+              <a:buNone/>
             </a:pPr>
             <a:r>
               <a:rPr lang="en-US" sz="1400" dirty="0">
@@ -3054,17 +3093,13 @@
                 <a:ea typeface="Calibri" pitchFamily="34" charset="-122"/>
                 <a:cs typeface="Calibri" pitchFamily="34" charset="-120"/>
               </a:rPr>
-              <a:t>True positive vs false positive</a:t>
+              <a:t>Type bytes, or pick a preset. Each cell is one if in the real source.</a:t>
             </a:r>
             <a:endParaRPr lang="en-US" sz="1400" dirty="0"/>
           </a:p>
           <a:p>
-            <a:pPr marL="342900" indent="-342900">
-              <a:spcAft>
-                <a:spcPts val="600"/>
-              </a:spcAft>
-              <a:buSzPct val="100000"/>
-              <a:buChar char="•"/>
+            <a:pPr indent="0" marL="0">
+              <a:buNone/>
             </a:pPr>
             <a:r>
               <a:rPr lang="en-US" sz="1400" dirty="0">
@@ -3075,87 +3110,45 @@
                 <a:ea typeface="Calibri" pitchFamily="34" charset="-122"/>
                 <a:cs typeface="Calibri" pitchFamily="34" charset="-120"/>
               </a:rPr>
-              <a:t>Map each to a CWE + severity</a:t>
+              <a:t>Try it live: /sim/fuzz-verdict (interactive simulation, web only)</a:t>
             </a:r>
             <a:endParaRPr lang="en-US" sz="1400" dirty="0"/>
           </a:p>
-          <a:p>
-            <a:pPr marL="342900" indent="-342900">
-              <a:spcAft>
-                <a:spcPts val="600"/>
-              </a:spcAft>
-              <a:buSzPct val="100000"/>
-              <a:buChar char="•"/>
-            </a:pPr>
-            <a:r>
-              <a:rPr lang="en-US" sz="1400" dirty="0">
-                <a:solidFill>
-                  <a:srgbClr val="1F2937"/>
+        </p:txBody>
+      </p:sp>
+      <p:sp>
+        <p:nvSpPr>
+          <p:cNvPr id="6" name="Text 3"/>
+          <p:cNvSpPr/>
+          <p:nvPr/>
+        </p:nvSpPr>
+        <p:spPr>
+          <a:xfrm>
+            <a:off x="457200" y="4800600"/>
+            <a:ext cx="6949440" cy="274320"/>
+          </a:xfrm>
+          <a:prstGeom prst="rect">
+            <a:avLst/>
+          </a:prstGeom>
+          <a:noFill/>
+          <a:ln/>
+        </p:spPr>
+        <p:txBody>
+          <a:bodyPr wrap="square" lIns="0" tIns="0" rIns="0" bIns="0" rtlCol="0" anchor="ctr"/>
+          <a:lstStyle/>
+          <a:p>
+            <a:pPr indent="0" marL="0">
+              <a:buNone/>
+            </a:pPr>
+            <a:r>
+              <a:rPr lang="en-US" sz="900" dirty="0">
+                <a:solidFill>
+                  <a:srgbClr val="64748B"/>
                 </a:solidFill>
                 <a:latin typeface="Calibri" pitchFamily="34" charset="0"/>
                 <a:ea typeface="Calibri" pitchFamily="34" charset="-122"/>
                 <a:cs typeface="Calibri" pitchFamily="34" charset="-120"/>
               </a:rPr>
-              <a:t>Prioritize by exploitability × impact</a:t>
-            </a:r>
-            <a:endParaRPr lang="en-US" sz="1400" dirty="0"/>
-          </a:p>
-          <a:p>
-            <a:pPr marL="342900" indent="-342900">
-              <a:spcAft>
-                <a:spcPts val="600"/>
-              </a:spcAft>
-              <a:buSzPct val="100000"/>
-              <a:buChar char="•"/>
-            </a:pPr>
-            <a:r>
-              <a:rPr lang="en-US" sz="1400" dirty="0">
-                <a:solidFill>
-                  <a:srgbClr val="1F2937"/>
-                </a:solidFill>
-                <a:latin typeface="Calibri" pitchFamily="34" charset="0"/>
-                <a:ea typeface="Calibri" pitchFamily="34" charset="-122"/>
-                <a:cs typeface="Calibri" pitchFamily="34" charset="-120"/>
-              </a:rPr>
-              <a:t>Noise kills trust in tools — triage well</a:t>
-            </a:r>
-            <a:endParaRPr lang="en-US" sz="1400" dirty="0"/>
-          </a:p>
-        </p:txBody>
-      </p:sp>
-      <p:sp>
-        <p:nvSpPr>
-          <p:cNvPr id="7" name="Text 4"/>
-          <p:cNvSpPr/>
-          <p:nvPr/>
-        </p:nvSpPr>
-        <p:spPr>
-          <a:xfrm>
-            <a:off x="457200" y="4800600"/>
-            <a:ext cx="6949440" cy="274320"/>
-          </a:xfrm>
-          <a:prstGeom prst="rect">
-            <a:avLst/>
-          </a:prstGeom>
-          <a:noFill/>
-          <a:ln/>
-        </p:spPr>
-        <p:txBody>
-          <a:bodyPr wrap="square" lIns="0" tIns="0" rIns="0" bIns="0" rtlCol="0" anchor="ctr"/>
-          <a:lstStyle/>
-          <a:p>
-            <a:pPr indent="0" marL="0">
-              <a:buNone/>
-            </a:pPr>
-            <a:r>
-              <a:rPr lang="en-US" sz="900" dirty="0">
-                <a:solidFill>
-                  <a:srgbClr val="64748B"/>
-                </a:solidFill>
-                <a:latin typeface="Calibri" pitchFamily="34" charset="0"/>
-                <a:ea typeface="Calibri" pitchFamily="34" charset="-122"/>
-                <a:cs typeface="Calibri" pitchFamily="34" charset="-120"/>
-              </a:rPr>
               <a:t>Software Security · Week 2</a:t>
             </a:r>
             <a:endParaRPr lang="en-US" sz="900" dirty="0"/>
@@ -3164,7 +3157,7 @@
       </p:sp>
       <p:pic>
         <p:nvPicPr>
-          <p:cNvPr id="8" name="Image 1" descr="/Users/pop7/Library/CloudStorage/OneDrive-MonsterConnectCo.,Ltd/Lecture/KOSEN69 - software-security/slides/pptx/assets/logo-small.png">    </p:cNvPr>
+          <p:cNvPr id="7" name="Image 1" descr="/Users/pop7/Library/CloudStorage/OneDrive-MonsterConnectCo.,Ltd/Lecture/KOSEN69 - software-security/slides/pptx/assets/logo-small.png">    </p:cNvPr>
           <p:cNvPicPr>
             <a:picLocks noChangeAspect="1"/>
           </p:cNvPicPr>
@@ -3302,7 +3295,7 @@
                 <a:ea typeface="Arial" pitchFamily="34" charset="-122"/>
                 <a:cs typeface="Arial" pitchFamily="34" charset="-120"/>
               </a:rPr>
-              <a:t>Try it — which bug is this, really?</a:t>
+              <a:t>Triage: not every finding is a bug</a:t>
             </a:r>
             <a:endParaRPr lang="en-US" sz="2600" dirty="0"/>
           </a:p>
@@ -3310,14 +3303,43 @@
       </p:sp>
       <p:sp>
         <p:nvSpPr>
-          <p:cNvPr id="5" name="Text 2"/>
-          <p:cNvSpPr/>
-          <p:nvPr/>
-        </p:nvSpPr>
-        <p:spPr>
-          <a:xfrm>
-            <a:off x="548640" y="1325880"/>
-            <a:ext cx="8046720" cy="822960"/>
+          <p:cNvPr id="5" name="Shape 2"/>
+          <p:cNvSpPr/>
+          <p:nvPr/>
+        </p:nvSpPr>
+        <p:spPr>
+          <a:xfrm>
+            <a:off x="457200" y="1325880"/>
+            <a:ext cx="8229600" cy="1517904"/>
+          </a:xfrm>
+          <a:prstGeom prst="roundRect">
+            <a:avLst>
+              <a:gd name="adj" fmla="val 4819"/>
+            </a:avLst>
+          </a:prstGeom>
+          <a:solidFill>
+            <a:srgbClr val="F1F5F9"/>
+          </a:solidFill>
+          <a:ln/>
+          <a:effectLst>
+            <a:outerShdw sx="100000" sy="100000" kx="0" ky="0" algn="bl" rotWithShape="0" blurRad="76200" dist="25400" dir="5400000">
+              <a:srgbClr val="000000">
+                <a:alpha val="12000"/>
+              </a:srgbClr>
+            </a:outerShdw>
+          </a:effectLst>
+        </p:spPr>
+      </p:sp>
+      <p:sp>
+        <p:nvSpPr>
+          <p:cNvPr id="6" name="Text 3"/>
+          <p:cNvSpPr/>
+          <p:nvPr/>
+        </p:nvSpPr>
+        <p:spPr>
+          <a:xfrm>
+            <a:off x="731520" y="1435608"/>
+            <a:ext cx="7680960" cy="1298448"/>
           </a:xfrm>
           <a:prstGeom prst="rect">
             <a:avLst/>
@@ -3331,8 +3353,12 @@
           </a:bodyPr>
           <a:lstStyle/>
           <a:p>
-            <a:pPr indent="0" marL="0">
-              <a:buNone/>
+            <a:pPr marL="342900" indent="-342900">
+              <a:spcAft>
+                <a:spcPts val="600"/>
+              </a:spcAft>
+              <a:buSzPct val="100000"/>
+              <a:buChar char="•"/>
             </a:pPr>
             <a:r>
               <a:rPr lang="en-US" sz="1400" dirty="0">
@@ -3343,13 +3369,17 @@
                 <a:ea typeface="Calibri" pitchFamily="34" charset="-122"/>
                 <a:cs typeface="Calibri" pitchFamily="34" charset="-120"/>
               </a:rPr>
-              <a:t>Seven raw findings from a real scan. Map each back to the one bug underneath.</a:t>
+              <a:t>True positive vs false positive</a:t>
             </a:r>
             <a:endParaRPr lang="en-US" sz="1400" dirty="0"/>
           </a:p>
           <a:p>
-            <a:pPr indent="0" marL="0">
-              <a:buNone/>
+            <a:pPr marL="342900" indent="-342900">
+              <a:spcAft>
+                <a:spcPts val="600"/>
+              </a:spcAft>
+              <a:buSzPct val="100000"/>
+              <a:buChar char="•"/>
             </a:pPr>
             <a:r>
               <a:rPr lang="en-US" sz="1400" dirty="0">
@@ -3360,45 +3390,87 @@
                 <a:ea typeface="Calibri" pitchFamily="34" charset="-122"/>
                 <a:cs typeface="Calibri" pitchFamily="34" charset="-120"/>
               </a:rPr>
-              <a:t>Try it live: /sim/triage-drill (interactive simulation, web only)</a:t>
+              <a:t>Map each to a CWE + severity</a:t>
             </a:r>
             <a:endParaRPr lang="en-US" sz="1400" dirty="0"/>
           </a:p>
-        </p:txBody>
-      </p:sp>
-      <p:sp>
-        <p:nvSpPr>
-          <p:cNvPr id="6" name="Text 3"/>
-          <p:cNvSpPr/>
-          <p:nvPr/>
-        </p:nvSpPr>
-        <p:spPr>
-          <a:xfrm>
-            <a:off x="457200" y="4800600"/>
-            <a:ext cx="6949440" cy="274320"/>
-          </a:xfrm>
-          <a:prstGeom prst="rect">
-            <a:avLst/>
-          </a:prstGeom>
-          <a:noFill/>
-          <a:ln/>
-        </p:spPr>
-        <p:txBody>
-          <a:bodyPr wrap="square" lIns="0" tIns="0" rIns="0" bIns="0" rtlCol="0" anchor="ctr"/>
-          <a:lstStyle/>
-          <a:p>
-            <a:pPr indent="0" marL="0">
-              <a:buNone/>
-            </a:pPr>
-            <a:r>
-              <a:rPr lang="en-US" sz="900" dirty="0">
-                <a:solidFill>
-                  <a:srgbClr val="64748B"/>
+          <a:p>
+            <a:pPr marL="342900" indent="-342900">
+              <a:spcAft>
+                <a:spcPts val="600"/>
+              </a:spcAft>
+              <a:buSzPct val="100000"/>
+              <a:buChar char="•"/>
+            </a:pPr>
+            <a:r>
+              <a:rPr lang="en-US" sz="1400" dirty="0">
+                <a:solidFill>
+                  <a:srgbClr val="1F2937"/>
                 </a:solidFill>
                 <a:latin typeface="Calibri" pitchFamily="34" charset="0"/>
                 <a:ea typeface="Calibri" pitchFamily="34" charset="-122"/>
                 <a:cs typeface="Calibri" pitchFamily="34" charset="-120"/>
               </a:rPr>
+              <a:t>Prioritize by exploitability × impact</a:t>
+            </a:r>
+            <a:endParaRPr lang="en-US" sz="1400" dirty="0"/>
+          </a:p>
+          <a:p>
+            <a:pPr marL="342900" indent="-342900">
+              <a:spcAft>
+                <a:spcPts val="600"/>
+              </a:spcAft>
+              <a:buSzPct val="100000"/>
+              <a:buChar char="•"/>
+            </a:pPr>
+            <a:r>
+              <a:rPr lang="en-US" sz="1400" dirty="0">
+                <a:solidFill>
+                  <a:srgbClr val="1F2937"/>
+                </a:solidFill>
+                <a:latin typeface="Calibri" pitchFamily="34" charset="0"/>
+                <a:ea typeface="Calibri" pitchFamily="34" charset="-122"/>
+                <a:cs typeface="Calibri" pitchFamily="34" charset="-120"/>
+              </a:rPr>
+              <a:t>Noise kills trust in tools — triage well</a:t>
+            </a:r>
+            <a:endParaRPr lang="en-US" sz="1400" dirty="0"/>
+          </a:p>
+        </p:txBody>
+      </p:sp>
+      <p:sp>
+        <p:nvSpPr>
+          <p:cNvPr id="7" name="Text 4"/>
+          <p:cNvSpPr/>
+          <p:nvPr/>
+        </p:nvSpPr>
+        <p:spPr>
+          <a:xfrm>
+            <a:off x="457200" y="4800600"/>
+            <a:ext cx="6949440" cy="274320"/>
+          </a:xfrm>
+          <a:prstGeom prst="rect">
+            <a:avLst/>
+          </a:prstGeom>
+          <a:noFill/>
+          <a:ln/>
+        </p:spPr>
+        <p:txBody>
+          <a:bodyPr wrap="square" lIns="0" tIns="0" rIns="0" bIns="0" rtlCol="0" anchor="ctr"/>
+          <a:lstStyle/>
+          <a:p>
+            <a:pPr indent="0" marL="0">
+              <a:buNone/>
+            </a:pPr>
+            <a:r>
+              <a:rPr lang="en-US" sz="900" dirty="0">
+                <a:solidFill>
+                  <a:srgbClr val="64748B"/>
+                </a:solidFill>
+                <a:latin typeface="Calibri" pitchFamily="34" charset="0"/>
+                <a:ea typeface="Calibri" pitchFamily="34" charset="-122"/>
+                <a:cs typeface="Calibri" pitchFamily="34" charset="-120"/>
+              </a:rPr>
               <a:t>Software Security · Week 2</a:t>
             </a:r>
             <a:endParaRPr lang="en-US" sz="900" dirty="0"/>
@@ -3407,7 +3479,7 @@
       </p:sp>
       <p:pic>
         <p:nvPicPr>
-          <p:cNvPr id="7" name="Image 1" descr="/Users/pop7/Library/CloudStorage/OneDrive-MonsterConnectCo.,Ltd/Lecture/KOSEN69 - software-security/slides/pptx/assets/logo-small.png">    </p:cNvPr>
+          <p:cNvPr id="8" name="Image 1" descr="/Users/pop7/Library/CloudStorage/OneDrive-MonsterConnectCo.,Ltd/Lecture/KOSEN69 - software-security/slides/pptx/assets/logo-small.png">    </p:cNvPr>
           <p:cNvPicPr>
             <a:picLocks noChangeAspect="1"/>
           </p:cNvPicPr>
@@ -3545,7 +3617,7 @@
                 <a:ea typeface="Arial" pitchFamily="34" charset="-122"/>
                 <a:cs typeface="Arial" pitchFamily="34" charset="-120"/>
               </a:rPr>
-              <a:t>Tools you'll meet</a:t>
+              <a:t>Try it — which bug is this, really?</a:t>
             </a:r>
             <a:endParaRPr lang="en-US" sz="2600" dirty="0"/>
           </a:p>
@@ -3553,43 +3625,14 @@
       </p:sp>
       <p:sp>
         <p:nvSpPr>
-          <p:cNvPr id="5" name="Shape 2"/>
-          <p:cNvSpPr/>
-          <p:nvPr/>
-        </p:nvSpPr>
-        <p:spPr>
-          <a:xfrm>
-            <a:off x="457200" y="1325880"/>
-            <a:ext cx="8229600" cy="1609344"/>
-          </a:xfrm>
-          <a:prstGeom prst="roundRect">
-            <a:avLst>
-              <a:gd name="adj" fmla="val 4545"/>
-            </a:avLst>
-          </a:prstGeom>
-          <a:solidFill>
-            <a:srgbClr val="F1F5F9"/>
-          </a:solidFill>
-          <a:ln/>
-          <a:effectLst>
-            <a:outerShdw sx="100000" sy="100000" kx="0" ky="0" algn="bl" rotWithShape="0" blurRad="76200" dist="25400" dir="5400000">
-              <a:srgbClr val="000000">
-                <a:alpha val="12000"/>
-              </a:srgbClr>
-            </a:outerShdw>
-          </a:effectLst>
-        </p:spPr>
-      </p:sp>
-      <p:sp>
-        <p:nvSpPr>
-          <p:cNvPr id="6" name="Text 3"/>
-          <p:cNvSpPr/>
-          <p:nvPr/>
-        </p:nvSpPr>
-        <p:spPr>
-          <a:xfrm>
-            <a:off x="731520" y="1435608"/>
-            <a:ext cx="7680960" cy="1389888"/>
+          <p:cNvPr id="5" name="Text 2"/>
+          <p:cNvSpPr/>
+          <p:nvPr/>
+        </p:nvSpPr>
+        <p:spPr>
+          <a:xfrm>
+            <a:off x="548640" y="1325880"/>
+            <a:ext cx="8046720" cy="822960"/>
           </a:xfrm>
           <a:prstGeom prst="rect">
             <a:avLst/>
@@ -3603,12 +3646,8 @@
           </a:bodyPr>
           <a:lstStyle/>
           <a:p>
-            <a:pPr marL="342900" indent="-342900">
-              <a:spcAft>
-                <a:spcPts val="600"/>
-              </a:spcAft>
-              <a:buSzPct val="100000"/>
-              <a:buChar char="•"/>
+            <a:pPr indent="0" marL="0">
+              <a:buNone/>
             </a:pPr>
             <a:r>
               <a:rPr lang="en-US" sz="1400" dirty="0">
@@ -3619,17 +3658,13 @@
                 <a:ea typeface="Calibri" pitchFamily="34" charset="-122"/>
                 <a:cs typeface="Calibri" pitchFamily="34" charset="-120"/>
               </a:rPr>
-              <a:t>Trivy — the SCA scanner you'll actually run this lab (dependency scan today; image + IaC scanning return in W12/13)</a:t>
+              <a:t>Seven raw findings from a real scan. Map each back to the one bug underneath.</a:t>
             </a:r>
             <a:endParaRPr lang="en-US" sz="1400" dirty="0"/>
           </a:p>
           <a:p>
-            <a:pPr marL="342900" indent="-342900">
-              <a:spcAft>
-                <a:spcPts val="600"/>
-              </a:spcAft>
-              <a:buSzPct val="100000"/>
-              <a:buChar char="•"/>
+            <a:pPr indent="0" marL="0">
+              <a:buNone/>
             </a:pPr>
             <a:r>
               <a:rPr lang="en-US" sz="1400" dirty="0">
@@ -3640,66 +3675,45 @@
                 <a:ea typeface="Calibri" pitchFamily="34" charset="-122"/>
                 <a:cs typeface="Calibri" pitchFamily="34" charset="-120"/>
               </a:rPr>
-              <a:t>SonarQube, GitHub Advanced Security (GHAS) — quality-gate/SAST-in-the-repo tools you'll see in industry/internships, not used in this lab</a:t>
+              <a:t>Try it live: /sim/triage-drill (interactive simulation, web only)</a:t>
             </a:r>
             <a:endParaRPr lang="en-US" sz="1400" dirty="0"/>
           </a:p>
-          <a:p>
-            <a:pPr marL="342900" indent="-342900">
-              <a:spcAft>
-                <a:spcPts val="600"/>
-              </a:spcAft>
-              <a:buSzPct val="100000"/>
-              <a:buChar char="•"/>
-            </a:pPr>
-            <a:r>
-              <a:rPr lang="en-US" sz="1400" dirty="0">
-                <a:solidFill>
-                  <a:srgbClr val="1F2937"/>
+        </p:txBody>
+      </p:sp>
+      <p:sp>
+        <p:nvSpPr>
+          <p:cNvPr id="6" name="Text 3"/>
+          <p:cNvSpPr/>
+          <p:nvPr/>
+        </p:nvSpPr>
+        <p:spPr>
+          <a:xfrm>
+            <a:off x="457200" y="4800600"/>
+            <a:ext cx="6949440" cy="274320"/>
+          </a:xfrm>
+          <a:prstGeom prst="rect">
+            <a:avLst/>
+          </a:prstGeom>
+          <a:noFill/>
+          <a:ln/>
+        </p:spPr>
+        <p:txBody>
+          <a:bodyPr wrap="square" lIns="0" tIns="0" rIns="0" bIns="0" rtlCol="0" anchor="ctr"/>
+          <a:lstStyle/>
+          <a:p>
+            <a:pPr indent="0" marL="0">
+              <a:buNone/>
+            </a:pPr>
+            <a:r>
+              <a:rPr lang="en-US" sz="900" dirty="0">
+                <a:solidFill>
+                  <a:srgbClr val="64748B"/>
                 </a:solidFill>
                 <a:latin typeface="Calibri" pitchFamily="34" charset="0"/>
                 <a:ea typeface="Calibri" pitchFamily="34" charset="-122"/>
                 <a:cs typeface="Calibri" pitchFamily="34" charset="-120"/>
               </a:rPr>
-              <a:t>Address technical debt early — cheaper than re-work later</a:t>
-            </a:r>
-            <a:endParaRPr lang="en-US" sz="1400" dirty="0"/>
-          </a:p>
-        </p:txBody>
-      </p:sp>
-      <p:sp>
-        <p:nvSpPr>
-          <p:cNvPr id="7" name="Text 4"/>
-          <p:cNvSpPr/>
-          <p:nvPr/>
-        </p:nvSpPr>
-        <p:spPr>
-          <a:xfrm>
-            <a:off x="457200" y="4800600"/>
-            <a:ext cx="6949440" cy="274320"/>
-          </a:xfrm>
-          <a:prstGeom prst="rect">
-            <a:avLst/>
-          </a:prstGeom>
-          <a:noFill/>
-          <a:ln/>
-        </p:spPr>
-        <p:txBody>
-          <a:bodyPr wrap="square" lIns="0" tIns="0" rIns="0" bIns="0" rtlCol="0" anchor="ctr"/>
-          <a:lstStyle/>
-          <a:p>
-            <a:pPr indent="0" marL="0">
-              <a:buNone/>
-            </a:pPr>
-            <a:r>
-              <a:rPr lang="en-US" sz="900" dirty="0">
-                <a:solidFill>
-                  <a:srgbClr val="64748B"/>
-                </a:solidFill>
-                <a:latin typeface="Calibri" pitchFamily="34" charset="0"/>
-                <a:ea typeface="Calibri" pitchFamily="34" charset="-122"/>
-                <a:cs typeface="Calibri" pitchFamily="34" charset="-120"/>
-              </a:rPr>
               <a:t>Software Security · Week 2</a:t>
             </a:r>
             <a:endParaRPr lang="en-US" sz="900" dirty="0"/>
@@ -3708,7 +3722,7 @@
       </p:sp>
       <p:pic>
         <p:nvPicPr>
-          <p:cNvPr id="8" name="Image 1" descr="/Users/pop7/Library/CloudStorage/OneDrive-MonsterConnectCo.,Ltd/Lecture/KOSEN69 - software-security/slides/pptx/assets/logo-small.png">    </p:cNvPr>
+          <p:cNvPr id="7" name="Image 1" descr="/Users/pop7/Library/CloudStorage/OneDrive-MonsterConnectCo.,Ltd/Lecture/KOSEN69 - software-security/slides/pptx/assets/logo-small.png">    </p:cNvPr>
           <p:cNvPicPr>
             <a:picLocks noChangeAspect="1"/>
           </p:cNvPicPr>
@@ -3846,7 +3860,7 @@
                 <a:ea typeface="Arial" pitchFamily="34" charset="-122"/>
                 <a:cs typeface="Arial" pitchFamily="34" charset="-120"/>
               </a:rPr>
-              <a:t>🏁 Game — Bug Triage Race</a:t>
+              <a:t>Tools you'll meet</a:t>
             </a:r>
             <a:endParaRPr lang="en-US" sz="2600" dirty="0"/>
           </a:p>
@@ -3861,11 +3875,11 @@
         <p:spPr>
           <a:xfrm>
             <a:off x="457200" y="1325880"/>
-            <a:ext cx="8229600" cy="896112"/>
+            <a:ext cx="8229600" cy="1609344"/>
           </a:xfrm>
           <a:prstGeom prst="roundRect">
             <a:avLst>
-              <a:gd name="adj" fmla="val 8163"/>
+              <a:gd name="adj" fmla="val 4545"/>
             </a:avLst>
           </a:prstGeom>
           <a:solidFill>
@@ -3890,7 +3904,7 @@
         <p:spPr>
           <a:xfrm>
             <a:off x="731520" y="1435608"/>
-            <a:ext cx="7680960" cy="676656"/>
+            <a:ext cx="7680960" cy="1389888"/>
           </a:xfrm>
           <a:prstGeom prst="rect">
             <a:avLst/>
@@ -3920,7 +3934,7 @@
                 <a:ea typeface="Calibri" pitchFamily="34" charset="-122"/>
                 <a:cs typeface="Calibri" pitchFamily="34" charset="-120"/>
               </a:rPr>
-              <a:t>Run Semgrep + Gitleaks on the flawed repo</a:t>
+              <a:t>Trivy — the SCA scanner you'll actually run this lab (dependency scan today; image + IaC scanning return in W12/13)</a:t>
             </a:r>
             <a:endParaRPr lang="en-US" sz="1400" dirty="0"/>
           </a:p>
@@ -3941,164 +3955,66 @@
                 <a:ea typeface="Calibri" pitchFamily="34" charset="-122"/>
                 <a:cs typeface="Calibri" pitchFamily="34" charset="-120"/>
               </a:rPr>
-              <a:t>Score = true positives − misclassified · live scoreboard</a:t>
+              <a:t>SonarQube, GitHub Advanced Security (GHAS) — quality-gate/SAST-in-the-repo tools you'll see in industry/internships, not used in this lab</a:t>
             </a:r>
             <a:endParaRPr lang="en-US" sz="1400" dirty="0"/>
           </a:p>
-        </p:txBody>
-      </p:sp>
-      <p:sp>
-        <p:nvSpPr>
-          <p:cNvPr id="7" name="Shape 4"/>
-          <p:cNvSpPr/>
-          <p:nvPr/>
-        </p:nvSpPr>
-        <p:spPr>
-          <a:xfrm>
-            <a:off x="457200" y="2386584"/>
-            <a:ext cx="8229600" cy="1152144"/>
-          </a:xfrm>
-          <a:prstGeom prst="roundRect">
-            <a:avLst>
-              <a:gd name="adj" fmla="val 4762"/>
-            </a:avLst>
-          </a:prstGeom>
-          <a:solidFill>
-            <a:srgbClr val="0A1020"/>
-          </a:solidFill>
-          <a:ln w="12700">
-            <a:solidFill>
-              <a:srgbClr val="E8EDF3"/>
-            </a:solidFill>
-            <a:prstDash val="solid"/>
-          </a:ln>
-        </p:spPr>
-      </p:sp>
-      <p:sp>
-        <p:nvSpPr>
-          <p:cNvPr id="8" name="Text 5"/>
-          <p:cNvSpPr/>
-          <p:nvPr/>
-        </p:nvSpPr>
-        <p:spPr>
-          <a:xfrm>
-            <a:off x="640080" y="2459736"/>
-            <a:ext cx="7863840" cy="1005840"/>
-          </a:xfrm>
-          <a:prstGeom prst="rect">
-            <a:avLst/>
-          </a:prstGeom>
-          <a:noFill/>
-          <a:ln/>
-        </p:spPr>
-        <p:txBody>
-          <a:bodyPr wrap="square" lIns="0" tIns="0" rIns="0" bIns="0" rtlCol="0" anchor="t">
-            <a:normAutofit/>
-          </a:bodyPr>
-          <a:lstStyle/>
-          <a:p>
-            <a:pPr indent="0" marL="0">
-              <a:buNone/>
-            </a:pPr>
-            <a:r>
-              <a:rPr lang="en-US" sz="1150" dirty="0">
-                <a:solidFill>
-                  <a:srgbClr val="9FE7D6"/>
-                </a:solidFill>
-                <a:latin typeface="Courier New" pitchFamily="34" charset="0"/>
-                <a:ea typeface="Courier New" pitchFamily="34" charset="-122"/>
-                <a:cs typeface="Courier New" pitchFamily="34" charset="-120"/>
-              </a:rPr>
-              <a:t>docker run --rm -v "$PWD/vulnerable-repo:/src" semgrep/semgrep \</a:t>
-            </a:r>
-            <a:endParaRPr lang="en-US" sz="1150" dirty="0"/>
-          </a:p>
-          <a:p>
-            <a:pPr indent="0" marL="0">
-              <a:buNone/>
-            </a:pPr>
-            <a:r>
-              <a:rPr lang="en-US" sz="1150" dirty="0">
-                <a:solidFill>
-                  <a:srgbClr val="9FE7D6"/>
-                </a:solidFill>
-                <a:latin typeface="Courier New" pitchFamily="34" charset="0"/>
-                <a:ea typeface="Courier New" pitchFamily="34" charset="-122"/>
-                <a:cs typeface="Courier New" pitchFamily="34" charset="-120"/>
-              </a:rPr>
-              <a:t>  semgrep --config p/default --config p/owasp-top-ten /src</a:t>
-            </a:r>
-            <a:endParaRPr lang="en-US" sz="1150" dirty="0"/>
-          </a:p>
-          <a:p>
-            <a:pPr indent="0" marL="0">
-              <a:buNone/>
-            </a:pPr>
-            <a:r>
-              <a:rPr lang="en-US" sz="1150" dirty="0">
-                <a:solidFill>
-                  <a:srgbClr val="9FE7D6"/>
-                </a:solidFill>
-                <a:latin typeface="Courier New" pitchFamily="34" charset="0"/>
-                <a:ea typeface="Courier New" pitchFamily="34" charset="-122"/>
-                <a:cs typeface="Courier New" pitchFamily="34" charset="-120"/>
-              </a:rPr>
-              <a:t>docker run --rm -v "$PWD/vulnerable-repo:/repo" zricethezav/gitleaks:latest \</a:t>
-            </a:r>
-            <a:endParaRPr lang="en-US" sz="1150" dirty="0"/>
-          </a:p>
-          <a:p>
-            <a:pPr indent="0" marL="0">
-              <a:buNone/>
-            </a:pPr>
-            <a:r>
-              <a:rPr lang="en-US" sz="1150" dirty="0">
-                <a:solidFill>
-                  <a:srgbClr val="9FE7D6"/>
-                </a:solidFill>
-                <a:latin typeface="Courier New" pitchFamily="34" charset="0"/>
-                <a:ea typeface="Courier New" pitchFamily="34" charset="-122"/>
-                <a:cs typeface="Courier New" pitchFamily="34" charset="-120"/>
-              </a:rPr>
-              <a:t>  detect -s /repo -v --no-git</a:t>
-            </a:r>
-            <a:endParaRPr lang="en-US" sz="1150" dirty="0"/>
-          </a:p>
-        </p:txBody>
-      </p:sp>
-      <p:sp>
-        <p:nvSpPr>
-          <p:cNvPr id="9" name="Text 6"/>
-          <p:cNvSpPr/>
-          <p:nvPr/>
-        </p:nvSpPr>
-        <p:spPr>
-          <a:xfrm>
-            <a:off x="457200" y="4800600"/>
-            <a:ext cx="6949440" cy="274320"/>
-          </a:xfrm>
-          <a:prstGeom prst="rect">
-            <a:avLst/>
-          </a:prstGeom>
-          <a:noFill/>
-          <a:ln/>
-        </p:spPr>
-        <p:txBody>
-          <a:bodyPr wrap="square" lIns="0" tIns="0" rIns="0" bIns="0" rtlCol="0" anchor="ctr"/>
-          <a:lstStyle/>
-          <a:p>
-            <a:pPr indent="0" marL="0">
-              <a:buNone/>
-            </a:pPr>
-            <a:r>
-              <a:rPr lang="en-US" sz="900" dirty="0">
-                <a:solidFill>
-                  <a:srgbClr val="64748B"/>
+          <a:p>
+            <a:pPr marL="342900" indent="-342900">
+              <a:spcAft>
+                <a:spcPts val="600"/>
+              </a:spcAft>
+              <a:buSzPct val="100000"/>
+              <a:buChar char="•"/>
+            </a:pPr>
+            <a:r>
+              <a:rPr lang="en-US" sz="1400" dirty="0">
+                <a:solidFill>
+                  <a:srgbClr val="1F2937"/>
                 </a:solidFill>
                 <a:latin typeface="Calibri" pitchFamily="34" charset="0"/>
                 <a:ea typeface="Calibri" pitchFamily="34" charset="-122"/>
                 <a:cs typeface="Calibri" pitchFamily="34" charset="-120"/>
               </a:rPr>
+              <a:t>Address technical debt early — cheaper than re-work later</a:t>
+            </a:r>
+            <a:endParaRPr lang="en-US" sz="1400" dirty="0"/>
+          </a:p>
+        </p:txBody>
+      </p:sp>
+      <p:sp>
+        <p:nvSpPr>
+          <p:cNvPr id="7" name="Text 4"/>
+          <p:cNvSpPr/>
+          <p:nvPr/>
+        </p:nvSpPr>
+        <p:spPr>
+          <a:xfrm>
+            <a:off x="457200" y="4800600"/>
+            <a:ext cx="6949440" cy="274320"/>
+          </a:xfrm>
+          <a:prstGeom prst="rect">
+            <a:avLst/>
+          </a:prstGeom>
+          <a:noFill/>
+          <a:ln/>
+        </p:spPr>
+        <p:txBody>
+          <a:bodyPr wrap="square" lIns="0" tIns="0" rIns="0" bIns="0" rtlCol="0" anchor="ctr"/>
+          <a:lstStyle/>
+          <a:p>
+            <a:pPr indent="0" marL="0">
+              <a:buNone/>
+            </a:pPr>
+            <a:r>
+              <a:rPr lang="en-US" sz="900" dirty="0">
+                <a:solidFill>
+                  <a:srgbClr val="64748B"/>
+                </a:solidFill>
+                <a:latin typeface="Calibri" pitchFamily="34" charset="0"/>
+                <a:ea typeface="Calibri" pitchFamily="34" charset="-122"/>
+                <a:cs typeface="Calibri" pitchFamily="34" charset="-120"/>
+              </a:rPr>
               <a:t>Software Security · Week 2</a:t>
             </a:r>
             <a:endParaRPr lang="en-US" sz="900" dirty="0"/>
@@ -4107,7 +4023,7 @@
       </p:sp>
       <p:pic>
         <p:nvPicPr>
-          <p:cNvPr id="10" name="Image 1" descr="/Users/pop7/Library/CloudStorage/OneDrive-MonsterConnectCo.,Ltd/Lecture/KOSEN69 - software-security/slides/pptx/assets/logo-small.png">    </p:cNvPr>
+          <p:cNvPr id="8" name="Image 1" descr="/Users/pop7/Library/CloudStorage/OneDrive-MonsterConnectCo.,Ltd/Lecture/KOSEN69 - software-security/slides/pptx/assets/logo-small.png">    </p:cNvPr>
           <p:cNvPicPr>
             <a:picLocks noChangeAspect="1"/>
           </p:cNvPicPr>
@@ -4245,7 +4161,7 @@
                 <a:ea typeface="Arial" pitchFamily="34" charset="-122"/>
                 <a:cs typeface="Arial" pitchFamily="34" charset="-120"/>
               </a:rPr>
-              <a:t>🐝 Mini-game — Fuzzing Race</a:t>
+              <a:t>🏁 Game — Bug Triage Race</a:t>
             </a:r>
             <a:endParaRPr lang="en-US" sz="2600" dirty="0"/>
           </a:p>
@@ -4260,11 +4176,11 @@
         <p:spPr>
           <a:xfrm>
             <a:off x="457200" y="1325880"/>
-            <a:ext cx="8229600" cy="1207008"/>
+            <a:ext cx="8229600" cy="896112"/>
           </a:xfrm>
           <a:prstGeom prst="roundRect">
             <a:avLst>
-              <a:gd name="adj" fmla="val 6061"/>
+              <a:gd name="adj" fmla="val 8163"/>
             </a:avLst>
           </a:prstGeom>
           <a:solidFill>
@@ -4289,7 +4205,7 @@
         <p:spPr>
           <a:xfrm>
             <a:off x="731520" y="1435608"/>
-            <a:ext cx="7680960" cy="987552"/>
+            <a:ext cx="7680960" cy="676656"/>
           </a:xfrm>
           <a:prstGeom prst="rect">
             <a:avLst/>
@@ -4319,7 +4235,7 @@
                 <a:ea typeface="Calibri" pitchFamily="34" charset="-122"/>
                 <a:cs typeface="Calibri" pitchFamily="34" charset="-120"/>
               </a:rPr>
-              <a:t>First team to make the provided target crash wins</a:t>
+              <a:t>Run Semgrep + Gitleaks on the flawed repo</a:t>
             </a:r>
             <a:endParaRPr lang="en-US" sz="1400" dirty="0"/>
           </a:p>
@@ -4340,66 +4256,164 @@
                 <a:ea typeface="Calibri" pitchFamily="34" charset="-122"/>
                 <a:cs typeface="Calibri" pitchFamily="34" charset="-120"/>
               </a:rPr>
-              <a:t>One crash → one root-cause note</a:t>
+              <a:t>Score = true positives − misclassified · live scoreboard</a:t>
             </a:r>
             <a:endParaRPr lang="en-US" sz="1400" dirty="0"/>
           </a:p>
-          <a:p>
-            <a:pPr marL="342900" indent="-342900">
-              <a:spcAft>
-                <a:spcPts val="600"/>
-              </a:spcAft>
-              <a:buSzPct val="100000"/>
-              <a:buChar char="•"/>
-            </a:pPr>
-            <a:r>
-              <a:rPr lang="en-US" sz="1400" dirty="0">
-                <a:solidFill>
-                  <a:srgbClr val="1F2937"/>
+        </p:txBody>
+      </p:sp>
+      <p:sp>
+        <p:nvSpPr>
+          <p:cNvPr id="7" name="Shape 4"/>
+          <p:cNvSpPr/>
+          <p:nvPr/>
+        </p:nvSpPr>
+        <p:spPr>
+          <a:xfrm>
+            <a:off x="457200" y="2386584"/>
+            <a:ext cx="8229600" cy="1152144"/>
+          </a:xfrm>
+          <a:prstGeom prst="roundRect">
+            <a:avLst>
+              <a:gd name="adj" fmla="val 4762"/>
+            </a:avLst>
+          </a:prstGeom>
+          <a:solidFill>
+            <a:srgbClr val="0A1020"/>
+          </a:solidFill>
+          <a:ln w="12700">
+            <a:solidFill>
+              <a:srgbClr val="E8EDF3"/>
+            </a:solidFill>
+            <a:prstDash val="solid"/>
+          </a:ln>
+        </p:spPr>
+      </p:sp>
+      <p:sp>
+        <p:nvSpPr>
+          <p:cNvPr id="8" name="Text 5"/>
+          <p:cNvSpPr/>
+          <p:nvPr/>
+        </p:nvSpPr>
+        <p:spPr>
+          <a:xfrm>
+            <a:off x="640080" y="2459736"/>
+            <a:ext cx="7863840" cy="1005840"/>
+          </a:xfrm>
+          <a:prstGeom prst="rect">
+            <a:avLst/>
+          </a:prstGeom>
+          <a:noFill/>
+          <a:ln/>
+        </p:spPr>
+        <p:txBody>
+          <a:bodyPr wrap="square" lIns="0" tIns="0" rIns="0" bIns="0" rtlCol="0" anchor="t">
+            <a:normAutofit/>
+          </a:bodyPr>
+          <a:lstStyle/>
+          <a:p>
+            <a:pPr indent="0" marL="0">
+              <a:buNone/>
+            </a:pPr>
+            <a:r>
+              <a:rPr lang="en-US" sz="1150" dirty="0">
+                <a:solidFill>
+                  <a:srgbClr val="9FE7D6"/>
+                </a:solidFill>
+                <a:latin typeface="Courier New" pitchFamily="34" charset="0"/>
+                <a:ea typeface="Courier New" pitchFamily="34" charset="-122"/>
+                <a:cs typeface="Courier New" pitchFamily="34" charset="-120"/>
+              </a:rPr>
+              <a:t>docker run --rm -v "$PWD/vulnerable-repo:/src" semgrep/semgrep \</a:t>
+            </a:r>
+            <a:endParaRPr lang="en-US" sz="1150" dirty="0"/>
+          </a:p>
+          <a:p>
+            <a:pPr indent="0" marL="0">
+              <a:buNone/>
+            </a:pPr>
+            <a:r>
+              <a:rPr lang="en-US" sz="1150" dirty="0">
+                <a:solidFill>
+                  <a:srgbClr val="9FE7D6"/>
+                </a:solidFill>
+                <a:latin typeface="Courier New" pitchFamily="34" charset="0"/>
+                <a:ea typeface="Courier New" pitchFamily="34" charset="-122"/>
+                <a:cs typeface="Courier New" pitchFamily="34" charset="-120"/>
+              </a:rPr>
+              <a:t>  semgrep --config p/default --config p/owasp-top-ten /src</a:t>
+            </a:r>
+            <a:endParaRPr lang="en-US" sz="1150" dirty="0"/>
+          </a:p>
+          <a:p>
+            <a:pPr indent="0" marL="0">
+              <a:buNone/>
+            </a:pPr>
+            <a:r>
+              <a:rPr lang="en-US" sz="1150" dirty="0">
+                <a:solidFill>
+                  <a:srgbClr val="9FE7D6"/>
+                </a:solidFill>
+                <a:latin typeface="Courier New" pitchFamily="34" charset="0"/>
+                <a:ea typeface="Courier New" pitchFamily="34" charset="-122"/>
+                <a:cs typeface="Courier New" pitchFamily="34" charset="-120"/>
+              </a:rPr>
+              <a:t>docker run --rm -v "$PWD/vulnerable-repo:/repo" zricethezav/gitleaks:latest \</a:t>
+            </a:r>
+            <a:endParaRPr lang="en-US" sz="1150" dirty="0"/>
+          </a:p>
+          <a:p>
+            <a:pPr indent="0" marL="0">
+              <a:buNone/>
+            </a:pPr>
+            <a:r>
+              <a:rPr lang="en-US" sz="1150" dirty="0">
+                <a:solidFill>
+                  <a:srgbClr val="9FE7D6"/>
+                </a:solidFill>
+                <a:latin typeface="Courier New" pitchFamily="34" charset="0"/>
+                <a:ea typeface="Courier New" pitchFamily="34" charset="-122"/>
+                <a:cs typeface="Courier New" pitchFamily="34" charset="-120"/>
+              </a:rPr>
+              <a:t>  detect -s /repo -v --no-git</a:t>
+            </a:r>
+            <a:endParaRPr lang="en-US" sz="1150" dirty="0"/>
+          </a:p>
+        </p:txBody>
+      </p:sp>
+      <p:sp>
+        <p:nvSpPr>
+          <p:cNvPr id="9" name="Text 6"/>
+          <p:cNvSpPr/>
+          <p:nvPr/>
+        </p:nvSpPr>
+        <p:spPr>
+          <a:xfrm>
+            <a:off x="457200" y="4800600"/>
+            <a:ext cx="6949440" cy="274320"/>
+          </a:xfrm>
+          <a:prstGeom prst="rect">
+            <a:avLst/>
+          </a:prstGeom>
+          <a:noFill/>
+          <a:ln/>
+        </p:spPr>
+        <p:txBody>
+          <a:bodyPr wrap="square" lIns="0" tIns="0" rIns="0" bIns="0" rtlCol="0" anchor="ctr"/>
+          <a:lstStyle/>
+          <a:p>
+            <a:pPr indent="0" marL="0">
+              <a:buNone/>
+            </a:pPr>
+            <a:r>
+              <a:rPr lang="en-US" sz="900" dirty="0">
+                <a:solidFill>
+                  <a:srgbClr val="64748B"/>
                 </a:solidFill>
                 <a:latin typeface="Calibri" pitchFamily="34" charset="0"/>
                 <a:ea typeface="Calibri" pitchFamily="34" charset="-122"/>
                 <a:cs typeface="Calibri" pitchFamily="34" charset="-120"/>
               </a:rPr>
-              <a:t>Full fuzz→exploit lab returns in Week 11</a:t>
-            </a:r>
-            <a:endParaRPr lang="en-US" sz="1400" dirty="0"/>
-          </a:p>
-        </p:txBody>
-      </p:sp>
-      <p:sp>
-        <p:nvSpPr>
-          <p:cNvPr id="7" name="Text 4"/>
-          <p:cNvSpPr/>
-          <p:nvPr/>
-        </p:nvSpPr>
-        <p:spPr>
-          <a:xfrm>
-            <a:off x="457200" y="4800600"/>
-            <a:ext cx="6949440" cy="274320"/>
-          </a:xfrm>
-          <a:prstGeom prst="rect">
-            <a:avLst/>
-          </a:prstGeom>
-          <a:noFill/>
-          <a:ln/>
-        </p:spPr>
-        <p:txBody>
-          <a:bodyPr wrap="square" lIns="0" tIns="0" rIns="0" bIns="0" rtlCol="0" anchor="ctr"/>
-          <a:lstStyle/>
-          <a:p>
-            <a:pPr indent="0" marL="0">
-              <a:buNone/>
-            </a:pPr>
-            <a:r>
-              <a:rPr lang="en-US" sz="900" dirty="0">
-                <a:solidFill>
-                  <a:srgbClr val="64748B"/>
-                </a:solidFill>
-                <a:latin typeface="Calibri" pitchFamily="34" charset="0"/>
-                <a:ea typeface="Calibri" pitchFamily="34" charset="-122"/>
-                <a:cs typeface="Calibri" pitchFamily="34" charset="-120"/>
-              </a:rPr>
               <a:t>Software Security · Week 2</a:t>
             </a:r>
             <a:endParaRPr lang="en-US" sz="900" dirty="0"/>
@@ -4408,7 +4422,7 @@
       </p:sp>
       <p:pic>
         <p:nvPicPr>
-          <p:cNvPr id="8" name="Image 1" descr="/Users/pop7/Library/CloudStorage/OneDrive-MonsterConnectCo.,Ltd/Lecture/KOSEN69 - software-security/slides/pptx/assets/logo-small.png">    </p:cNvPr>
+          <p:cNvPr id="10" name="Image 1" descr="/Users/pop7/Library/CloudStorage/OneDrive-MonsterConnectCo.,Ltd/Lecture/KOSEN69 - software-security/slides/pptx/assets/logo-small.png">    </p:cNvPr>
           <p:cNvPicPr>
             <a:picLocks noChangeAspect="1"/>
           </p:cNvPicPr>
@@ -4546,7 +4560,7 @@
                 <a:ea typeface="Arial" pitchFamily="34" charset="-122"/>
                 <a:cs typeface="Arial" pitchFamily="34" charset="-120"/>
               </a:rPr>
-              <a:t>Lab 2 — deliverable</a:t>
+              <a:t>🐝 Mini-game — Fuzzing Race</a:t>
             </a:r>
             <a:endParaRPr lang="en-US" sz="2600" dirty="0"/>
           </a:p>
@@ -4561,74 +4575,11 @@
         <p:spPr>
           <a:xfrm>
             <a:off x="457200" y="1325880"/>
-            <a:ext cx="8229600" cy="822960"/>
+            <a:ext cx="8229600" cy="1207008"/>
           </a:xfrm>
           <a:prstGeom prst="roundRect">
             <a:avLst>
-              <a:gd name="adj" fmla="val 8889"/>
-            </a:avLst>
-          </a:prstGeom>
-          <a:solidFill>
-            <a:srgbClr val="E8EDF3"/>
-          </a:solidFill>
-          <a:ln/>
-        </p:spPr>
-      </p:sp>
-      <p:sp>
-        <p:nvSpPr>
-          <p:cNvPr id="6" name="Text 3"/>
-          <p:cNvSpPr/>
-          <p:nvPr/>
-        </p:nvSpPr>
-        <p:spPr>
-          <a:xfrm>
-            <a:off x="731520" y="1325880"/>
-            <a:ext cx="7680960" cy="822960"/>
-          </a:xfrm>
-          <a:prstGeom prst="rect">
-            <a:avLst/>
-          </a:prstGeom>
-          <a:noFill/>
-          <a:ln/>
-        </p:spPr>
-        <p:txBody>
-          <a:bodyPr wrap="square" lIns="0" tIns="0" rIns="0" bIns="0" rtlCol="0" anchor="ctr">
-            <a:normAutofit/>
-          </a:bodyPr>
-          <a:lstStyle/>
-          <a:p>
-            <a:pPr indent="0" marL="0">
-              <a:buNone/>
-            </a:pPr>
-            <a:r>
-              <a:rPr lang="en-US" sz="1400" i="1" dirty="0">
-                <a:solidFill>
-                  <a:srgbClr val="E35205"/>
-                </a:solidFill>
-                <a:latin typeface="Calibri" pitchFamily="34" charset="0"/>
-                <a:ea typeface="Calibri" pitchFamily="34" charset="-122"/>
-                <a:cs typeface="Calibri" pitchFamily="34" charset="-120"/>
-              </a:rPr>
-              <a:t>📋 Worksheet 2 — labs/week02-sdlc-tooling/worksheet.md (Part 3) · kickoff: bash scan.sh (Semgrep ×2 rulesets + Gitleaks --no-git on ./vulnerable-repo)</a:t>
-            </a:r>
-            <a:endParaRPr lang="en-US" sz="1400" dirty="0"/>
-          </a:p>
-        </p:txBody>
-      </p:sp>
-      <p:sp>
-        <p:nvSpPr>
-          <p:cNvPr id="7" name="Shape 4"/>
-          <p:cNvSpPr/>
-          <p:nvPr/>
-        </p:nvSpPr>
-        <p:spPr>
-          <a:xfrm>
-            <a:off x="457200" y="2313432"/>
-            <a:ext cx="8229600" cy="2029968"/>
-          </a:xfrm>
-          <a:prstGeom prst="roundRect">
-            <a:avLst>
-              <a:gd name="adj" fmla="val 3604"/>
+              <a:gd name="adj" fmla="val 6061"/>
             </a:avLst>
           </a:prstGeom>
           <a:solidFill>
@@ -4646,14 +4597,14 @@
       </p:sp>
       <p:sp>
         <p:nvSpPr>
-          <p:cNvPr id="8" name="Text 5"/>
-          <p:cNvSpPr/>
-          <p:nvPr/>
-        </p:nvSpPr>
-        <p:spPr>
-          <a:xfrm>
-            <a:off x="731520" y="2423160"/>
-            <a:ext cx="7680960" cy="1810512"/>
+          <p:cNvPr id="6" name="Text 3"/>
+          <p:cNvSpPr/>
+          <p:nvPr/>
+        </p:nvSpPr>
+        <p:spPr>
+          <a:xfrm>
+            <a:off x="731520" y="1435608"/>
+            <a:ext cx="7680960" cy="987552"/>
           </a:xfrm>
           <a:prstGeom prst="rect">
             <a:avLst/>
@@ -4683,7 +4634,7 @@
                 <a:ea typeface="Calibri" pitchFamily="34" charset="-122"/>
                 <a:cs typeface="Calibri" pitchFamily="34" charset="-120"/>
               </a:rPr>
-              <a:t>A findings triage table: tool, CWE, severity, TP/FP, fix idea (3 TP + 1 FP, justified)</a:t>
+              <a:t>First team to make the provided target crash wins</a:t>
             </a:r>
             <a:endParaRPr lang="en-US" sz="1400" dirty="0"/>
           </a:p>
@@ -4704,7 +4655,7 @@
                 <a:ea typeface="Calibri" pitchFamily="34" charset="-122"/>
                 <a:cs typeface="Calibri" pitchFamily="34" charset="-120"/>
               </a:rPr>
-              <a:t>1 fuzzing crash with a one-line root cause</a:t>
+              <a:t>One crash → one root-cause note</a:t>
             </a:r>
             <a:endParaRPr lang="en-US" sz="1400" dirty="0"/>
           </a:p>
@@ -4725,87 +4676,45 @@
                 <a:ea typeface="Calibri" pitchFamily="34" charset="-122"/>
                 <a:cs typeface="Calibri" pitchFamily="34" charset="-120"/>
               </a:rPr>
-              <a:t>Trivy SCA scan of the NoteVault project target</a:t>
+              <a:t>Full fuzz→exploit lab returns in Week 11</a:t>
             </a:r>
             <a:endParaRPr lang="en-US" sz="1400" dirty="0"/>
           </a:p>
-          <a:p>
-            <a:pPr marL="342900" indent="-342900">
-              <a:spcAft>
-                <a:spcPts val="600"/>
-              </a:spcAft>
-              <a:buSzPct val="100000"/>
-              <a:buChar char="•"/>
-            </a:pPr>
-            <a:r>
-              <a:rPr lang="en-US" sz="1400" dirty="0">
-                <a:solidFill>
-                  <a:srgbClr val="1F2937"/>
+        </p:txBody>
+      </p:sp>
+      <p:sp>
+        <p:nvSpPr>
+          <p:cNvPr id="7" name="Text 4"/>
+          <p:cNvSpPr/>
+          <p:nvPr/>
+        </p:nvSpPr>
+        <p:spPr>
+          <a:xfrm>
+            <a:off x="457200" y="4800600"/>
+            <a:ext cx="6949440" cy="274320"/>
+          </a:xfrm>
+          <a:prstGeom prst="rect">
+            <a:avLst/>
+          </a:prstGeom>
+          <a:noFill/>
+          <a:ln/>
+        </p:spPr>
+        <p:txBody>
+          <a:bodyPr wrap="square" lIns="0" tIns="0" rIns="0" bIns="0" rtlCol="0" anchor="ctr"/>
+          <a:lstStyle/>
+          <a:p>
+            <a:pPr indent="0" marL="0">
+              <a:buNone/>
+            </a:pPr>
+            <a:r>
+              <a:rPr lang="en-US" sz="900" dirty="0">
+                <a:solidFill>
+                  <a:srgbClr val="64748B"/>
                 </a:solidFill>
                 <a:latin typeface="Calibri" pitchFamily="34" charset="0"/>
                 <a:ea typeface="Calibri" pitchFamily="34" charset="-122"/>
                 <a:cs typeface="Calibri" pitchFamily="34" charset="-120"/>
               </a:rPr>
-              <a:t>A security CI gate built from Week 15's security-ci.yml</a:t>
-            </a:r>
-            <a:endParaRPr lang="en-US" sz="1400" dirty="0"/>
-          </a:p>
-          <a:p>
-            <a:pPr marL="342900" indent="-342900">
-              <a:spcAft>
-                <a:spcPts val="600"/>
-              </a:spcAft>
-              <a:buSzPct val="100000"/>
-              <a:buChar char="•"/>
-            </a:pPr>
-            <a:r>
-              <a:rPr lang="en-US" sz="1400" dirty="0">
-                <a:solidFill>
-                  <a:srgbClr val="1F2937"/>
-                </a:solidFill>
-                <a:latin typeface="Calibri" pitchFamily="34" charset="0"/>
-                <a:ea typeface="Calibri" pitchFamily="34" charset="-122"/>
-                <a:cs typeface="Calibri" pitchFamily="34" charset="-120"/>
-              </a:rPr>
-              <a:t>One SAST blind spot you found by hand</a:t>
-            </a:r>
-            <a:endParaRPr lang="en-US" sz="1400" dirty="0"/>
-          </a:p>
-        </p:txBody>
-      </p:sp>
-      <p:sp>
-        <p:nvSpPr>
-          <p:cNvPr id="9" name="Text 6"/>
-          <p:cNvSpPr/>
-          <p:nvPr/>
-        </p:nvSpPr>
-        <p:spPr>
-          <a:xfrm>
-            <a:off x="457200" y="4800600"/>
-            <a:ext cx="6949440" cy="274320"/>
-          </a:xfrm>
-          <a:prstGeom prst="rect">
-            <a:avLst/>
-          </a:prstGeom>
-          <a:noFill/>
-          <a:ln/>
-        </p:spPr>
-        <p:txBody>
-          <a:bodyPr wrap="square" lIns="0" tIns="0" rIns="0" bIns="0" rtlCol="0" anchor="ctr"/>
-          <a:lstStyle/>
-          <a:p>
-            <a:pPr indent="0" marL="0">
-              <a:buNone/>
-            </a:pPr>
-            <a:r>
-              <a:rPr lang="en-US" sz="900" dirty="0">
-                <a:solidFill>
-                  <a:srgbClr val="64748B"/>
-                </a:solidFill>
-                <a:latin typeface="Calibri" pitchFamily="34" charset="0"/>
-                <a:ea typeface="Calibri" pitchFamily="34" charset="-122"/>
-                <a:cs typeface="Calibri" pitchFamily="34" charset="-120"/>
-              </a:rPr>
               <a:t>Software Security · Week 2</a:t>
             </a:r>
             <a:endParaRPr lang="en-US" sz="900" dirty="0"/>
@@ -4814,7 +4723,7 @@
       </p:sp>
       <p:pic>
         <p:nvPicPr>
-          <p:cNvPr id="10" name="Image 1" descr="/Users/pop7/Library/CloudStorage/OneDrive-MonsterConnectCo.,Ltd/Lecture/KOSEN69 - software-security/slides/pptx/assets/logo-small.png">    </p:cNvPr>
+          <p:cNvPr id="8" name="Image 1" descr="/Users/pop7/Library/CloudStorage/OneDrive-MonsterConnectCo.,Ltd/Lecture/KOSEN69 - software-security/slides/pptx/assets/logo-small.png">    </p:cNvPr>
           <p:cNvPicPr>
             <a:picLocks noChangeAspect="1"/>
           </p:cNvPicPr>
@@ -4952,7 +4861,7 @@
                 <a:ea typeface="Arial" pitchFamily="34" charset="-122"/>
                 <a:cs typeface="Arial" pitchFamily="34" charset="-120"/>
               </a:rPr>
-              <a:t>Lab 2 — deliverable (cont.)</a:t>
+              <a:t>Lab 2 — deliverable</a:t>
             </a:r>
             <a:endParaRPr lang="en-US" sz="2600" dirty="0"/>
           </a:p>
@@ -4967,11 +4876,74 @@
         <p:spPr>
           <a:xfrm>
             <a:off x="457200" y="1325880"/>
-            <a:ext cx="8229600" cy="1097280"/>
+            <a:ext cx="8229600" cy="822960"/>
           </a:xfrm>
           <a:prstGeom prst="roundRect">
             <a:avLst>
-              <a:gd name="adj" fmla="val 6667"/>
+              <a:gd name="adj" fmla="val 8889"/>
+            </a:avLst>
+          </a:prstGeom>
+          <a:solidFill>
+            <a:srgbClr val="E8EDF3"/>
+          </a:solidFill>
+          <a:ln/>
+        </p:spPr>
+      </p:sp>
+      <p:sp>
+        <p:nvSpPr>
+          <p:cNvPr id="6" name="Text 3"/>
+          <p:cNvSpPr/>
+          <p:nvPr/>
+        </p:nvSpPr>
+        <p:spPr>
+          <a:xfrm>
+            <a:off x="731520" y="1325880"/>
+            <a:ext cx="7680960" cy="822960"/>
+          </a:xfrm>
+          <a:prstGeom prst="rect">
+            <a:avLst/>
+          </a:prstGeom>
+          <a:noFill/>
+          <a:ln/>
+        </p:spPr>
+        <p:txBody>
+          <a:bodyPr wrap="square" lIns="0" tIns="0" rIns="0" bIns="0" rtlCol="0" anchor="ctr">
+            <a:normAutofit/>
+          </a:bodyPr>
+          <a:lstStyle/>
+          <a:p>
+            <a:pPr indent="0" marL="0">
+              <a:buNone/>
+            </a:pPr>
+            <a:r>
+              <a:rPr lang="en-US" sz="1400" i="1" dirty="0">
+                <a:solidFill>
+                  <a:srgbClr val="E35205"/>
+                </a:solidFill>
+                <a:latin typeface="Calibri" pitchFamily="34" charset="0"/>
+                <a:ea typeface="Calibri" pitchFamily="34" charset="-122"/>
+                <a:cs typeface="Calibri" pitchFamily="34" charset="-120"/>
+              </a:rPr>
+              <a:t>📋 Worksheet 2 — labs/week02-sdlc-tooling/worksheet.md (Part 3) · kickoff: bash scan.sh (Semgrep ×2 rulesets + Gitleaks --no-git on ./vulnerable-repo)</a:t>
+            </a:r>
+            <a:endParaRPr lang="en-US" sz="1400" dirty="0"/>
+          </a:p>
+        </p:txBody>
+      </p:sp>
+      <p:sp>
+        <p:nvSpPr>
+          <p:cNvPr id="7" name="Shape 4"/>
+          <p:cNvSpPr/>
+          <p:nvPr/>
+        </p:nvSpPr>
+        <p:spPr>
+          <a:xfrm>
+            <a:off x="457200" y="2313432"/>
+            <a:ext cx="8229600" cy="2029968"/>
+          </a:xfrm>
+          <a:prstGeom prst="roundRect">
+            <a:avLst>
+              <a:gd name="adj" fmla="val 3604"/>
             </a:avLst>
           </a:prstGeom>
           <a:solidFill>
@@ -4989,14 +4961,14 @@
       </p:sp>
       <p:sp>
         <p:nvSpPr>
-          <p:cNvPr id="6" name="Text 3"/>
-          <p:cNvSpPr/>
-          <p:nvPr/>
-        </p:nvSpPr>
-        <p:spPr>
-          <a:xfrm>
-            <a:off x="731520" y="1435608"/>
-            <a:ext cx="7680960" cy="877824"/>
+          <p:cNvPr id="8" name="Text 5"/>
+          <p:cNvSpPr/>
+          <p:nvPr/>
+        </p:nvSpPr>
+        <p:spPr>
+          <a:xfrm>
+            <a:off x="731520" y="2423160"/>
+            <a:ext cx="7680960" cy="1810512"/>
           </a:xfrm>
           <a:prstGeom prst="rect">
             <a:avLst/>
@@ -5026,7 +4998,7 @@
                 <a:ea typeface="Calibri" pitchFamily="34" charset="-122"/>
                 <a:cs typeface="Calibri" pitchFamily="34" charset="-120"/>
               </a:rPr>
-              <a:t>Defend/fix: remediate all 5 planted flaws, before/after diff — this alone is 25 of 100 rubric points</a:t>
+              <a:t>A findings triage table: tool, CWE, severity, TP/FP, fix idea (3 TP + 1 FP, justified)</a:t>
             </a:r>
             <a:endParaRPr lang="en-US" sz="1400" dirty="0"/>
           </a:p>
@@ -5047,45 +5019,108 @@
                 <a:ea typeface="Calibri" pitchFamily="34" charset="-122"/>
                 <a:cs typeface="Calibri" pitchFamily="34" charset="-120"/>
               </a:rPr>
-              <a:t>+ Audit the AI and EiPE / Prompt Problem (see worksheet)</a:t>
+              <a:t>1 fuzzing crash with a one-line root cause</a:t>
             </a:r>
             <a:endParaRPr lang="en-US" sz="1400" dirty="0"/>
           </a:p>
-        </p:txBody>
-      </p:sp>
-      <p:sp>
-        <p:nvSpPr>
-          <p:cNvPr id="7" name="Text 4"/>
-          <p:cNvSpPr/>
-          <p:nvPr/>
-        </p:nvSpPr>
-        <p:spPr>
-          <a:xfrm>
-            <a:off x="457200" y="4800600"/>
-            <a:ext cx="6949440" cy="274320"/>
-          </a:xfrm>
-          <a:prstGeom prst="rect">
-            <a:avLst/>
-          </a:prstGeom>
-          <a:noFill/>
-          <a:ln/>
-        </p:spPr>
-        <p:txBody>
-          <a:bodyPr wrap="square" lIns="0" tIns="0" rIns="0" bIns="0" rtlCol="0" anchor="ctr"/>
-          <a:lstStyle/>
-          <a:p>
-            <a:pPr indent="0" marL="0">
-              <a:buNone/>
-            </a:pPr>
-            <a:r>
-              <a:rPr lang="en-US" sz="900" dirty="0">
-                <a:solidFill>
-                  <a:srgbClr val="64748B"/>
+          <a:p>
+            <a:pPr marL="342900" indent="-342900">
+              <a:spcAft>
+                <a:spcPts val="600"/>
+              </a:spcAft>
+              <a:buSzPct val="100000"/>
+              <a:buChar char="•"/>
+            </a:pPr>
+            <a:r>
+              <a:rPr lang="en-US" sz="1400" dirty="0">
+                <a:solidFill>
+                  <a:srgbClr val="1F2937"/>
                 </a:solidFill>
                 <a:latin typeface="Calibri" pitchFamily="34" charset="0"/>
                 <a:ea typeface="Calibri" pitchFamily="34" charset="-122"/>
                 <a:cs typeface="Calibri" pitchFamily="34" charset="-120"/>
               </a:rPr>
+              <a:t>Trivy SCA scan of the NoteVault project target</a:t>
+            </a:r>
+            <a:endParaRPr lang="en-US" sz="1400" dirty="0"/>
+          </a:p>
+          <a:p>
+            <a:pPr marL="342900" indent="-342900">
+              <a:spcAft>
+                <a:spcPts val="600"/>
+              </a:spcAft>
+              <a:buSzPct val="100000"/>
+              <a:buChar char="•"/>
+            </a:pPr>
+            <a:r>
+              <a:rPr lang="en-US" sz="1400" dirty="0">
+                <a:solidFill>
+                  <a:srgbClr val="1F2937"/>
+                </a:solidFill>
+                <a:latin typeface="Calibri" pitchFamily="34" charset="0"/>
+                <a:ea typeface="Calibri" pitchFamily="34" charset="-122"/>
+                <a:cs typeface="Calibri" pitchFamily="34" charset="-120"/>
+              </a:rPr>
+              <a:t>A security CI gate built from Week 15's security-ci.yml</a:t>
+            </a:r>
+            <a:endParaRPr lang="en-US" sz="1400" dirty="0"/>
+          </a:p>
+          <a:p>
+            <a:pPr marL="342900" indent="-342900">
+              <a:spcAft>
+                <a:spcPts val="600"/>
+              </a:spcAft>
+              <a:buSzPct val="100000"/>
+              <a:buChar char="•"/>
+            </a:pPr>
+            <a:r>
+              <a:rPr lang="en-US" sz="1400" dirty="0">
+                <a:solidFill>
+                  <a:srgbClr val="1F2937"/>
+                </a:solidFill>
+                <a:latin typeface="Calibri" pitchFamily="34" charset="0"/>
+                <a:ea typeface="Calibri" pitchFamily="34" charset="-122"/>
+                <a:cs typeface="Calibri" pitchFamily="34" charset="-120"/>
+              </a:rPr>
+              <a:t>One SAST blind spot you found by hand</a:t>
+            </a:r>
+            <a:endParaRPr lang="en-US" sz="1400" dirty="0"/>
+          </a:p>
+        </p:txBody>
+      </p:sp>
+      <p:sp>
+        <p:nvSpPr>
+          <p:cNvPr id="9" name="Text 6"/>
+          <p:cNvSpPr/>
+          <p:nvPr/>
+        </p:nvSpPr>
+        <p:spPr>
+          <a:xfrm>
+            <a:off x="457200" y="4800600"/>
+            <a:ext cx="6949440" cy="274320"/>
+          </a:xfrm>
+          <a:prstGeom prst="rect">
+            <a:avLst/>
+          </a:prstGeom>
+          <a:noFill/>
+          <a:ln/>
+        </p:spPr>
+        <p:txBody>
+          <a:bodyPr wrap="square" lIns="0" tIns="0" rIns="0" bIns="0" rtlCol="0" anchor="ctr"/>
+          <a:lstStyle/>
+          <a:p>
+            <a:pPr indent="0" marL="0">
+              <a:buNone/>
+            </a:pPr>
+            <a:r>
+              <a:rPr lang="en-US" sz="900" dirty="0">
+                <a:solidFill>
+                  <a:srgbClr val="64748B"/>
+                </a:solidFill>
+                <a:latin typeface="Calibri" pitchFamily="34" charset="0"/>
+                <a:ea typeface="Calibri" pitchFamily="34" charset="-122"/>
+                <a:cs typeface="Calibri" pitchFamily="34" charset="-120"/>
+              </a:rPr>
               <a:t>Software Security · Week 2</a:t>
             </a:r>
             <a:endParaRPr lang="en-US" sz="900" dirty="0"/>
@@ -5094,7 +5129,7 @@
       </p:sp>
       <p:pic>
         <p:nvPicPr>
-          <p:cNvPr id="8" name="Image 1" descr="/Users/pop7/Library/CloudStorage/OneDrive-MonsterConnectCo.,Ltd/Lecture/KOSEN69 - software-security/slides/pptx/assets/logo-small.png">    </p:cNvPr>
+          <p:cNvPr id="10" name="Image 1" descr="/Users/pop7/Library/CloudStorage/OneDrive-MonsterConnectCo.,Ltd/Lecture/KOSEN69 - software-security/slides/pptx/assets/logo-small.png">    </p:cNvPr>
           <p:cNvPicPr>
             <a:picLocks noChangeAspect="1"/>
           </p:cNvPicPr>
@@ -5232,7 +5267,7 @@
                 <a:ea typeface="Arial" pitchFamily="34" charset="-122"/>
                 <a:cs typeface="Arial" pitchFamily="34" charset="-120"/>
               </a:rPr>
-              <a:t>Key takeaways</a:t>
+              <a:t>Lab 2 — deliverable (cont.)</a:t>
             </a:r>
             <a:endParaRPr lang="en-US" sz="2600" dirty="0"/>
           </a:p>
@@ -5247,11 +5282,11 @@
         <p:spPr>
           <a:xfrm>
             <a:off x="457200" y="1325880"/>
-            <a:ext cx="8229600" cy="1207008"/>
+            <a:ext cx="8229600" cy="1097280"/>
           </a:xfrm>
           <a:prstGeom prst="roundRect">
             <a:avLst>
-              <a:gd name="adj" fmla="val 6061"/>
+              <a:gd name="adj" fmla="val 6667"/>
             </a:avLst>
           </a:prstGeom>
           <a:solidFill>
@@ -5276,7 +5311,7 @@
         <p:spPr>
           <a:xfrm>
             <a:off x="731520" y="1435608"/>
-            <a:ext cx="7680960" cy="987552"/>
+            <a:ext cx="7680960" cy="877824"/>
           </a:xfrm>
           <a:prstGeom prst="rect">
             <a:avLst/>
@@ -5306,7 +5341,7 @@
                 <a:ea typeface="Calibri" pitchFamily="34" charset="-122"/>
                 <a:cs typeface="Calibri" pitchFamily="34" charset="-120"/>
               </a:rPr>
-              <a:t>No single tool finds everything — layer SAST/DAST/SCA/fuzzing</a:t>
+              <a:t>Defend/fix: remediate all 5 planted flaws, before/after diff — this alone is 25 of 100 rubric points</a:t>
             </a:r>
             <a:endParaRPr lang="en-US" sz="1400" dirty="0"/>
           </a:p>
@@ -5327,28 +5362,7 @@
                 <a:ea typeface="Calibri" pitchFamily="34" charset="-122"/>
                 <a:cs typeface="Calibri" pitchFamily="34" charset="-120"/>
               </a:rPr>
-              <a:t>Triage by CWE + severity; kill the noise</a:t>
-            </a:r>
-            <a:endParaRPr lang="en-US" sz="1400" dirty="0"/>
-          </a:p>
-          <a:p>
-            <a:pPr marL="342900" indent="-342900">
-              <a:spcAft>
-                <a:spcPts val="600"/>
-              </a:spcAft>
-              <a:buSzPct val="100000"/>
-              <a:buChar char="•"/>
-            </a:pPr>
-            <a:r>
-              <a:rPr lang="en-US" sz="1400" dirty="0">
-                <a:solidFill>
-                  <a:srgbClr val="1F2937"/>
-                </a:solidFill>
-                <a:latin typeface="Calibri" pitchFamily="34" charset="0"/>
-                <a:ea typeface="Calibri" pitchFamily="34" charset="-122"/>
-                <a:cs typeface="Calibri" pitchFamily="34" charset="-120"/>
-              </a:rPr>
-              <a:t>Fuzzing is the highest-yield bug finder — automate it</a:t>
+              <a:t>+ Audit the AI and EiPE / Prompt Problem (see worksheet)</a:t>
             </a:r>
             <a:endParaRPr lang="en-US" sz="1400" dirty="0"/>
           </a:p>
@@ -5451,14 +5465,65 @@
       </p:grpSpPr>
       <p:sp>
         <p:nvSpPr>
-          <p:cNvPr id="2" name="Text 0"/>
-          <p:cNvSpPr/>
-          <p:nvPr/>
-        </p:nvSpPr>
-        <p:spPr>
-          <a:xfrm>
-            <a:off x="640080" y="1737360"/>
-            <a:ext cx="7863840" cy="1097280"/>
+          <p:cNvPr id="2" name="Shape 0"/>
+          <p:cNvSpPr/>
+          <p:nvPr/>
+        </p:nvSpPr>
+        <p:spPr>
+          <a:xfrm>
+            <a:off x="457200" y="384048"/>
+            <a:ext cx="530352" cy="530352"/>
+          </a:xfrm>
+          <a:prstGeom prst="ellipse">
+            <a:avLst/>
+          </a:prstGeom>
+          <a:solidFill>
+            <a:srgbClr val="E35205"/>
+          </a:solidFill>
+          <a:ln/>
+          <a:effectLst>
+            <a:outerShdw sx="100000" sy="100000" kx="0" ky="0" algn="bl" rotWithShape="0" blurRad="76200" dist="25400" dir="5400000">
+              <a:srgbClr val="000000">
+                <a:alpha val="12000"/>
+              </a:srgbClr>
+            </a:outerShdw>
+          </a:effectLst>
+        </p:spPr>
+      </p:sp>
+      <p:pic>
+        <p:nvPicPr>
+          <p:cNvPr id="3" name="Image 0" descr="preencoded.png">    </p:cNvPr>
+          <p:cNvPicPr>
+            <a:picLocks noChangeAspect="1"/>
+          </p:cNvPicPr>
+          <p:nvPr/>
+        </p:nvPicPr>
+        <p:blipFill>
+          <a:blip r:embed="rId1"/>
+          <a:stretch>
+            <a:fillRect/>
+          </a:stretch>
+        </p:blipFill>
+        <p:spPr>
+          <a:xfrm>
+            <a:off x="594360" y="521208"/>
+            <a:ext cx="256032" cy="256032"/>
+          </a:xfrm>
+          <a:prstGeom prst="rect">
+            <a:avLst/>
+          </a:prstGeom>
+        </p:spPr>
+      </p:pic>
+      <p:sp>
+        <p:nvSpPr>
+          <p:cNvPr id="4" name="Text 1"/>
+          <p:cNvSpPr/>
+          <p:nvPr/>
+        </p:nvSpPr>
+        <p:spPr>
+          <a:xfrm>
+            <a:off x="1143000" y="329184"/>
+            <a:ext cx="7498080" cy="603504"/>
           </a:xfrm>
           <a:prstGeom prst="rect">
             <a:avLst/>
@@ -5474,7 +5539,7 @@
               <a:buNone/>
             </a:pPr>
             <a:r>
-              <a:rPr lang="en-US" sz="4600" b="1" dirty="0">
+              <a:rPr lang="en-US" sz="2600" b="1" dirty="0">
                 <a:solidFill>
                   <a:srgbClr val="1F2937"/>
                 </a:solidFill>
@@ -5482,22 +5547,51 @@
                 <a:ea typeface="Arial" pitchFamily="34" charset="-122"/>
                 <a:cs typeface="Arial" pitchFamily="34" charset="-120"/>
               </a:rPr>
-              <a:t>Questions?</a:t>
-            </a:r>
-            <a:endParaRPr lang="en-US" sz="4600" dirty="0"/>
-          </a:p>
-        </p:txBody>
-      </p:sp>
-      <p:sp>
-        <p:nvSpPr>
-          <p:cNvPr id="3" name="Text 1"/>
-          <p:cNvSpPr/>
-          <p:nvPr/>
-        </p:nvSpPr>
-        <p:spPr>
-          <a:xfrm>
-            <a:off x="658368" y="2834640"/>
-            <a:ext cx="7863840" cy="731520"/>
+              <a:t>Key takeaways</a:t>
+            </a:r>
+            <a:endParaRPr lang="en-US" sz="2600" dirty="0"/>
+          </a:p>
+        </p:txBody>
+      </p:sp>
+      <p:sp>
+        <p:nvSpPr>
+          <p:cNvPr id="5" name="Shape 2"/>
+          <p:cNvSpPr/>
+          <p:nvPr/>
+        </p:nvSpPr>
+        <p:spPr>
+          <a:xfrm>
+            <a:off x="457200" y="1325880"/>
+            <a:ext cx="8229600" cy="1207008"/>
+          </a:xfrm>
+          <a:prstGeom prst="roundRect">
+            <a:avLst>
+              <a:gd name="adj" fmla="val 6061"/>
+            </a:avLst>
+          </a:prstGeom>
+          <a:solidFill>
+            <a:srgbClr val="F1F5F9"/>
+          </a:solidFill>
+          <a:ln/>
+          <a:effectLst>
+            <a:outerShdw sx="100000" sy="100000" kx="0" ky="0" algn="bl" rotWithShape="0" blurRad="76200" dist="25400" dir="5400000">
+              <a:srgbClr val="000000">
+                <a:alpha val="12000"/>
+              </a:srgbClr>
+            </a:outerShdw>
+          </a:effectLst>
+        </p:spPr>
+      </p:sp>
+      <p:sp>
+        <p:nvSpPr>
+          <p:cNvPr id="6" name="Text 3"/>
+          <p:cNvSpPr/>
+          <p:nvPr/>
+        </p:nvSpPr>
+        <p:spPr>
+          <a:xfrm>
+            <a:off x="731520" y="1435608"/>
+            <a:ext cx="7680960" cy="987552"/>
           </a:xfrm>
           <a:prstGeom prst="rect">
             <a:avLst/>
@@ -5506,37 +5600,124 @@
           <a:ln/>
         </p:spPr>
         <p:txBody>
-          <a:bodyPr wrap="square" lIns="0" tIns="0" rIns="0" bIns="0" rtlCol="0" anchor="ctr"/>
-          <a:lstStyle/>
-          <a:p>
-            <a:pPr indent="0" marL="0">
-              <a:buNone/>
-            </a:pPr>
-            <a:r>
-              <a:rPr lang="en-US" sz="1800" dirty="0">
-                <a:solidFill>
-                  <a:srgbClr val="E35205"/>
+          <a:bodyPr wrap="square" lIns="0" tIns="0" rIns="0" bIns="0" rtlCol="0" anchor="t">
+            <a:normAutofit/>
+          </a:bodyPr>
+          <a:lstStyle/>
+          <a:p>
+            <a:pPr marL="342900" indent="-342900">
+              <a:spcAft>
+                <a:spcPts val="600"/>
+              </a:spcAft>
+              <a:buSzPct val="100000"/>
+              <a:buChar char="•"/>
+            </a:pPr>
+            <a:r>
+              <a:rPr lang="en-US" sz="1400" dirty="0">
+                <a:solidFill>
+                  <a:srgbClr val="1F2937"/>
                 </a:solidFill>
                 <a:latin typeface="Calibri" pitchFamily="34" charset="0"/>
                 <a:ea typeface="Calibri" pitchFamily="34" charset="-122"/>
                 <a:cs typeface="Calibri" pitchFamily="34" charset="-120"/>
               </a:rPr>
-              <a:t>Next week: Cryptography used correctly</a:t>
-            </a:r>
-            <a:endParaRPr lang="en-US" sz="1800" dirty="0"/>
+              <a:t>No single tool finds everything — layer SAST/DAST/SCA/fuzzing</a:t>
+            </a:r>
+            <a:endParaRPr lang="en-US" sz="1400" dirty="0"/>
+          </a:p>
+          <a:p>
+            <a:pPr marL="342900" indent="-342900">
+              <a:spcAft>
+                <a:spcPts val="600"/>
+              </a:spcAft>
+              <a:buSzPct val="100000"/>
+              <a:buChar char="•"/>
+            </a:pPr>
+            <a:r>
+              <a:rPr lang="en-US" sz="1400" dirty="0">
+                <a:solidFill>
+                  <a:srgbClr val="1F2937"/>
+                </a:solidFill>
+                <a:latin typeface="Calibri" pitchFamily="34" charset="0"/>
+                <a:ea typeface="Calibri" pitchFamily="34" charset="-122"/>
+                <a:cs typeface="Calibri" pitchFamily="34" charset="-120"/>
+              </a:rPr>
+              <a:t>Triage by CWE + severity; kill the noise</a:t>
+            </a:r>
+            <a:endParaRPr lang="en-US" sz="1400" dirty="0"/>
+          </a:p>
+          <a:p>
+            <a:pPr marL="342900" indent="-342900">
+              <a:spcAft>
+                <a:spcPts val="600"/>
+              </a:spcAft>
+              <a:buSzPct val="100000"/>
+              <a:buChar char="•"/>
+            </a:pPr>
+            <a:r>
+              <a:rPr lang="en-US" sz="1400" dirty="0">
+                <a:solidFill>
+                  <a:srgbClr val="1F2937"/>
+                </a:solidFill>
+                <a:latin typeface="Calibri" pitchFamily="34" charset="0"/>
+                <a:ea typeface="Calibri" pitchFamily="34" charset="-122"/>
+                <a:cs typeface="Calibri" pitchFamily="34" charset="-120"/>
+              </a:rPr>
+              <a:t>Fuzzing is the highest-yield bug finder — automate it</a:t>
+            </a:r>
+            <a:endParaRPr lang="en-US" sz="1400" dirty="0"/>
+          </a:p>
+        </p:txBody>
+      </p:sp>
+      <p:sp>
+        <p:nvSpPr>
+          <p:cNvPr id="7" name="Text 4"/>
+          <p:cNvSpPr/>
+          <p:nvPr/>
+        </p:nvSpPr>
+        <p:spPr>
+          <a:xfrm>
+            <a:off x="457200" y="4800600"/>
+            <a:ext cx="6949440" cy="274320"/>
+          </a:xfrm>
+          <a:prstGeom prst="rect">
+            <a:avLst/>
+          </a:prstGeom>
+          <a:noFill/>
+          <a:ln/>
+        </p:spPr>
+        <p:txBody>
+          <a:bodyPr wrap="square" lIns="0" tIns="0" rIns="0" bIns="0" rtlCol="0" anchor="ctr"/>
+          <a:lstStyle/>
+          <a:p>
+            <a:pPr indent="0" marL="0">
+              <a:buNone/>
+            </a:pPr>
+            <a:r>
+              <a:rPr lang="en-US" sz="900" dirty="0">
+                <a:solidFill>
+                  <a:srgbClr val="64748B"/>
+                </a:solidFill>
+                <a:latin typeface="Calibri" pitchFamily="34" charset="0"/>
+                <a:ea typeface="Calibri" pitchFamily="34" charset="-122"/>
+                <a:cs typeface="Calibri" pitchFamily="34" charset="-120"/>
+              </a:rPr>
+              <a:t>Software Security · Week 2</a:t>
+            </a:r>
+            <a:endParaRPr lang="en-US" sz="900" dirty="0"/>
           </a:p>
         </p:txBody>
       </p:sp>
       <p:pic>
         <p:nvPicPr>
-          <p:cNvPr id="4" name="Image 0" descr="/Users/pop7/Library/CloudStorage/OneDrive-MonsterConnectCo.,Ltd/Lecture/KOSEN69 - software-security/slides/pptx/assets/logo-small.png">    </p:cNvPr>
+          <p:cNvPr id="8" name="Image 1" descr="/Users/pop7/Library/CloudStorage/OneDrive-MonsterConnectCo.,Ltd/Lecture/KOSEN69 - software-security/slides/pptx/assets/logo-small.png">    </p:cNvPr>
           <p:cNvPicPr>
             <a:picLocks noChangeAspect="1"/>
           </p:cNvPicPr>
           <p:nvPr/>
         </p:nvPicPr>
         <p:blipFill>
-          <a:blip r:embed="rId1"/>
+          <a:blip r:embed="rId2"/>
           <a:stretch>
             <a:fillRect/>
           </a:stretch>
@@ -5859,6 +6040,140 @@
         </p:nvPicPr>
         <p:blipFill>
           <a:blip r:embed="rId2"/>
+          <a:stretch>
+            <a:fillRect/>
+          </a:stretch>
+        </p:blipFill>
+        <p:spPr>
+          <a:xfrm>
+            <a:off x="7882128" y="4700016"/>
+            <a:ext cx="768096" cy="356616"/>
+          </a:xfrm>
+          <a:prstGeom prst="rect">
+            <a:avLst/>
+          </a:prstGeom>
+        </p:spPr>
+      </p:pic>
+    </p:spTree>
+  </p:cSld>
+  <p:clrMapOvr>
+    <a:masterClrMapping/>
+  </p:clrMapOvr>
+</p:sld>
+</file>
+
+<file path=ppt/slides/slide20.xml><?xml version="1.0" encoding="utf-8"?>
+<p:sld xmlns:a="http://schemas.openxmlformats.org/drawingml/2006/main" xmlns:r="http://schemas.openxmlformats.org/officeDocument/2006/relationships" xmlns:p="http://schemas.openxmlformats.org/presentationml/2006/main">
+  <p:cSld name="Slide 20">
+    <p:bg>
+      <p:bgPr>
+        <a:solidFill>
+          <a:srgbClr val="FFFFFF"/>
+        </a:solidFill>
+      </p:bgPr>
+    </p:bg>
+    <p:spTree>
+      <p:nvGrpSpPr>
+        <p:cNvPr id="1" name=""/>
+        <p:cNvGrpSpPr/>
+        <p:nvPr/>
+      </p:nvGrpSpPr>
+      <p:grpSpPr>
+        <a:xfrm>
+          <a:off x="0" y="0"/>
+          <a:ext cx="0" cy="0"/>
+          <a:chOff x="0" y="0"/>
+          <a:chExt cx="0" cy="0"/>
+        </a:xfrm>
+      </p:grpSpPr>
+      <p:sp>
+        <p:nvSpPr>
+          <p:cNvPr id="2" name="Text 0"/>
+          <p:cNvSpPr/>
+          <p:nvPr/>
+        </p:nvSpPr>
+        <p:spPr>
+          <a:xfrm>
+            <a:off x="640080" y="1737360"/>
+            <a:ext cx="7863840" cy="1097280"/>
+          </a:xfrm>
+          <a:prstGeom prst="rect">
+            <a:avLst/>
+          </a:prstGeom>
+          <a:noFill/>
+          <a:ln/>
+        </p:spPr>
+        <p:txBody>
+          <a:bodyPr wrap="square" lIns="0" tIns="0" rIns="0" bIns="0" rtlCol="0" anchor="ctr"/>
+          <a:lstStyle/>
+          <a:p>
+            <a:pPr indent="0" marL="0">
+              <a:buNone/>
+            </a:pPr>
+            <a:r>
+              <a:rPr lang="en-US" sz="4600" b="1" dirty="0">
+                <a:solidFill>
+                  <a:srgbClr val="1F2937"/>
+                </a:solidFill>
+                <a:latin typeface="Arial" pitchFamily="34" charset="0"/>
+                <a:ea typeface="Arial" pitchFamily="34" charset="-122"/>
+                <a:cs typeface="Arial" pitchFamily="34" charset="-120"/>
+              </a:rPr>
+              <a:t>Questions?</a:t>
+            </a:r>
+            <a:endParaRPr lang="en-US" sz="4600" dirty="0"/>
+          </a:p>
+        </p:txBody>
+      </p:sp>
+      <p:sp>
+        <p:nvSpPr>
+          <p:cNvPr id="3" name="Text 1"/>
+          <p:cNvSpPr/>
+          <p:nvPr/>
+        </p:nvSpPr>
+        <p:spPr>
+          <a:xfrm>
+            <a:off x="658368" y="2834640"/>
+            <a:ext cx="7863840" cy="731520"/>
+          </a:xfrm>
+          <a:prstGeom prst="rect">
+            <a:avLst/>
+          </a:prstGeom>
+          <a:noFill/>
+          <a:ln/>
+        </p:spPr>
+        <p:txBody>
+          <a:bodyPr wrap="square" lIns="0" tIns="0" rIns="0" bIns="0" rtlCol="0" anchor="ctr"/>
+          <a:lstStyle/>
+          <a:p>
+            <a:pPr indent="0" marL="0">
+              <a:buNone/>
+            </a:pPr>
+            <a:r>
+              <a:rPr lang="en-US" sz="1800" dirty="0">
+                <a:solidFill>
+                  <a:srgbClr val="E35205"/>
+                </a:solidFill>
+                <a:latin typeface="Calibri" pitchFamily="34" charset="0"/>
+                <a:ea typeface="Calibri" pitchFamily="34" charset="-122"/>
+                <a:cs typeface="Calibri" pitchFamily="34" charset="-120"/>
+              </a:rPr>
+              <a:t>Next week: Cryptography used correctly</a:t>
+            </a:r>
+            <a:endParaRPr lang="en-US" sz="1800" dirty="0"/>
+          </a:p>
+        </p:txBody>
+      </p:sp>
+      <p:pic>
+        <p:nvPicPr>
+          <p:cNvPr id="4" name="Image 0" descr="/Users/pop7/Library/CloudStorage/OneDrive-MonsterConnectCo.,Ltd/Lecture/KOSEN69 - software-security/slides/pptx/assets/logo-small.png">    </p:cNvPr>
+          <p:cNvPicPr>
+            <a:picLocks noChangeAspect="1"/>
+          </p:cNvPicPr>
+          <p:nvPr/>
+        </p:nvPicPr>
+        <p:blipFill>
+          <a:blip r:embed="rId1"/>
           <a:stretch>
             <a:fillRect/>
           </a:stretch>

</xml_diff>